<commit_message>
vault backup: 2026-08-18 08:06:27
</commit_message>
<xml_diff>
--- a/PPT/入职以来AI工作复盘/入职以来AI工作复盘.pptx
+++ b/PPT/入职以来AI工作复盘/入职以来AI工作复盘.pptx
@@ -5,7 +5,7 @@
     <p:sldMasterId id="2147483648" r:id="rId1"/>
   </p:sldMasterIdLst>
   <p:notesMasterIdLst>
-    <p:notesMasterId r:id="rId16"/>
+    <p:notesMasterId r:id="rId15"/>
   </p:notesMasterIdLst>
   <p:sldIdLst>
     <p:sldId id="256" r:id="rId3"/>
@@ -16,11 +16,10 @@
     <p:sldId id="261" r:id="rId8"/>
     <p:sldId id="262" r:id="rId9"/>
     <p:sldId id="263" r:id="rId10"/>
-    <p:sldId id="264" r:id="rId11"/>
-    <p:sldId id="265" r:id="rId12"/>
-    <p:sldId id="266" r:id="rId13"/>
-    <p:sldId id="267" r:id="rId14"/>
-    <p:sldId id="268" r:id="rId15"/>
+    <p:sldId id="265" r:id="rId11"/>
+    <p:sldId id="266" r:id="rId12"/>
+    <p:sldId id="267" r:id="rId13"/>
+    <p:sldId id="268" r:id="rId14"/>
   </p:sldIdLst>
   <p:sldSz cx="12192000" cy="6858000"/>
   <p:notesSz cx="6858000" cy="12192000"/>
@@ -912,1723 +911,6 @@
   <p:cSld>
     <p:spTree>
       <p:nvGrpSpPr>
-        <p:cNvPr id="12" name="" descr="&lt;Slide style={{ width:'1280px', height:'720px', position:'relative', background:'#FFFFFF', fontFamily:'微软雅黑' }}&gt;&#10;  &lt;Box style={{ position:'absolute', left:56, top:36, flexDirection:'row', alignItems:'center', gap:12 }}&gt;&#10;    &lt;Box style={{ width:8, height:34, background:'#4472C4' }} /&gt;&#10;    &lt;Text style={{ fontSize:30, fontWeight:'bold', color:'#052B7C' }}&gt;五、宏昊AI助手 · 验收运营&lt;/Text&gt;&#10;  &lt;/Box&gt;&#10;&#10;  &lt;Box style={{ position:'absolute', left:56, top:130, right:56, flexDirection:'row', gap:22 }}&gt;&#10;    {[['37','平台验收项'],['19','问题反馈闭环'],['93.3%','6 月单月通过率']].map((c, i) =&gt; (&#10;      &lt;Box key={i} style={{ flex:1, background:'#F4F7FC', borderRadius:10, padding:'22px 18px', alignItems:'center' }}&gt;&#10;        &lt;Text style={{ fontSize:56, fontWeight:'bold', color:'#4472C4' }}&gt;{c[0]}&lt;/Text&gt;&#10;        &lt;Text style={{ fontSize:18, color:'#1A1A1A', marginTop:6 }}&gt;{c[1]}&lt;/Text&gt;&#10;      &lt;/Box&gt;&#10;    ))}&#10;  &lt;/Box&gt;&#10;&#10;  &lt;Box style={{ position:'absolute', left:56, top:300, right:56, background:'#052B7C', borderRadius:10, padding:'16px 22px' }}&gt;&#10;    &lt;Text style={{ fontSize:18, color:'#FFFFFF', lineHeight:1.5 }}&gt;入职以来 &lt;span style={{ fontWeight:'bold' }}&gt;37 项验收 + 19 项问题反馈闭环&lt;/span&gt;，6 月单月通过率 93.3% → 把「供应商交付」变「可度量、可追溯、有退回机制」的质量门槛。&lt;/Text&gt;&#10;  &lt;/Box&gt;&#10;&#10;  &lt;Box style={{ position:'absolute', left:56, top:400, right:56 }}&gt;&#10;    &lt;Table&#10;      style={{ width:'100%', height:230 }}&#10;      defaultTextStyle={{ fontSize:15, textAlign:'center', color:'#1A1A1A' }}&#10;      defaultCellStyle={{ border:{ left:{width:1,color:'#CCCCCC'}, right:{width:1,color:'#CCCCCC'}, top:{width:1,color:'#CCCCCC'}, bottom:{width:1,color:'#CCCCCC'} } }}&#10;      cells={[&#10;        [ {text:'周期', textStyle:{bold:true,color:'#1A1A1A'}, cellStyle:{background:{color:'#DAE3F3'}}},&#10;          {text:'验收产出', textStyle:{bold:true,color:'#1A1A1A'}, cellStyle:{background:{color:'#DAE3F3'}}},&#10;          {text:'问题反馈', textStyle:{bold:true,color:'#1A1A1A'}, cellStyle:{background:{color:'#DAE3F3'}}},&#10;          {text:'通过情况', textStyle:{bold:true,color:'#1A1A1A'}, cellStyle:{background:{color:'#DAE3F3'}}} ],&#10;        [ '4 月', '3 测试 + 2 验收（5 项）', '4', '—' ],&#10;        [ '5 月', '9 项测试验收', '3', '—' ],&#10;        [ '6 月', '15 用例（5 批次）', '8', {text:'14/15 通过（93.3%）', textStyle:{bold:true,color:'#4472C4'}} ],&#10;        [ '7 月（2607）', '5 轮验收（8 项）', '4', '—' ],&#10;      ]}&#10;    /&gt;&#10;  &lt;/Box&gt;&#10;&#10;  &lt;Box style={{ position:'absolute', left:56, top:668, right:56, flexDirection:'row', justifyContent:'space-between' }}&gt;&#10;    &lt;Text style={{ fontSize:14, color:'#888' }}&gt;入职以来 AI 工作复盘&lt;/Text&gt;&#10;    &lt;Text style={{ fontSize:14, color:'#888' }}&gt;10 / 13&lt;/Text&gt;&#10;  &lt;/Box&gt;&#10;&lt;/Slide&gt;"/>
-        <p:cNvGrpSpPr/>
-        <p:nvPr/>
-      </p:nvGrpSpPr>
-      <p:grpSpPr>
-        <a:xfrm>
-          <a:off x="0" y="0"/>
-          <a:ext cx="0" cy="0"/>
-          <a:chOff x="0" y="0"/>
-          <a:chExt cx="0" cy="0"/>
-        </a:xfrm>
-      </p:grpSpPr>
-      <p:sp>
-        <p:nvSpPr>
-          <p:cNvPr id="13" name="矩形 12"/>
-          <p:cNvSpPr/>
-          <p:nvPr/>
-        </p:nvSpPr>
-        <p:spPr>
-          <a:xfrm>
-            <a:off x="0" y="0"/>
-            <a:ext cx="12192000" cy="6858000"/>
-          </a:xfrm>
-          <a:prstGeom prst="rect">
-            <a:avLst/>
-          </a:prstGeom>
-          <a:solidFill>
-            <a:srgbClr val="FFFFFF"/>
-          </a:solidFill>
-        </p:spPr>
-        <p:txBody>
-          <a:bodyPr/>
-          <a:p/>
-        </p:txBody>
-      </p:sp>
-      <p:sp>
-        <p:nvSpPr>
-          <p:cNvPr id="14" name="矩形 13"/>
-          <p:cNvSpPr/>
-          <p:nvPr/>
-        </p:nvSpPr>
-        <p:spPr>
-          <a:xfrm>
-            <a:off x="533400" y="352425"/>
-            <a:ext cx="76200" cy="323850"/>
-          </a:xfrm>
-          <a:prstGeom prst="rect">
-            <a:avLst/>
-          </a:prstGeom>
-          <a:solidFill>
-            <a:srgbClr val="4472C4"/>
-          </a:solidFill>
-        </p:spPr>
-        <p:txBody>
-          <a:bodyPr/>
-          <a:p/>
-        </p:txBody>
-      </p:sp>
-      <p:sp>
-        <p:nvSpPr>
-          <p:cNvPr id="15" name="文本框 14" descr="{&quot;isTemplate&quot;:true,&quot;type&quot;:&quot;text&quot;}"/>
-          <p:cNvSpPr txBox="1"/>
-          <p:nvPr/>
-        </p:nvSpPr>
-        <p:spPr>
-          <a:xfrm>
-            <a:off x="723900" y="342900"/>
-            <a:ext cx="3467100" cy="342900"/>
-          </a:xfrm>
-          <a:prstGeom prst="rect">
-            <a:avLst/>
-          </a:prstGeom>
-        </p:spPr>
-        <p:txBody>
-          <a:bodyPr wrap="none" lIns="0" tIns="0" rIns="0" bIns="0"/>
-          <a:p>
-            <a:pPr>
-              <a:lnSpc>
-                <a:spcPct val="100000"/>
-              </a:lnSpc>
-            </a:pPr>
-            <a:r>
-              <a:rPr lang="zh-CN" sz="2250" b="1">
-                <a:solidFill>
-                  <a:srgbClr val="052B7C"/>
-                </a:solidFill>
-                <a:latin typeface="微软雅黑" panose="020B0503020204020204" charset="-122"/>
-                <a:ea typeface="微软雅黑" panose="020B0503020204020204" charset="-122"/>
-              </a:rPr>
-              <a:t>五、宏昊</a:t>
-            </a:r>
-            <a:r>
-              <a:rPr lang="en-US" sz="2250" b="1">
-                <a:solidFill>
-                  <a:srgbClr val="052B7C"/>
-                </a:solidFill>
-                <a:latin typeface="微软雅黑" panose="020B0503020204020204" charset="-122"/>
-                <a:ea typeface="微软雅黑" panose="020B0503020204020204" charset="-122"/>
-              </a:rPr>
-              <a:t>AI</a:t>
-            </a:r>
-            <a:r>
-              <a:rPr lang="zh-CN" sz="2250" b="1">
-                <a:solidFill>
-                  <a:srgbClr val="052B7C"/>
-                </a:solidFill>
-                <a:latin typeface="微软雅黑" panose="020B0503020204020204" charset="-122"/>
-                <a:ea typeface="微软雅黑" panose="020B0503020204020204" charset="-122"/>
-              </a:rPr>
-              <a:t>助手</a:t>
-            </a:r>
-            <a:r>
-              <a:rPr lang="en-US" sz="2250" b="1">
-                <a:solidFill>
-                  <a:srgbClr val="052B7C"/>
-                </a:solidFill>
-                <a:latin typeface="微软雅黑" panose="020B0503020204020204" charset="-122"/>
-                <a:ea typeface="微软雅黑" panose="020B0503020204020204" charset="-122"/>
-              </a:rPr>
-              <a:t> · </a:t>
-            </a:r>
-            <a:r>
-              <a:rPr lang="zh-CN" sz="2250" b="1">
-                <a:solidFill>
-                  <a:srgbClr val="052B7C"/>
-                </a:solidFill>
-                <a:latin typeface="微软雅黑" panose="020B0503020204020204" charset="-122"/>
-                <a:ea typeface="微软雅黑" panose="020B0503020204020204" charset="-122"/>
-              </a:rPr>
-              <a:t>验收运营</a:t>
-            </a:r>
-            <a:endParaRPr lang="zh-CN" sz="2250" b="1">
-              <a:solidFill>
-                <a:srgbClr val="052B7C"/>
-              </a:solidFill>
-              <a:latin typeface="微软雅黑" panose="020B0503020204020204" charset="-122"/>
-              <a:ea typeface="微软雅黑" panose="020B0503020204020204" charset="-122"/>
-            </a:endParaRPr>
-          </a:p>
-        </p:txBody>
-      </p:sp>
-      <p:sp>
-        <p:nvSpPr>
-          <p:cNvPr id="16" name="圆角矩形 15"/>
-          <p:cNvSpPr/>
-          <p:nvPr/>
-        </p:nvSpPr>
-        <p:spPr>
-          <a:xfrm>
-            <a:off x="533400" y="1238250"/>
-            <a:ext cx="3571875" cy="1333500"/>
-          </a:xfrm>
-          <a:prstGeom prst="roundRect">
-            <a:avLst>
-              <a:gd name="adj" fmla="val 7143"/>
-            </a:avLst>
-          </a:prstGeom>
-          <a:solidFill>
-            <a:srgbClr val="F4F7FC"/>
-          </a:solidFill>
-        </p:spPr>
-        <p:txBody>
-          <a:bodyPr/>
-          <a:p/>
-        </p:txBody>
-      </p:sp>
-      <p:sp>
-        <p:nvSpPr>
-          <p:cNvPr id="17" name="文本框 16" descr="{&quot;isTemplate&quot;:true,&quot;type&quot;:&quot;text&quot;}"/>
-          <p:cNvSpPr txBox="1"/>
-          <p:nvPr/>
-        </p:nvSpPr>
-        <p:spPr>
-          <a:xfrm>
-            <a:off x="1981200" y="1447800"/>
-            <a:ext cx="685800" cy="647700"/>
-          </a:xfrm>
-          <a:prstGeom prst="rect">
-            <a:avLst/>
-          </a:prstGeom>
-        </p:spPr>
-        <p:txBody>
-          <a:bodyPr wrap="none" lIns="0" tIns="0" rIns="0" bIns="0"/>
-          <a:p>
-            <a:pPr>
-              <a:lnSpc>
-                <a:spcPct val="100000"/>
-              </a:lnSpc>
-            </a:pPr>
-            <a:r>
-              <a:rPr lang="en-US" sz="4200" b="1">
-                <a:solidFill>
-                  <a:srgbClr val="4472C4"/>
-                </a:solidFill>
-                <a:latin typeface="微软雅黑" panose="020B0503020204020204" charset="-122"/>
-                <a:ea typeface="微软雅黑" panose="020B0503020204020204" charset="-122"/>
-              </a:rPr>
-              <a:t>37</a:t>
-            </a:r>
-            <a:endParaRPr lang="en-US" sz="4200" b="1">
-              <a:solidFill>
-                <a:srgbClr val="4472C4"/>
-              </a:solidFill>
-              <a:latin typeface="微软雅黑" panose="020B0503020204020204" charset="-122"/>
-              <a:ea typeface="微软雅黑" panose="020B0503020204020204" charset="-122"/>
-            </a:endParaRPr>
-          </a:p>
-        </p:txBody>
-      </p:sp>
-      <p:sp>
-        <p:nvSpPr>
-          <p:cNvPr id="18" name="文本框 17" descr="{&quot;isTemplate&quot;:true,&quot;type&quot;:&quot;text&quot;}"/>
-          <p:cNvSpPr txBox="1"/>
-          <p:nvPr/>
-        </p:nvSpPr>
-        <p:spPr>
-          <a:xfrm>
-            <a:off x="1895475" y="2152650"/>
-            <a:ext cx="857250" cy="209550"/>
-          </a:xfrm>
-          <a:prstGeom prst="rect">
-            <a:avLst/>
-          </a:prstGeom>
-        </p:spPr>
-        <p:txBody>
-          <a:bodyPr wrap="none" lIns="0" tIns="0" rIns="0" bIns="0"/>
-          <a:p>
-            <a:pPr>
-              <a:lnSpc>
-                <a:spcPct val="100000"/>
-              </a:lnSpc>
-            </a:pPr>
-            <a:r>
-              <a:rPr lang="zh-CN" sz="1350">
-                <a:solidFill>
-                  <a:srgbClr val="1A1A1A"/>
-                </a:solidFill>
-                <a:latin typeface="微软雅黑" panose="020B0503020204020204" charset="-122"/>
-                <a:ea typeface="微软雅黑" panose="020B0503020204020204" charset="-122"/>
-              </a:rPr>
-              <a:t>平台验收项</a:t>
-            </a:r>
-            <a:endParaRPr lang="zh-CN" sz="1350">
-              <a:solidFill>
-                <a:srgbClr val="1A1A1A"/>
-              </a:solidFill>
-              <a:latin typeface="微软雅黑" panose="020B0503020204020204" charset="-122"/>
-              <a:ea typeface="微软雅黑" panose="020B0503020204020204" charset="-122"/>
-            </a:endParaRPr>
-          </a:p>
-        </p:txBody>
-      </p:sp>
-      <p:sp>
-        <p:nvSpPr>
-          <p:cNvPr id="19" name="圆角矩形 18"/>
-          <p:cNvSpPr/>
-          <p:nvPr/>
-        </p:nvSpPr>
-        <p:spPr>
-          <a:xfrm>
-            <a:off x="4314825" y="1238250"/>
-            <a:ext cx="3562350" cy="1333500"/>
-          </a:xfrm>
-          <a:prstGeom prst="roundRect">
-            <a:avLst>
-              <a:gd name="adj" fmla="val 7143"/>
-            </a:avLst>
-          </a:prstGeom>
-          <a:solidFill>
-            <a:srgbClr val="F4F7FC"/>
-          </a:solidFill>
-        </p:spPr>
-        <p:txBody>
-          <a:bodyPr/>
-          <a:p/>
-        </p:txBody>
-      </p:sp>
-      <p:sp>
-        <p:nvSpPr>
-          <p:cNvPr id="20" name="文本框 19" descr="{&quot;isTemplate&quot;:true,&quot;type&quot;:&quot;text&quot;}"/>
-          <p:cNvSpPr txBox="1"/>
-          <p:nvPr/>
-        </p:nvSpPr>
-        <p:spPr>
-          <a:xfrm>
-            <a:off x="5753100" y="1447800"/>
-            <a:ext cx="685800" cy="647700"/>
-          </a:xfrm>
-          <a:prstGeom prst="rect">
-            <a:avLst/>
-          </a:prstGeom>
-        </p:spPr>
-        <p:txBody>
-          <a:bodyPr wrap="none" lIns="0" tIns="0" rIns="0" bIns="0"/>
-          <a:p>
-            <a:pPr>
-              <a:lnSpc>
-                <a:spcPct val="100000"/>
-              </a:lnSpc>
-            </a:pPr>
-            <a:r>
-              <a:rPr lang="en-US" sz="4200" b="1">
-                <a:solidFill>
-                  <a:srgbClr val="4472C4"/>
-                </a:solidFill>
-                <a:latin typeface="微软雅黑" panose="020B0503020204020204" charset="-122"/>
-                <a:ea typeface="微软雅黑" panose="020B0503020204020204" charset="-122"/>
-              </a:rPr>
-              <a:t>19</a:t>
-            </a:r>
-            <a:endParaRPr lang="en-US" sz="4200" b="1">
-              <a:solidFill>
-                <a:srgbClr val="4472C4"/>
-              </a:solidFill>
-              <a:latin typeface="微软雅黑" panose="020B0503020204020204" charset="-122"/>
-              <a:ea typeface="微软雅黑" panose="020B0503020204020204" charset="-122"/>
-            </a:endParaRPr>
-          </a:p>
-        </p:txBody>
-      </p:sp>
-      <p:sp>
-        <p:nvSpPr>
-          <p:cNvPr id="21" name="文本框 20" descr="{&quot;isTemplate&quot;:true,&quot;type&quot;:&quot;text&quot;}"/>
-          <p:cNvSpPr txBox="1"/>
-          <p:nvPr/>
-        </p:nvSpPr>
-        <p:spPr>
-          <a:xfrm>
-            <a:off x="5581650" y="2152650"/>
-            <a:ext cx="1028700" cy="209550"/>
-          </a:xfrm>
-          <a:prstGeom prst="rect">
-            <a:avLst/>
-          </a:prstGeom>
-        </p:spPr>
-        <p:txBody>
-          <a:bodyPr wrap="none" lIns="0" tIns="0" rIns="0" bIns="0"/>
-          <a:p>
-            <a:pPr>
-              <a:lnSpc>
-                <a:spcPct val="100000"/>
-              </a:lnSpc>
-            </a:pPr>
-            <a:r>
-              <a:rPr lang="zh-CN" sz="1350">
-                <a:solidFill>
-                  <a:srgbClr val="1A1A1A"/>
-                </a:solidFill>
-                <a:latin typeface="微软雅黑" panose="020B0503020204020204" charset="-122"/>
-                <a:ea typeface="微软雅黑" panose="020B0503020204020204" charset="-122"/>
-              </a:rPr>
-              <a:t>问题反馈闭环</a:t>
-            </a:r>
-            <a:endParaRPr lang="zh-CN" sz="1350">
-              <a:solidFill>
-                <a:srgbClr val="1A1A1A"/>
-              </a:solidFill>
-              <a:latin typeface="微软雅黑" panose="020B0503020204020204" charset="-122"/>
-              <a:ea typeface="微软雅黑" panose="020B0503020204020204" charset="-122"/>
-            </a:endParaRPr>
-          </a:p>
-        </p:txBody>
-      </p:sp>
-      <p:sp>
-        <p:nvSpPr>
-          <p:cNvPr id="22" name="圆角矩形 21"/>
-          <p:cNvSpPr/>
-          <p:nvPr/>
-        </p:nvSpPr>
-        <p:spPr>
-          <a:xfrm>
-            <a:off x="8086725" y="1238250"/>
-            <a:ext cx="3571875" cy="1333500"/>
-          </a:xfrm>
-          <a:prstGeom prst="roundRect">
-            <a:avLst>
-              <a:gd name="adj" fmla="val 7143"/>
-            </a:avLst>
-          </a:prstGeom>
-          <a:solidFill>
-            <a:srgbClr val="F4F7FC"/>
-          </a:solidFill>
-        </p:spPr>
-        <p:txBody>
-          <a:bodyPr/>
-          <a:p/>
-        </p:txBody>
-      </p:sp>
-      <p:sp>
-        <p:nvSpPr>
-          <p:cNvPr id="23" name="文本框 22" descr="{&quot;isTemplate&quot;:true,&quot;type&quot;:&quot;text&quot;}"/>
-          <p:cNvSpPr txBox="1"/>
-          <p:nvPr/>
-        </p:nvSpPr>
-        <p:spPr>
-          <a:xfrm>
-            <a:off x="8963025" y="1447800"/>
-            <a:ext cx="1828800" cy="647700"/>
-          </a:xfrm>
-          <a:prstGeom prst="rect">
-            <a:avLst/>
-          </a:prstGeom>
-        </p:spPr>
-        <p:txBody>
-          <a:bodyPr wrap="none" lIns="0" tIns="0" rIns="0" bIns="0"/>
-          <a:p>
-            <a:pPr>
-              <a:lnSpc>
-                <a:spcPct val="100000"/>
-              </a:lnSpc>
-            </a:pPr>
-            <a:r>
-              <a:rPr lang="en-US" sz="4200" b="1">
-                <a:solidFill>
-                  <a:srgbClr val="4472C4"/>
-                </a:solidFill>
-                <a:latin typeface="微软雅黑" panose="020B0503020204020204" charset="-122"/>
-                <a:ea typeface="微软雅黑" panose="020B0503020204020204" charset="-122"/>
-              </a:rPr>
-              <a:t>93.3%</a:t>
-            </a:r>
-            <a:endParaRPr lang="en-US" sz="4200" b="1">
-              <a:solidFill>
-                <a:srgbClr val="4472C4"/>
-              </a:solidFill>
-              <a:latin typeface="微软雅黑" panose="020B0503020204020204" charset="-122"/>
-              <a:ea typeface="微软雅黑" panose="020B0503020204020204" charset="-122"/>
-            </a:endParaRPr>
-          </a:p>
-        </p:txBody>
-      </p:sp>
-      <p:sp>
-        <p:nvSpPr>
-          <p:cNvPr id="24" name="文本框 23" descr="{&quot;isTemplate&quot;:true,&quot;type&quot;:&quot;text&quot;}"/>
-          <p:cNvSpPr txBox="1"/>
-          <p:nvPr/>
-        </p:nvSpPr>
-        <p:spPr>
-          <a:xfrm>
-            <a:off x="9286875" y="2152650"/>
-            <a:ext cx="1181100" cy="209550"/>
-          </a:xfrm>
-          <a:prstGeom prst="rect">
-            <a:avLst/>
-          </a:prstGeom>
-        </p:spPr>
-        <p:txBody>
-          <a:bodyPr wrap="none" lIns="0" tIns="0" rIns="0" bIns="0"/>
-          <a:p>
-            <a:pPr>
-              <a:lnSpc>
-                <a:spcPct val="100000"/>
-              </a:lnSpc>
-            </a:pPr>
-            <a:r>
-              <a:rPr lang="en-US" sz="1350">
-                <a:solidFill>
-                  <a:srgbClr val="1A1A1A"/>
-                </a:solidFill>
-                <a:latin typeface="微软雅黑" panose="020B0503020204020204" charset="-122"/>
-                <a:ea typeface="微软雅黑" panose="020B0503020204020204" charset="-122"/>
-              </a:rPr>
-              <a:t>6 </a:t>
-            </a:r>
-            <a:r>
-              <a:rPr lang="zh-CN" sz="1350">
-                <a:solidFill>
-                  <a:srgbClr val="1A1A1A"/>
-                </a:solidFill>
-                <a:latin typeface="微软雅黑" panose="020B0503020204020204" charset="-122"/>
-                <a:ea typeface="微软雅黑" panose="020B0503020204020204" charset="-122"/>
-              </a:rPr>
-              <a:t>月单月通过率</a:t>
-            </a:r>
-            <a:endParaRPr lang="zh-CN" sz="1350">
-              <a:solidFill>
-                <a:srgbClr val="1A1A1A"/>
-              </a:solidFill>
-              <a:latin typeface="微软雅黑" panose="020B0503020204020204" charset="-122"/>
-              <a:ea typeface="微软雅黑" panose="020B0503020204020204" charset="-122"/>
-            </a:endParaRPr>
-          </a:p>
-        </p:txBody>
-      </p:sp>
-      <p:sp>
-        <p:nvSpPr>
-          <p:cNvPr id="25" name="圆角矩形 24"/>
-          <p:cNvSpPr/>
-          <p:nvPr/>
-        </p:nvSpPr>
-        <p:spPr>
-          <a:xfrm>
-            <a:off x="533400" y="2857500"/>
-            <a:ext cx="11125200" cy="619125"/>
-          </a:xfrm>
-          <a:prstGeom prst="roundRect">
-            <a:avLst>
-              <a:gd name="adj" fmla="val 15385"/>
-            </a:avLst>
-          </a:prstGeom>
-          <a:solidFill>
-            <a:srgbClr val="052B7C"/>
-          </a:solidFill>
-        </p:spPr>
-        <p:txBody>
-          <a:bodyPr/>
-          <a:p/>
-        </p:txBody>
-      </p:sp>
-      <p:sp>
-        <p:nvSpPr>
-          <p:cNvPr id="26" name="文本框 25" descr="{&quot;isTemplate&quot;:true,&quot;type&quot;:&quot;text&quot;}"/>
-          <p:cNvSpPr txBox="1"/>
-          <p:nvPr/>
-        </p:nvSpPr>
-        <p:spPr>
-          <a:xfrm>
-            <a:off x="742950" y="3009900"/>
-            <a:ext cx="10706100" cy="314325"/>
-          </a:xfrm>
-          <a:prstGeom prst="rect">
-            <a:avLst/>
-          </a:prstGeom>
-        </p:spPr>
-        <p:txBody>
-          <a:bodyPr wrap="none" lIns="0" tIns="0" rIns="0" bIns="0"/>
-          <a:p>
-            <a:pPr>
-              <a:lnSpc>
-                <a:spcPct val="150000"/>
-              </a:lnSpc>
-            </a:pPr>
-            <a:r>
-              <a:rPr lang="zh-CN" sz="1350">
-                <a:solidFill>
-                  <a:srgbClr val="FFFFFF"/>
-                </a:solidFill>
-                <a:latin typeface="微软雅黑" panose="020B0503020204020204" charset="-122"/>
-                <a:ea typeface="微软雅黑" panose="020B0503020204020204" charset="-122"/>
-              </a:rPr>
-              <a:t>入职以来</a:t>
-            </a:r>
-            <a:r>
-              <a:rPr lang="en-US" sz="1350">
-                <a:solidFill>
-                  <a:srgbClr val="FFFFFF"/>
-                </a:solidFill>
-                <a:latin typeface="微软雅黑" panose="020B0503020204020204" charset="-122"/>
-                <a:ea typeface="微软雅黑" panose="020B0503020204020204" charset="-122"/>
-              </a:rPr>
-              <a:t> </a:t>
-            </a:r>
-            <a:r>
-              <a:rPr lang="en-US" sz="1350" b="1">
-                <a:solidFill>
-                  <a:srgbClr val="FFFFFF"/>
-                </a:solidFill>
-                <a:latin typeface="微软雅黑" panose="020B0503020204020204" charset="-122"/>
-                <a:ea typeface="微软雅黑" panose="020B0503020204020204" charset="-122"/>
-              </a:rPr>
-              <a:t>37 </a:t>
-            </a:r>
-            <a:r>
-              <a:rPr lang="zh-CN" sz="1350" b="1">
-                <a:solidFill>
-                  <a:srgbClr val="FFFFFF"/>
-                </a:solidFill>
-                <a:latin typeface="微软雅黑" panose="020B0503020204020204" charset="-122"/>
-                <a:ea typeface="微软雅黑" panose="020B0503020204020204" charset="-122"/>
-              </a:rPr>
-              <a:t>项验收</a:t>
-            </a:r>
-            <a:r>
-              <a:rPr lang="en-US" sz="1350" b="1">
-                <a:solidFill>
-                  <a:srgbClr val="FFFFFF"/>
-                </a:solidFill>
-                <a:latin typeface="微软雅黑" panose="020B0503020204020204" charset="-122"/>
-                <a:ea typeface="微软雅黑" panose="020B0503020204020204" charset="-122"/>
-              </a:rPr>
-              <a:t> + 19 </a:t>
-            </a:r>
-            <a:r>
-              <a:rPr lang="zh-CN" sz="1350" b="1">
-                <a:solidFill>
-                  <a:srgbClr val="FFFFFF"/>
-                </a:solidFill>
-                <a:latin typeface="微软雅黑" panose="020B0503020204020204" charset="-122"/>
-                <a:ea typeface="微软雅黑" panose="020B0503020204020204" charset="-122"/>
-              </a:rPr>
-              <a:t>项问题反馈闭环</a:t>
-            </a:r>
-            <a:r>
-              <a:rPr lang="zh-CN" sz="1350">
-                <a:solidFill>
-                  <a:srgbClr val="FFFFFF"/>
-                </a:solidFill>
-                <a:latin typeface="微软雅黑" panose="020B0503020204020204" charset="-122"/>
-                <a:ea typeface="微软雅黑" panose="020B0503020204020204" charset="-122"/>
-              </a:rPr>
-              <a:t>，</a:t>
-            </a:r>
-            <a:r>
-              <a:rPr lang="en-US" sz="1350">
-                <a:solidFill>
-                  <a:srgbClr val="FFFFFF"/>
-                </a:solidFill>
-                <a:latin typeface="微软雅黑" panose="020B0503020204020204" charset="-122"/>
-                <a:ea typeface="微软雅黑" panose="020B0503020204020204" charset="-122"/>
-              </a:rPr>
-              <a:t>6 </a:t>
-            </a:r>
-            <a:r>
-              <a:rPr lang="zh-CN" sz="1350">
-                <a:solidFill>
-                  <a:srgbClr val="FFFFFF"/>
-                </a:solidFill>
-                <a:latin typeface="微软雅黑" panose="020B0503020204020204" charset="-122"/>
-                <a:ea typeface="微软雅黑" panose="020B0503020204020204" charset="-122"/>
-              </a:rPr>
-              <a:t>月单月通过率</a:t>
-            </a:r>
-            <a:r>
-              <a:rPr lang="en-US" sz="1350">
-                <a:solidFill>
-                  <a:srgbClr val="FFFFFF"/>
-                </a:solidFill>
-                <a:latin typeface="微软雅黑" panose="020B0503020204020204" charset="-122"/>
-                <a:ea typeface="微软雅黑" panose="020B0503020204020204" charset="-122"/>
-              </a:rPr>
-              <a:t> 93.3% → </a:t>
-            </a:r>
-            <a:r>
-              <a:rPr lang="zh-CN" sz="1350">
-                <a:solidFill>
-                  <a:srgbClr val="FFFFFF"/>
-                </a:solidFill>
-                <a:latin typeface="微软雅黑" panose="020B0503020204020204" charset="-122"/>
-                <a:ea typeface="微软雅黑" panose="020B0503020204020204" charset="-122"/>
-              </a:rPr>
-              <a:t>把「供应商交付」变「可度量、可追溯、有退回机制」的质量门槛。</a:t>
-            </a:r>
-            <a:endParaRPr lang="zh-CN" sz="1350">
-              <a:solidFill>
-                <a:srgbClr val="FFFFFF"/>
-              </a:solidFill>
-              <a:latin typeface="微软雅黑" panose="020B0503020204020204" charset="-122"/>
-              <a:ea typeface="微软雅黑" panose="020B0503020204020204" charset="-122"/>
-            </a:endParaRPr>
-          </a:p>
-        </p:txBody>
-      </p:sp>
-      <p:graphicFrame>
-        <p:nvGraphicFramePr>
-          <p:cNvPr id="27" name="表格 26"/>
-          <p:cNvGraphicFramePr/>
-          <p:nvPr/>
-        </p:nvGraphicFramePr>
-        <p:xfrm>
-          <a:off x="533400" y="3810000"/>
-          <a:ext cx="11125200" cy="2190750"/>
-        </p:xfrm>
-        <a:graphic>
-          <a:graphicData uri="http://schemas.openxmlformats.org/drawingml/2006/table">
-            <a:tbl>
-              <a:tblPr/>
-              <a:tblGrid>
-                <a:gridCol w="2249357"/>
-                <a:gridCol w="3790905"/>
-                <a:gridCol w="1511151"/>
-                <a:gridCol w="3573786"/>
-              </a:tblGrid>
-              <a:tr h="438150">
-                <a:tc>
-                  <a:txBody>
-                    <a:bodyPr wrap="square">
-                      <a:spAutoFit/>
-                    </a:bodyPr>
-                    <a:p>
-                      <a:pPr marL="114300" marR="114300" algn="l">
-                        <a:lnSpc>
-                          <a:spcPct val="120000"/>
-                        </a:lnSpc>
-                      </a:pPr>
-                      <a:r>
-                        <a:rPr sz="1125" b="1">
-                          <a:solidFill>
-                            <a:srgbClr val="1A1A1A"/>
-                          </a:solidFill>
-                          <a:latin typeface="微软雅黑" panose="020B0503020204020204" charset="-122"/>
-                          <a:ea typeface="微软雅黑" panose="020B0503020204020204" charset="-122"/>
-                        </a:rPr>
-                        <a:t>周期</a:t>
-                      </a:r>
-                      <a:endParaRPr sz="1125" b="1">
-                        <a:solidFill>
-                          <a:srgbClr val="1A1A1A"/>
-                        </a:solidFill>
-                        <a:latin typeface="微软雅黑" panose="020B0503020204020204" charset="-122"/>
-                        <a:ea typeface="微软雅黑" panose="020B0503020204020204" charset="-122"/>
-                      </a:endParaRPr>
-                    </a:p>
-                  </a:txBody>
-                  <a:tcPr marL="0" marR="0" marT="0" marB="0" anchor="ctr">
-                    <a:lnL>
-                      <a:noFill/>
-                    </a:lnL>
-                    <a:lnR>
-                      <a:noFill/>
-                    </a:lnR>
-                    <a:lnT>
-                      <a:noFill/>
-                    </a:lnT>
-                    <a:lnB>
-                      <a:noFill/>
-                    </a:lnB>
-                    <a:solidFill>
-                      <a:srgbClr val="DAE3F3"/>
-                    </a:solidFill>
-                  </a:tcPr>
-                </a:tc>
-                <a:tc>
-                  <a:txBody>
-                    <a:bodyPr wrap="square">
-                      <a:spAutoFit/>
-                    </a:bodyPr>
-                    <a:p>
-                      <a:pPr marL="114300" marR="114300" algn="l">
-                        <a:lnSpc>
-                          <a:spcPct val="120000"/>
-                        </a:lnSpc>
-                      </a:pPr>
-                      <a:r>
-                        <a:rPr sz="1125" b="1">
-                          <a:solidFill>
-                            <a:srgbClr val="1A1A1A"/>
-                          </a:solidFill>
-                          <a:latin typeface="微软雅黑" panose="020B0503020204020204" charset="-122"/>
-                          <a:ea typeface="微软雅黑" panose="020B0503020204020204" charset="-122"/>
-                        </a:rPr>
-                        <a:t>验收产出</a:t>
-                      </a:r>
-                      <a:endParaRPr sz="1125" b="1">
-                        <a:solidFill>
-                          <a:srgbClr val="1A1A1A"/>
-                        </a:solidFill>
-                        <a:latin typeface="微软雅黑" panose="020B0503020204020204" charset="-122"/>
-                        <a:ea typeface="微软雅黑" panose="020B0503020204020204" charset="-122"/>
-                      </a:endParaRPr>
-                    </a:p>
-                  </a:txBody>
-                  <a:tcPr marL="0" marR="0" marT="0" marB="0" anchor="ctr">
-                    <a:lnL>
-                      <a:noFill/>
-                    </a:lnL>
-                    <a:lnR>
-                      <a:noFill/>
-                    </a:lnR>
-                    <a:lnT>
-                      <a:noFill/>
-                    </a:lnT>
-                    <a:lnB>
-                      <a:noFill/>
-                    </a:lnB>
-                    <a:solidFill>
-                      <a:srgbClr val="DAE3F3"/>
-                    </a:solidFill>
-                  </a:tcPr>
-                </a:tc>
-                <a:tc>
-                  <a:txBody>
-                    <a:bodyPr wrap="square">
-                      <a:spAutoFit/>
-                    </a:bodyPr>
-                    <a:p>
-                      <a:pPr marL="114300" marR="114300" algn="l">
-                        <a:lnSpc>
-                          <a:spcPct val="120000"/>
-                        </a:lnSpc>
-                      </a:pPr>
-                      <a:r>
-                        <a:rPr sz="1125" b="1">
-                          <a:solidFill>
-                            <a:srgbClr val="1A1A1A"/>
-                          </a:solidFill>
-                          <a:latin typeface="微软雅黑" panose="020B0503020204020204" charset="-122"/>
-                          <a:ea typeface="微软雅黑" panose="020B0503020204020204" charset="-122"/>
-                        </a:rPr>
-                        <a:t>问题反馈</a:t>
-                      </a:r>
-                      <a:endParaRPr sz="1125" b="1">
-                        <a:solidFill>
-                          <a:srgbClr val="1A1A1A"/>
-                        </a:solidFill>
-                        <a:latin typeface="微软雅黑" panose="020B0503020204020204" charset="-122"/>
-                        <a:ea typeface="微软雅黑" panose="020B0503020204020204" charset="-122"/>
-                      </a:endParaRPr>
-                    </a:p>
-                  </a:txBody>
-                  <a:tcPr marL="0" marR="0" marT="0" marB="0" anchor="ctr">
-                    <a:lnL>
-                      <a:noFill/>
-                    </a:lnL>
-                    <a:lnR>
-                      <a:noFill/>
-                    </a:lnR>
-                    <a:lnT>
-                      <a:noFill/>
-                    </a:lnT>
-                    <a:lnB>
-                      <a:noFill/>
-                    </a:lnB>
-                    <a:solidFill>
-                      <a:srgbClr val="DAE3F3"/>
-                    </a:solidFill>
-                  </a:tcPr>
-                </a:tc>
-                <a:tc>
-                  <a:txBody>
-                    <a:bodyPr wrap="square">
-                      <a:spAutoFit/>
-                    </a:bodyPr>
-                    <a:p>
-                      <a:pPr marL="114300" marR="114300" algn="l">
-                        <a:lnSpc>
-                          <a:spcPct val="120000"/>
-                        </a:lnSpc>
-                      </a:pPr>
-                      <a:r>
-                        <a:rPr sz="1125" b="1">
-                          <a:solidFill>
-                            <a:srgbClr val="1A1A1A"/>
-                          </a:solidFill>
-                          <a:latin typeface="微软雅黑" panose="020B0503020204020204" charset="-122"/>
-                          <a:ea typeface="微软雅黑" panose="020B0503020204020204" charset="-122"/>
-                        </a:rPr>
-                        <a:t>通过情况</a:t>
-                      </a:r>
-                      <a:endParaRPr sz="1125" b="1">
-                        <a:solidFill>
-                          <a:srgbClr val="1A1A1A"/>
-                        </a:solidFill>
-                        <a:latin typeface="微软雅黑" panose="020B0503020204020204" charset="-122"/>
-                        <a:ea typeface="微软雅黑" panose="020B0503020204020204" charset="-122"/>
-                      </a:endParaRPr>
-                    </a:p>
-                  </a:txBody>
-                  <a:tcPr marL="0" marR="0" marT="0" marB="0" anchor="ctr">
-                    <a:lnL>
-                      <a:noFill/>
-                    </a:lnL>
-                    <a:lnR>
-                      <a:noFill/>
-                    </a:lnR>
-                    <a:lnT>
-                      <a:noFill/>
-                    </a:lnT>
-                    <a:lnB>
-                      <a:noFill/>
-                    </a:lnB>
-                    <a:solidFill>
-                      <a:srgbClr val="DAE3F3"/>
-                    </a:solidFill>
-                  </a:tcPr>
-                </a:tc>
-              </a:tr>
-              <a:tr h="438150">
-                <a:tc>
-                  <a:txBody>
-                    <a:bodyPr wrap="square">
-                      <a:spAutoFit/>
-                    </a:bodyPr>
-                    <a:p>
-                      <a:pPr marL="114300" marR="114300" algn="l">
-                        <a:lnSpc>
-                          <a:spcPct val="120000"/>
-                        </a:lnSpc>
-                      </a:pPr>
-                      <a:r>
-                        <a:rPr sz="1125">
-                          <a:solidFill>
-                            <a:srgbClr val="1A1A1A"/>
-                          </a:solidFill>
-                          <a:latin typeface="微软雅黑" panose="020B0503020204020204" charset="-122"/>
-                          <a:ea typeface="微软雅黑" panose="020B0503020204020204" charset="-122"/>
-                        </a:rPr>
-                        <a:t>4 月</a:t>
-                      </a:r>
-                      <a:endParaRPr sz="1125">
-                        <a:solidFill>
-                          <a:srgbClr val="1A1A1A"/>
-                        </a:solidFill>
-                        <a:latin typeface="微软雅黑" panose="020B0503020204020204" charset="-122"/>
-                        <a:ea typeface="微软雅黑" panose="020B0503020204020204" charset="-122"/>
-                      </a:endParaRPr>
-                    </a:p>
-                  </a:txBody>
-                  <a:tcPr marL="0" marR="0" marT="0" marB="0" anchor="ctr">
-                    <a:lnL>
-                      <a:noFill/>
-                    </a:lnL>
-                    <a:lnR>
-                      <a:noFill/>
-                    </a:lnR>
-                    <a:lnT>
-                      <a:noFill/>
-                    </a:lnT>
-                    <a:lnB>
-                      <a:noFill/>
-                    </a:lnB>
-                  </a:tcPr>
-                </a:tc>
-                <a:tc>
-                  <a:txBody>
-                    <a:bodyPr wrap="square">
-                      <a:spAutoFit/>
-                    </a:bodyPr>
-                    <a:p>
-                      <a:pPr marL="114300" marR="114300" algn="l">
-                        <a:lnSpc>
-                          <a:spcPct val="120000"/>
-                        </a:lnSpc>
-                      </a:pPr>
-                      <a:r>
-                        <a:rPr sz="1125">
-                          <a:solidFill>
-                            <a:srgbClr val="1A1A1A"/>
-                          </a:solidFill>
-                          <a:latin typeface="微软雅黑" panose="020B0503020204020204" charset="-122"/>
-                          <a:ea typeface="微软雅黑" panose="020B0503020204020204" charset="-122"/>
-                        </a:rPr>
-                        <a:t>3 测试 + 2 验收（5 项）</a:t>
-                      </a:r>
-                      <a:endParaRPr sz="1125">
-                        <a:solidFill>
-                          <a:srgbClr val="1A1A1A"/>
-                        </a:solidFill>
-                        <a:latin typeface="微软雅黑" panose="020B0503020204020204" charset="-122"/>
-                        <a:ea typeface="微软雅黑" panose="020B0503020204020204" charset="-122"/>
-                      </a:endParaRPr>
-                    </a:p>
-                  </a:txBody>
-                  <a:tcPr marL="0" marR="0" marT="0" marB="0" anchor="ctr">
-                    <a:lnL>
-                      <a:noFill/>
-                    </a:lnL>
-                    <a:lnR>
-                      <a:noFill/>
-                    </a:lnR>
-                    <a:lnT>
-                      <a:noFill/>
-                    </a:lnT>
-                    <a:lnB>
-                      <a:noFill/>
-                    </a:lnB>
-                  </a:tcPr>
-                </a:tc>
-                <a:tc>
-                  <a:txBody>
-                    <a:bodyPr wrap="square">
-                      <a:spAutoFit/>
-                    </a:bodyPr>
-                    <a:p>
-                      <a:pPr marL="114300" marR="114300" algn="l">
-                        <a:lnSpc>
-                          <a:spcPct val="120000"/>
-                        </a:lnSpc>
-                      </a:pPr>
-                      <a:r>
-                        <a:rPr sz="1125">
-                          <a:solidFill>
-                            <a:srgbClr val="1A1A1A"/>
-                          </a:solidFill>
-                          <a:latin typeface="微软雅黑" panose="020B0503020204020204" charset="-122"/>
-                          <a:ea typeface="微软雅黑" panose="020B0503020204020204" charset="-122"/>
-                        </a:rPr>
-                        <a:t>4</a:t>
-                      </a:r>
-                      <a:endParaRPr sz="1125">
-                        <a:solidFill>
-                          <a:srgbClr val="1A1A1A"/>
-                        </a:solidFill>
-                        <a:latin typeface="微软雅黑" panose="020B0503020204020204" charset="-122"/>
-                        <a:ea typeface="微软雅黑" panose="020B0503020204020204" charset="-122"/>
-                      </a:endParaRPr>
-                    </a:p>
-                  </a:txBody>
-                  <a:tcPr marL="0" marR="0" marT="0" marB="0" anchor="ctr">
-                    <a:lnL>
-                      <a:noFill/>
-                    </a:lnL>
-                    <a:lnR>
-                      <a:noFill/>
-                    </a:lnR>
-                    <a:lnT>
-                      <a:noFill/>
-                    </a:lnT>
-                    <a:lnB>
-                      <a:noFill/>
-                    </a:lnB>
-                  </a:tcPr>
-                </a:tc>
-                <a:tc>
-                  <a:txBody>
-                    <a:bodyPr wrap="square">
-                      <a:spAutoFit/>
-                    </a:bodyPr>
-                    <a:p>
-                      <a:pPr marL="114300" marR="114300" algn="l">
-                        <a:lnSpc>
-                          <a:spcPct val="120000"/>
-                        </a:lnSpc>
-                      </a:pPr>
-                      <a:r>
-                        <a:rPr sz="1125">
-                          <a:solidFill>
-                            <a:srgbClr val="1A1A1A"/>
-                          </a:solidFill>
-                          <a:latin typeface="微软雅黑" panose="020B0503020204020204" charset="-122"/>
-                          <a:ea typeface="微软雅黑" panose="020B0503020204020204" charset="-122"/>
-                        </a:rPr>
-                        <a:t>—</a:t>
-                      </a:r>
-                      <a:endParaRPr sz="1125">
-                        <a:solidFill>
-                          <a:srgbClr val="1A1A1A"/>
-                        </a:solidFill>
-                        <a:latin typeface="微软雅黑" panose="020B0503020204020204" charset="-122"/>
-                        <a:ea typeface="微软雅黑" panose="020B0503020204020204" charset="-122"/>
-                      </a:endParaRPr>
-                    </a:p>
-                  </a:txBody>
-                  <a:tcPr marL="0" marR="0" marT="0" marB="0" anchor="ctr">
-                    <a:lnL>
-                      <a:noFill/>
-                    </a:lnL>
-                    <a:lnR>
-                      <a:noFill/>
-                    </a:lnR>
-                    <a:lnT>
-                      <a:noFill/>
-                    </a:lnT>
-                    <a:lnB>
-                      <a:noFill/>
-                    </a:lnB>
-                  </a:tcPr>
-                </a:tc>
-              </a:tr>
-              <a:tr h="438150">
-                <a:tc>
-                  <a:txBody>
-                    <a:bodyPr wrap="square">
-                      <a:spAutoFit/>
-                    </a:bodyPr>
-                    <a:p>
-                      <a:pPr marL="114300" marR="114300" algn="l">
-                        <a:lnSpc>
-                          <a:spcPct val="120000"/>
-                        </a:lnSpc>
-                      </a:pPr>
-                      <a:r>
-                        <a:rPr sz="1125">
-                          <a:solidFill>
-                            <a:srgbClr val="1A1A1A"/>
-                          </a:solidFill>
-                          <a:latin typeface="微软雅黑" panose="020B0503020204020204" charset="-122"/>
-                          <a:ea typeface="微软雅黑" panose="020B0503020204020204" charset="-122"/>
-                        </a:rPr>
-                        <a:t>5 月</a:t>
-                      </a:r>
-                      <a:endParaRPr sz="1125">
-                        <a:solidFill>
-                          <a:srgbClr val="1A1A1A"/>
-                        </a:solidFill>
-                        <a:latin typeface="微软雅黑" panose="020B0503020204020204" charset="-122"/>
-                        <a:ea typeface="微软雅黑" panose="020B0503020204020204" charset="-122"/>
-                      </a:endParaRPr>
-                    </a:p>
-                  </a:txBody>
-                  <a:tcPr marL="0" marR="0" marT="0" marB="0" anchor="ctr">
-                    <a:lnL>
-                      <a:noFill/>
-                    </a:lnL>
-                    <a:lnR>
-                      <a:noFill/>
-                    </a:lnR>
-                    <a:lnT>
-                      <a:noFill/>
-                    </a:lnT>
-                    <a:lnB>
-                      <a:noFill/>
-                    </a:lnB>
-                  </a:tcPr>
-                </a:tc>
-                <a:tc>
-                  <a:txBody>
-                    <a:bodyPr wrap="square">
-                      <a:spAutoFit/>
-                    </a:bodyPr>
-                    <a:p>
-                      <a:pPr marL="114300" marR="114300" algn="l">
-                        <a:lnSpc>
-                          <a:spcPct val="120000"/>
-                        </a:lnSpc>
-                      </a:pPr>
-                      <a:r>
-                        <a:rPr sz="1125">
-                          <a:solidFill>
-                            <a:srgbClr val="1A1A1A"/>
-                          </a:solidFill>
-                          <a:latin typeface="微软雅黑" panose="020B0503020204020204" charset="-122"/>
-                          <a:ea typeface="微软雅黑" panose="020B0503020204020204" charset="-122"/>
-                        </a:rPr>
-                        <a:t>9 项测试验收</a:t>
-                      </a:r>
-                      <a:endParaRPr sz="1125">
-                        <a:solidFill>
-                          <a:srgbClr val="1A1A1A"/>
-                        </a:solidFill>
-                        <a:latin typeface="微软雅黑" panose="020B0503020204020204" charset="-122"/>
-                        <a:ea typeface="微软雅黑" panose="020B0503020204020204" charset="-122"/>
-                      </a:endParaRPr>
-                    </a:p>
-                  </a:txBody>
-                  <a:tcPr marL="0" marR="0" marT="0" marB="0" anchor="ctr">
-                    <a:lnL>
-                      <a:noFill/>
-                    </a:lnL>
-                    <a:lnR>
-                      <a:noFill/>
-                    </a:lnR>
-                    <a:lnT>
-                      <a:noFill/>
-                    </a:lnT>
-                    <a:lnB>
-                      <a:noFill/>
-                    </a:lnB>
-                  </a:tcPr>
-                </a:tc>
-                <a:tc>
-                  <a:txBody>
-                    <a:bodyPr wrap="square">
-                      <a:spAutoFit/>
-                    </a:bodyPr>
-                    <a:p>
-                      <a:pPr marL="114300" marR="114300" algn="l">
-                        <a:lnSpc>
-                          <a:spcPct val="120000"/>
-                        </a:lnSpc>
-                      </a:pPr>
-                      <a:r>
-                        <a:rPr sz="1125">
-                          <a:solidFill>
-                            <a:srgbClr val="1A1A1A"/>
-                          </a:solidFill>
-                          <a:latin typeface="微软雅黑" panose="020B0503020204020204" charset="-122"/>
-                          <a:ea typeface="微软雅黑" panose="020B0503020204020204" charset="-122"/>
-                        </a:rPr>
-                        <a:t>3</a:t>
-                      </a:r>
-                      <a:endParaRPr sz="1125">
-                        <a:solidFill>
-                          <a:srgbClr val="1A1A1A"/>
-                        </a:solidFill>
-                        <a:latin typeface="微软雅黑" panose="020B0503020204020204" charset="-122"/>
-                        <a:ea typeface="微软雅黑" panose="020B0503020204020204" charset="-122"/>
-                      </a:endParaRPr>
-                    </a:p>
-                  </a:txBody>
-                  <a:tcPr marL="0" marR="0" marT="0" marB="0" anchor="ctr">
-                    <a:lnL>
-                      <a:noFill/>
-                    </a:lnL>
-                    <a:lnR>
-                      <a:noFill/>
-                    </a:lnR>
-                    <a:lnT>
-                      <a:noFill/>
-                    </a:lnT>
-                    <a:lnB>
-                      <a:noFill/>
-                    </a:lnB>
-                  </a:tcPr>
-                </a:tc>
-                <a:tc>
-                  <a:txBody>
-                    <a:bodyPr wrap="square">
-                      <a:spAutoFit/>
-                    </a:bodyPr>
-                    <a:p>
-                      <a:pPr marL="114300" marR="114300" algn="l">
-                        <a:lnSpc>
-                          <a:spcPct val="120000"/>
-                        </a:lnSpc>
-                      </a:pPr>
-                      <a:r>
-                        <a:rPr sz="1125">
-                          <a:solidFill>
-                            <a:srgbClr val="1A1A1A"/>
-                          </a:solidFill>
-                          <a:latin typeface="微软雅黑" panose="020B0503020204020204" charset="-122"/>
-                          <a:ea typeface="微软雅黑" panose="020B0503020204020204" charset="-122"/>
-                        </a:rPr>
-                        <a:t>—</a:t>
-                      </a:r>
-                      <a:endParaRPr sz="1125">
-                        <a:solidFill>
-                          <a:srgbClr val="1A1A1A"/>
-                        </a:solidFill>
-                        <a:latin typeface="微软雅黑" panose="020B0503020204020204" charset="-122"/>
-                        <a:ea typeface="微软雅黑" panose="020B0503020204020204" charset="-122"/>
-                      </a:endParaRPr>
-                    </a:p>
-                  </a:txBody>
-                  <a:tcPr marL="0" marR="0" marT="0" marB="0" anchor="ctr">
-                    <a:lnL>
-                      <a:noFill/>
-                    </a:lnL>
-                    <a:lnR>
-                      <a:noFill/>
-                    </a:lnR>
-                    <a:lnT>
-                      <a:noFill/>
-                    </a:lnT>
-                    <a:lnB>
-                      <a:noFill/>
-                    </a:lnB>
-                  </a:tcPr>
-                </a:tc>
-              </a:tr>
-              <a:tr h="438150">
-                <a:tc>
-                  <a:txBody>
-                    <a:bodyPr wrap="square">
-                      <a:spAutoFit/>
-                    </a:bodyPr>
-                    <a:p>
-                      <a:pPr marL="114300" marR="114300" algn="l">
-                        <a:lnSpc>
-                          <a:spcPct val="120000"/>
-                        </a:lnSpc>
-                      </a:pPr>
-                      <a:r>
-                        <a:rPr sz="1125">
-                          <a:solidFill>
-                            <a:srgbClr val="1A1A1A"/>
-                          </a:solidFill>
-                          <a:latin typeface="微软雅黑" panose="020B0503020204020204" charset="-122"/>
-                          <a:ea typeface="微软雅黑" panose="020B0503020204020204" charset="-122"/>
-                        </a:rPr>
-                        <a:t>6 月</a:t>
-                      </a:r>
-                      <a:endParaRPr sz="1125">
-                        <a:solidFill>
-                          <a:srgbClr val="1A1A1A"/>
-                        </a:solidFill>
-                        <a:latin typeface="微软雅黑" panose="020B0503020204020204" charset="-122"/>
-                        <a:ea typeface="微软雅黑" panose="020B0503020204020204" charset="-122"/>
-                      </a:endParaRPr>
-                    </a:p>
-                  </a:txBody>
-                  <a:tcPr marL="0" marR="0" marT="0" marB="0" anchor="ctr">
-                    <a:lnL>
-                      <a:noFill/>
-                    </a:lnL>
-                    <a:lnR>
-                      <a:noFill/>
-                    </a:lnR>
-                    <a:lnT>
-                      <a:noFill/>
-                    </a:lnT>
-                    <a:lnB>
-                      <a:noFill/>
-                    </a:lnB>
-                  </a:tcPr>
-                </a:tc>
-                <a:tc>
-                  <a:txBody>
-                    <a:bodyPr wrap="square">
-                      <a:spAutoFit/>
-                    </a:bodyPr>
-                    <a:p>
-                      <a:pPr marL="114300" marR="114300" algn="l">
-                        <a:lnSpc>
-                          <a:spcPct val="120000"/>
-                        </a:lnSpc>
-                      </a:pPr>
-                      <a:r>
-                        <a:rPr sz="1125">
-                          <a:solidFill>
-                            <a:srgbClr val="1A1A1A"/>
-                          </a:solidFill>
-                          <a:latin typeface="微软雅黑" panose="020B0503020204020204" charset="-122"/>
-                          <a:ea typeface="微软雅黑" panose="020B0503020204020204" charset="-122"/>
-                        </a:rPr>
-                        <a:t>15 用例（5 批次）</a:t>
-                      </a:r>
-                      <a:endParaRPr sz="1125">
-                        <a:solidFill>
-                          <a:srgbClr val="1A1A1A"/>
-                        </a:solidFill>
-                        <a:latin typeface="微软雅黑" panose="020B0503020204020204" charset="-122"/>
-                        <a:ea typeface="微软雅黑" panose="020B0503020204020204" charset="-122"/>
-                      </a:endParaRPr>
-                    </a:p>
-                  </a:txBody>
-                  <a:tcPr marL="0" marR="0" marT="0" marB="0" anchor="ctr">
-                    <a:lnL>
-                      <a:noFill/>
-                    </a:lnL>
-                    <a:lnR>
-                      <a:noFill/>
-                    </a:lnR>
-                    <a:lnT>
-                      <a:noFill/>
-                    </a:lnT>
-                    <a:lnB>
-                      <a:noFill/>
-                    </a:lnB>
-                  </a:tcPr>
-                </a:tc>
-                <a:tc>
-                  <a:txBody>
-                    <a:bodyPr wrap="square">
-                      <a:spAutoFit/>
-                    </a:bodyPr>
-                    <a:p>
-                      <a:pPr marL="114300" marR="114300" algn="l">
-                        <a:lnSpc>
-                          <a:spcPct val="120000"/>
-                        </a:lnSpc>
-                      </a:pPr>
-                      <a:r>
-                        <a:rPr sz="1125">
-                          <a:solidFill>
-                            <a:srgbClr val="1A1A1A"/>
-                          </a:solidFill>
-                          <a:latin typeface="微软雅黑" panose="020B0503020204020204" charset="-122"/>
-                          <a:ea typeface="微软雅黑" panose="020B0503020204020204" charset="-122"/>
-                        </a:rPr>
-                        <a:t>8</a:t>
-                      </a:r>
-                      <a:endParaRPr sz="1125">
-                        <a:solidFill>
-                          <a:srgbClr val="1A1A1A"/>
-                        </a:solidFill>
-                        <a:latin typeface="微软雅黑" panose="020B0503020204020204" charset="-122"/>
-                        <a:ea typeface="微软雅黑" panose="020B0503020204020204" charset="-122"/>
-                      </a:endParaRPr>
-                    </a:p>
-                  </a:txBody>
-                  <a:tcPr marL="0" marR="0" marT="0" marB="0" anchor="ctr">
-                    <a:lnL>
-                      <a:noFill/>
-                    </a:lnL>
-                    <a:lnR>
-                      <a:noFill/>
-                    </a:lnR>
-                    <a:lnT>
-                      <a:noFill/>
-                    </a:lnT>
-                    <a:lnB>
-                      <a:noFill/>
-                    </a:lnB>
-                  </a:tcPr>
-                </a:tc>
-                <a:tc>
-                  <a:txBody>
-                    <a:bodyPr wrap="square">
-                      <a:spAutoFit/>
-                    </a:bodyPr>
-                    <a:p>
-                      <a:pPr marL="114300" marR="114300" algn="l">
-                        <a:lnSpc>
-                          <a:spcPct val="120000"/>
-                        </a:lnSpc>
-                      </a:pPr>
-                      <a:r>
-                        <a:rPr sz="1125" b="1">
-                          <a:solidFill>
-                            <a:srgbClr val="4472C4"/>
-                          </a:solidFill>
-                          <a:latin typeface="微软雅黑" panose="020B0503020204020204" charset="-122"/>
-                          <a:ea typeface="微软雅黑" panose="020B0503020204020204" charset="-122"/>
-                        </a:rPr>
-                        <a:t>14/15 通过（93.3%）</a:t>
-                      </a:r>
-                      <a:endParaRPr sz="1125" b="1">
-                        <a:solidFill>
-                          <a:srgbClr val="4472C4"/>
-                        </a:solidFill>
-                        <a:latin typeface="微软雅黑" panose="020B0503020204020204" charset="-122"/>
-                        <a:ea typeface="微软雅黑" panose="020B0503020204020204" charset="-122"/>
-                      </a:endParaRPr>
-                    </a:p>
-                  </a:txBody>
-                  <a:tcPr marL="0" marR="0" marT="0" marB="0" anchor="ctr">
-                    <a:lnL>
-                      <a:noFill/>
-                    </a:lnL>
-                    <a:lnR>
-                      <a:noFill/>
-                    </a:lnR>
-                    <a:lnT>
-                      <a:noFill/>
-                    </a:lnT>
-                    <a:lnB>
-                      <a:noFill/>
-                    </a:lnB>
-                  </a:tcPr>
-                </a:tc>
-              </a:tr>
-              <a:tr h="438150">
-                <a:tc>
-                  <a:txBody>
-                    <a:bodyPr wrap="square">
-                      <a:spAutoFit/>
-                    </a:bodyPr>
-                    <a:p>
-                      <a:pPr marL="114300" marR="114300" algn="l">
-                        <a:lnSpc>
-                          <a:spcPct val="120000"/>
-                        </a:lnSpc>
-                      </a:pPr>
-                      <a:r>
-                        <a:rPr sz="1125">
-                          <a:solidFill>
-                            <a:srgbClr val="1A1A1A"/>
-                          </a:solidFill>
-                          <a:latin typeface="微软雅黑" panose="020B0503020204020204" charset="-122"/>
-                          <a:ea typeface="微软雅黑" panose="020B0503020204020204" charset="-122"/>
-                        </a:rPr>
-                        <a:t>7 月（2607）</a:t>
-                      </a:r>
-                      <a:endParaRPr sz="1125">
-                        <a:solidFill>
-                          <a:srgbClr val="1A1A1A"/>
-                        </a:solidFill>
-                        <a:latin typeface="微软雅黑" panose="020B0503020204020204" charset="-122"/>
-                        <a:ea typeface="微软雅黑" panose="020B0503020204020204" charset="-122"/>
-                      </a:endParaRPr>
-                    </a:p>
-                  </a:txBody>
-                  <a:tcPr marL="0" marR="0" marT="0" marB="0" anchor="ctr">
-                    <a:lnL>
-                      <a:noFill/>
-                    </a:lnL>
-                    <a:lnR>
-                      <a:noFill/>
-                    </a:lnR>
-                    <a:lnT>
-                      <a:noFill/>
-                    </a:lnT>
-                    <a:lnB>
-                      <a:noFill/>
-                    </a:lnB>
-                  </a:tcPr>
-                </a:tc>
-                <a:tc>
-                  <a:txBody>
-                    <a:bodyPr wrap="square">
-                      <a:spAutoFit/>
-                    </a:bodyPr>
-                    <a:p>
-                      <a:pPr marL="114300" marR="114300" algn="l">
-                        <a:lnSpc>
-                          <a:spcPct val="120000"/>
-                        </a:lnSpc>
-                      </a:pPr>
-                      <a:r>
-                        <a:rPr sz="1125">
-                          <a:solidFill>
-                            <a:srgbClr val="1A1A1A"/>
-                          </a:solidFill>
-                          <a:latin typeface="微软雅黑" panose="020B0503020204020204" charset="-122"/>
-                          <a:ea typeface="微软雅黑" panose="020B0503020204020204" charset="-122"/>
-                        </a:rPr>
-                        <a:t>5 轮验收（8 项）</a:t>
-                      </a:r>
-                      <a:endParaRPr sz="1125">
-                        <a:solidFill>
-                          <a:srgbClr val="1A1A1A"/>
-                        </a:solidFill>
-                        <a:latin typeface="微软雅黑" panose="020B0503020204020204" charset="-122"/>
-                        <a:ea typeface="微软雅黑" panose="020B0503020204020204" charset="-122"/>
-                      </a:endParaRPr>
-                    </a:p>
-                  </a:txBody>
-                  <a:tcPr marL="0" marR="0" marT="0" marB="0" anchor="ctr">
-                    <a:lnL>
-                      <a:noFill/>
-                    </a:lnL>
-                    <a:lnR>
-                      <a:noFill/>
-                    </a:lnR>
-                    <a:lnT>
-                      <a:noFill/>
-                    </a:lnT>
-                    <a:lnB>
-                      <a:noFill/>
-                    </a:lnB>
-                  </a:tcPr>
-                </a:tc>
-                <a:tc>
-                  <a:txBody>
-                    <a:bodyPr wrap="square">
-                      <a:spAutoFit/>
-                    </a:bodyPr>
-                    <a:p>
-                      <a:pPr marL="114300" marR="114300" algn="l">
-                        <a:lnSpc>
-                          <a:spcPct val="120000"/>
-                        </a:lnSpc>
-                      </a:pPr>
-                      <a:r>
-                        <a:rPr sz="1125">
-                          <a:solidFill>
-                            <a:srgbClr val="1A1A1A"/>
-                          </a:solidFill>
-                          <a:latin typeface="微软雅黑" panose="020B0503020204020204" charset="-122"/>
-                          <a:ea typeface="微软雅黑" panose="020B0503020204020204" charset="-122"/>
-                        </a:rPr>
-                        <a:t>4</a:t>
-                      </a:r>
-                      <a:endParaRPr sz="1125">
-                        <a:solidFill>
-                          <a:srgbClr val="1A1A1A"/>
-                        </a:solidFill>
-                        <a:latin typeface="微软雅黑" panose="020B0503020204020204" charset="-122"/>
-                        <a:ea typeface="微软雅黑" panose="020B0503020204020204" charset="-122"/>
-                      </a:endParaRPr>
-                    </a:p>
-                  </a:txBody>
-                  <a:tcPr marL="0" marR="0" marT="0" marB="0" anchor="ctr">
-                    <a:lnL>
-                      <a:noFill/>
-                    </a:lnL>
-                    <a:lnR>
-                      <a:noFill/>
-                    </a:lnR>
-                    <a:lnT>
-                      <a:noFill/>
-                    </a:lnT>
-                    <a:lnB>
-                      <a:noFill/>
-                    </a:lnB>
-                  </a:tcPr>
-                </a:tc>
-                <a:tc>
-                  <a:txBody>
-                    <a:bodyPr wrap="square">
-                      <a:spAutoFit/>
-                    </a:bodyPr>
-                    <a:p>
-                      <a:pPr marL="114300" marR="114300" algn="l">
-                        <a:lnSpc>
-                          <a:spcPct val="120000"/>
-                        </a:lnSpc>
-                      </a:pPr>
-                      <a:r>
-                        <a:rPr sz="1125">
-                          <a:solidFill>
-                            <a:srgbClr val="1A1A1A"/>
-                          </a:solidFill>
-                          <a:latin typeface="微软雅黑" panose="020B0503020204020204" charset="-122"/>
-                          <a:ea typeface="微软雅黑" panose="020B0503020204020204" charset="-122"/>
-                        </a:rPr>
-                        <a:t>—</a:t>
-                      </a:r>
-                      <a:endParaRPr sz="1125">
-                        <a:solidFill>
-                          <a:srgbClr val="1A1A1A"/>
-                        </a:solidFill>
-                        <a:latin typeface="微软雅黑" panose="020B0503020204020204" charset="-122"/>
-                        <a:ea typeface="微软雅黑" panose="020B0503020204020204" charset="-122"/>
-                      </a:endParaRPr>
-                    </a:p>
-                  </a:txBody>
-                  <a:tcPr marL="0" marR="0" marT="0" marB="0" anchor="ctr">
-                    <a:lnL>
-                      <a:noFill/>
-                    </a:lnL>
-                    <a:lnR>
-                      <a:noFill/>
-                    </a:lnR>
-                    <a:lnT>
-                      <a:noFill/>
-                    </a:lnT>
-                    <a:lnB>
-                      <a:noFill/>
-                    </a:lnB>
-                  </a:tcPr>
-                </a:tc>
-              </a:tr>
-            </a:tbl>
-          </a:graphicData>
-        </a:graphic>
-      </p:graphicFrame>
-      <p:sp>
-        <p:nvSpPr>
-          <p:cNvPr id="28" name="文本框 27" descr="{&quot;isTemplate&quot;:true,&quot;type&quot;:&quot;text&quot;}"/>
-          <p:cNvSpPr txBox="1"/>
-          <p:nvPr/>
-        </p:nvSpPr>
-        <p:spPr>
-          <a:xfrm>
-            <a:off x="533400" y="6362700"/>
-            <a:ext cx="1285875" cy="161925"/>
-          </a:xfrm>
-          <a:prstGeom prst="rect">
-            <a:avLst/>
-          </a:prstGeom>
-        </p:spPr>
-        <p:txBody>
-          <a:bodyPr wrap="none" lIns="0" tIns="0" rIns="0" bIns="0"/>
-          <a:p>
-            <a:pPr>
-              <a:lnSpc>
-                <a:spcPct val="100000"/>
-              </a:lnSpc>
-            </a:pPr>
-            <a:r>
-              <a:rPr lang="zh-CN" sz="1050">
-                <a:solidFill>
-                  <a:srgbClr val="888888"/>
-                </a:solidFill>
-                <a:latin typeface="微软雅黑" panose="020B0503020204020204" charset="-122"/>
-                <a:ea typeface="微软雅黑" panose="020B0503020204020204" charset="-122"/>
-              </a:rPr>
-              <a:t>入职以来</a:t>
-            </a:r>
-            <a:r>
-              <a:rPr lang="en-US" sz="1050">
-                <a:solidFill>
-                  <a:srgbClr val="888888"/>
-                </a:solidFill>
-                <a:latin typeface="微软雅黑" panose="020B0503020204020204" charset="-122"/>
-                <a:ea typeface="微软雅黑" panose="020B0503020204020204" charset="-122"/>
-              </a:rPr>
-              <a:t> AI </a:t>
-            </a:r>
-            <a:r>
-              <a:rPr lang="zh-CN" sz="1050">
-                <a:solidFill>
-                  <a:srgbClr val="888888"/>
-                </a:solidFill>
-                <a:latin typeface="微软雅黑" panose="020B0503020204020204" charset="-122"/>
-                <a:ea typeface="微软雅黑" panose="020B0503020204020204" charset="-122"/>
-              </a:rPr>
-              <a:t>工作复盘</a:t>
-            </a:r>
-            <a:endParaRPr lang="zh-CN" sz="1050">
-              <a:solidFill>
-                <a:srgbClr val="888888"/>
-              </a:solidFill>
-              <a:latin typeface="微软雅黑" panose="020B0503020204020204" charset="-122"/>
-              <a:ea typeface="微软雅黑" panose="020B0503020204020204" charset="-122"/>
-            </a:endParaRPr>
-          </a:p>
-        </p:txBody>
-      </p:sp>
-      <p:sp>
-        <p:nvSpPr>
-          <p:cNvPr id="29" name="文本框 28" descr="{&quot;isTemplate&quot;:true,&quot;type&quot;:&quot;text&quot;}"/>
-          <p:cNvSpPr txBox="1"/>
-          <p:nvPr/>
-        </p:nvSpPr>
-        <p:spPr>
-          <a:xfrm>
-            <a:off x="11229975" y="6362700"/>
-            <a:ext cx="428625" cy="161925"/>
-          </a:xfrm>
-          <a:prstGeom prst="rect">
-            <a:avLst/>
-          </a:prstGeom>
-        </p:spPr>
-        <p:txBody>
-          <a:bodyPr wrap="none" lIns="0" tIns="0" rIns="0" bIns="0"/>
-          <a:p>
-            <a:pPr>
-              <a:lnSpc>
-                <a:spcPct val="100000"/>
-              </a:lnSpc>
-            </a:pPr>
-            <a:r>
-              <a:rPr lang="en-US" sz="1050">
-                <a:solidFill>
-                  <a:srgbClr val="888888"/>
-                </a:solidFill>
-                <a:latin typeface="微软雅黑" panose="020B0503020204020204" charset="-122"/>
-                <a:ea typeface="微软雅黑" panose="020B0503020204020204" charset="-122"/>
-              </a:rPr>
-              <a:t>10 / 13</a:t>
-            </a:r>
-            <a:endParaRPr lang="en-US" sz="1050">
-              <a:solidFill>
-                <a:srgbClr val="888888"/>
-              </a:solidFill>
-              <a:latin typeface="微软雅黑" panose="020B0503020204020204" charset="-122"/>
-              <a:ea typeface="微软雅黑" panose="020B0503020204020204" charset="-122"/>
-            </a:endParaRPr>
-          </a:p>
-        </p:txBody>
-      </p:sp>
-    </p:spTree>
-  </p:cSld>
-  <p:clrMapOvr>
-    <a:masterClrMapping/>
-  </p:clrMapOvr>
-</p:sld>
-</file>
-
-<file path=ppt/slides/slide11.xml><?xml version="1.0" encoding="utf-8"?>
-<p:sld xmlns:a="http://schemas.openxmlformats.org/drawingml/2006/main" xmlns:r="http://schemas.openxmlformats.org/officeDocument/2006/relationships" xmlns:p="http://schemas.openxmlformats.org/presentationml/2006/main">
-  <p:cSld>
-    <p:spTree>
-      <p:nvGrpSpPr>
         <p:cNvPr id="30" name="" descr="&lt;Slide style={{ width:'1280px', height:'720px', position:'relative', background:'#FFFFFF', fontFamily:'微软雅黑' }}&gt;&#10;  &lt;Box style={{ position:'absolute', left:56, top:36, flexDirection:'row', alignItems:'center', gap:12 }}&gt;&#10;    &lt;Box style={{ width:8, height:34, background:'#4472C4' }} /&gt;&#10;    &lt;Text style={{ fontSize:30, fontWeight:'bold', color:'#052B7C' }}&gt;五、智能体矩阵与内容生成&lt;/Text&gt;&#10;  &lt;/Box&gt;&#10;&#10;  &lt;Box style={{ position:'absolute', left:56, top:120, right:56 }}&gt;&#10;    &lt;Table&#10;      style={{ width:'100%', height:440 }}&#10;      defaultTextStyle={{ fontSize:15, textAlign:'center', color:'#1A1A1A' }}&#10;      defaultCellStyle={{ border:{ left:{width:1,color:'#CCCCCC'}, right:{width:1,color:'#CCCCCC'}, top:{width:1,color:'#CCCCCC'}, bottom:{width:1,color:'#CCCCCC'} } }}&#10;      cells={[&#10;        [ {text:'智能体', textStyle:{bold:true,color:'#1A1A1A'}, cellStyle:{background:{color:'#DAE3F3'}}},&#10;          {text:'面向', textStyle:{bold:true,color:'#1A1A1A'}, cellStyle:{background:{color:'#DAE3F3'}}},&#10;          {text:'知识规模', textStyle:{bold:true,color:'#1A1A1A'}, cellStyle:{background:{color:'#DAE3F3'}}},&#10;          {text:'结构规模', textStyle:{bold:true,color:'#1A1A1A'}, cellStyle:{background:{color:'#DAE3F3'}}},&#10;          {text:'状态', textStyle:{bold:true,color:'#1A1A1A'}, cellStyle:{background:{color:'#DAE3F3'}}},&#10;          {text:'核心价值', textStyle:{bold:true,color:'#1A1A1A',textAlign:'left'}, cellStyle:{background:{color:'#DAE3F3'}}} ],&#10;        [ '说明书助手', '销售 / 业务', 'TDS 产品库', '6 模式 / 16 节提示词', '已上线', {text:'TDS 咨询秒级应答、选型有据不误导客户', textStyle:{textAlign:'left'}} ],&#10;        [ '销售 SOP / 全能助手', '销售', '7 份 SOP 源文件', '6 场景触发', '已上线', {text:'销售动作标准化、话术统一、新人即上手', textStyle:{textAlign:'left'}} ],&#10;        [ '业务智能助理', '营销中心 / 业务', 'SKILL.md + templates + role', '3 阶段 / 4 岗位自适应', {text:'迭代中 v5', textStyle:{color:'#C0504D',bold:true}}, {text:'客户问题全流程 AI 化 + 合规红线校验', textStyle:{textAlign:'left'}} ],&#10;        [ '应用工艺助手', '研发为主 + 业务', '工艺手册 + 研发培训', '20+ 疵病排查', '已上线', {text:'染整专业问答、客户质疑标准答案', textStyle:{textAlign:'left'}} ],&#10;      ]}&#10;    /&gt;&#10;  &lt;/Box&gt;&#10;&#10;  &lt;Box style={{ position:'absolute', left:56, top:568, right:56 }}&gt;&#10;    &lt;Text style={{ fontSize:16, color:'#1A1A1A', lineHeight:1.5 }}&gt;另有「培训助手」「视频 / 图片生成助手」等能力，构成平台智能体矩阵；06-12 提出 seedance/seedream 独立化诉求，07-14 图片 · 视频生成独立应用落地（营销 / 销售自助生产素材）。&lt;/Text&gt;&#10;  &lt;/Box&gt;&#10;&#10;  &lt;Box style={{ position:'absolute', left:56, top:668, right:56, flexDirection:'row', justifyContent:'space-between' }}&gt;&#10;    &lt;Text style={{ fontSize:14, color:'#888' }}&gt;入职以来 AI 工作复盘&lt;/Text&gt;&#10;    &lt;Text style={{ fontSize:14, color:'#888' }}&gt;11 / 13&lt;/Text&gt;&#10;  &lt;/Box&gt;&#10;&lt;/Slide&gt;"/>
         <p:cNvGrpSpPr/>
         <p:nvPr/>
@@ -4413,7 +2695,7 @@
 </p:sld>
 </file>
 
-<file path=ppt/slides/slide12.xml><?xml version="1.0" encoding="utf-8"?>
+<file path=ppt/slides/slide11.xml><?xml version="1.0" encoding="utf-8"?>
 <p:sld xmlns:a="http://schemas.openxmlformats.org/drawingml/2006/main" xmlns:r="http://schemas.openxmlformats.org/officeDocument/2006/relationships" xmlns:p="http://schemas.openxmlformats.org/presentationml/2006/main">
   <p:cSld>
     <p:spTree>
@@ -5509,7 +3791,7 @@
 </p:sld>
 </file>
 
-<file path=ppt/slides/slide13.xml><?xml version="1.0" encoding="utf-8"?>
+<file path=ppt/slides/slide12.xml><?xml version="1.0" encoding="utf-8"?>
 <p:sld xmlns:a="http://schemas.openxmlformats.org/drawingml/2006/main" xmlns:r="http://schemas.openxmlformats.org/officeDocument/2006/relationships" xmlns:p="http://schemas.openxmlformats.org/presentationml/2006/main">
   <p:cSld>
     <p:spTree>
@@ -5557,7 +3839,7 @@
         </p:nvSpPr>
         <p:spPr>
           <a:xfrm>
-            <a:off x="0" y="2857500"/>
+            <a:off x="0" y="2019300"/>
             <a:ext cx="12192000" cy="2190750"/>
           </a:xfrm>
           <a:prstGeom prst="rect">
@@ -5580,7 +3862,7 @@
         </p:nvSpPr>
         <p:spPr>
           <a:xfrm>
-            <a:off x="4762500" y="3400425"/>
+            <a:off x="4762500" y="2562225"/>
             <a:ext cx="2667000" cy="647700"/>
           </a:xfrm>
           <a:prstGeom prst="rect">
@@ -5623,7 +3905,7 @@
         </p:nvSpPr>
         <p:spPr>
           <a:xfrm>
-            <a:off x="4981575" y="4200525"/>
+            <a:off x="4981575" y="3362325"/>
             <a:ext cx="2228850" cy="304800"/>
           </a:xfrm>
           <a:prstGeom prst="rect">
@@ -5651,324 +3933,6 @@
             <a:endParaRPr lang="zh-CN" sz="1950">
               <a:solidFill>
                 <a:srgbClr val="FFFFFF"/>
-              </a:solidFill>
-              <a:latin typeface="微软雅黑" panose="020B0503020204020204" charset="-122"/>
-              <a:ea typeface="微软雅黑" panose="020B0503020204020204" charset="-122"/>
-            </a:endParaRPr>
-          </a:p>
-        </p:txBody>
-      </p:sp>
-      <p:sp>
-        <p:nvSpPr>
-          <p:cNvPr id="71" name="矩形 70"/>
-          <p:cNvSpPr/>
-          <p:nvPr/>
-        </p:nvSpPr>
-        <p:spPr>
-          <a:xfrm>
-            <a:off x="762000" y="1228725"/>
-            <a:ext cx="457200" cy="28575"/>
-          </a:xfrm>
-          <a:prstGeom prst="rect">
-            <a:avLst/>
-          </a:prstGeom>
-          <a:solidFill>
-            <a:srgbClr val="4472C4"/>
-          </a:solidFill>
-        </p:spPr>
-        <p:txBody>
-          <a:bodyPr/>
-          <a:p/>
-        </p:txBody>
-      </p:sp>
-      <p:sp>
-        <p:nvSpPr>
-          <p:cNvPr id="72" name="文本框 71" descr="{&quot;isTemplate&quot;:true,&quot;type&quot;:&quot;text&quot;}"/>
-          <p:cNvSpPr txBox="1"/>
-          <p:nvPr/>
-        </p:nvSpPr>
-        <p:spPr>
-          <a:xfrm>
-            <a:off x="1333500" y="1143000"/>
-            <a:ext cx="1524000" cy="190500"/>
-          </a:xfrm>
-          <a:prstGeom prst="rect">
-            <a:avLst/>
-          </a:prstGeom>
-        </p:spPr>
-        <p:txBody>
-          <a:bodyPr wrap="none" lIns="0" tIns="0" rIns="0" bIns="0"/>
-          <a:p>
-            <a:pPr>
-              <a:lnSpc>
-                <a:spcPct val="100000"/>
-              </a:lnSpc>
-            </a:pPr>
-            <a:r>
-              <a:rPr lang="zh-CN" sz="1200">
-                <a:solidFill>
-                  <a:srgbClr val="052B7C"/>
-                </a:solidFill>
-                <a:latin typeface="微软雅黑" panose="020B0503020204020204" charset="-122"/>
-                <a:ea typeface="微软雅黑" panose="020B0503020204020204" charset="-122"/>
-              </a:rPr>
-              <a:t>助力企业利润持续增长</a:t>
-            </a:r>
-            <a:endParaRPr lang="zh-CN" sz="1200">
-              <a:solidFill>
-                <a:srgbClr val="052B7C"/>
-              </a:solidFill>
-              <a:latin typeface="微软雅黑" panose="020B0503020204020204" charset="-122"/>
-              <a:ea typeface="微软雅黑" panose="020B0503020204020204" charset="-122"/>
-            </a:endParaRPr>
-          </a:p>
-        </p:txBody>
-      </p:sp>
-      <p:sp>
-        <p:nvSpPr>
-          <p:cNvPr id="73" name="文本框 72" descr="{&quot;isTemplate&quot;:true,&quot;type&quot;:&quot;text&quot;}"/>
-          <p:cNvSpPr txBox="1"/>
-          <p:nvPr/>
-        </p:nvSpPr>
-        <p:spPr>
-          <a:xfrm>
-            <a:off x="762000" y="5524500"/>
-            <a:ext cx="3781425" cy="209550"/>
-          </a:xfrm>
-          <a:prstGeom prst="rect">
-            <a:avLst/>
-          </a:prstGeom>
-        </p:spPr>
-        <p:txBody>
-          <a:bodyPr wrap="none" lIns="0" tIns="0" rIns="0" bIns="0"/>
-          <a:p>
-            <a:pPr>
-              <a:lnSpc>
-                <a:spcPct val="100000"/>
-              </a:lnSpc>
-            </a:pPr>
-            <a:r>
-              <a:rPr lang="zh-CN" sz="1350">
-                <a:solidFill>
-                  <a:srgbClr val="052B7C"/>
-                </a:solidFill>
-                <a:latin typeface="微软雅黑" panose="020B0503020204020204" charset="-122"/>
-                <a:ea typeface="微软雅黑" panose="020B0503020204020204" charset="-122"/>
-              </a:rPr>
-              <a:t>部　　门：</a:t>
-            </a:r>
-            <a:r>
-              <a:rPr lang="en-US" sz="1350">
-                <a:solidFill>
-                  <a:srgbClr val="052B7C"/>
-                </a:solidFill>
-                <a:latin typeface="微软雅黑" panose="020B0503020204020204" charset="-122"/>
-                <a:ea typeface="微软雅黑" panose="020B0503020204020204" charset="-122"/>
-              </a:rPr>
-              <a:t>AI </a:t>
-            </a:r>
-            <a:r>
-              <a:rPr lang="zh-CN" sz="1350">
-                <a:solidFill>
-                  <a:srgbClr val="052B7C"/>
-                </a:solidFill>
-                <a:latin typeface="微软雅黑" panose="020B0503020204020204" charset="-122"/>
-                <a:ea typeface="微软雅黑" panose="020B0503020204020204" charset="-122"/>
-              </a:rPr>
-              <a:t>技术专员（宏昊</a:t>
-            </a:r>
-            <a:r>
-              <a:rPr lang="en-US" sz="1350">
-                <a:solidFill>
-                  <a:srgbClr val="052B7C"/>
-                </a:solidFill>
-                <a:latin typeface="微软雅黑" panose="020B0503020204020204" charset="-122"/>
-                <a:ea typeface="微软雅黑" panose="020B0503020204020204" charset="-122"/>
-              </a:rPr>
-              <a:t>AI</a:t>
-            </a:r>
-            <a:r>
-              <a:rPr lang="zh-CN" sz="1350">
-                <a:solidFill>
-                  <a:srgbClr val="052B7C"/>
-                </a:solidFill>
-                <a:latin typeface="微软雅黑" panose="020B0503020204020204" charset="-122"/>
-                <a:ea typeface="微软雅黑" panose="020B0503020204020204" charset="-122"/>
-              </a:rPr>
-              <a:t>助手平台）</a:t>
-            </a:r>
-            <a:endParaRPr lang="zh-CN" sz="1350">
-              <a:solidFill>
-                <a:srgbClr val="052B7C"/>
-              </a:solidFill>
-              <a:latin typeface="微软雅黑" panose="020B0503020204020204" charset="-122"/>
-              <a:ea typeface="微软雅黑" panose="020B0503020204020204" charset="-122"/>
-            </a:endParaRPr>
-          </a:p>
-        </p:txBody>
-      </p:sp>
-      <p:sp>
-        <p:nvSpPr>
-          <p:cNvPr id="74" name="文本框 73" descr="{&quot;isTemplate&quot;:true,&quot;type&quot;:&quot;text&quot;}"/>
-          <p:cNvSpPr txBox="1"/>
-          <p:nvPr/>
-        </p:nvSpPr>
-        <p:spPr>
-          <a:xfrm>
-            <a:off x="762000" y="5829300"/>
-            <a:ext cx="3781425" cy="209550"/>
-          </a:xfrm>
-          <a:prstGeom prst="rect">
-            <a:avLst/>
-          </a:prstGeom>
-        </p:spPr>
-        <p:txBody>
-          <a:bodyPr wrap="none" lIns="0" tIns="0" rIns="0" bIns="0"/>
-          <a:p>
-            <a:pPr>
-              <a:lnSpc>
-                <a:spcPct val="100000"/>
-              </a:lnSpc>
-            </a:pPr>
-            <a:r>
-              <a:rPr lang="zh-CN" sz="1350">
-                <a:solidFill>
-                  <a:srgbClr val="052B7C"/>
-                </a:solidFill>
-                <a:latin typeface="微软雅黑" panose="020B0503020204020204" charset="-122"/>
-                <a:ea typeface="微软雅黑" panose="020B0503020204020204" charset="-122"/>
-              </a:rPr>
-              <a:t>汇报人：肖聪</a:t>
-            </a:r>
-            <a:endParaRPr lang="zh-CN" sz="1350">
-              <a:solidFill>
-                <a:srgbClr val="052B7C"/>
-              </a:solidFill>
-              <a:latin typeface="微软雅黑" panose="020B0503020204020204" charset="-122"/>
-              <a:ea typeface="微软雅黑" panose="020B0503020204020204" charset="-122"/>
-            </a:endParaRPr>
-          </a:p>
-        </p:txBody>
-      </p:sp>
-      <p:sp>
-        <p:nvSpPr>
-          <p:cNvPr id="75" name="文本框 74" descr="{&quot;isTemplate&quot;:true,&quot;type&quot;:&quot;text&quot;}"/>
-          <p:cNvSpPr txBox="1"/>
-          <p:nvPr/>
-        </p:nvSpPr>
-        <p:spPr>
-          <a:xfrm>
-            <a:off x="762000" y="6134100"/>
-            <a:ext cx="3781425" cy="209550"/>
-          </a:xfrm>
-          <a:prstGeom prst="rect">
-            <a:avLst/>
-          </a:prstGeom>
-        </p:spPr>
-        <p:txBody>
-          <a:bodyPr wrap="none" lIns="0" tIns="0" rIns="0" bIns="0"/>
-          <a:p>
-            <a:pPr>
-              <a:lnSpc>
-                <a:spcPct val="100000"/>
-              </a:lnSpc>
-            </a:pPr>
-            <a:r>
-              <a:rPr lang="zh-CN" sz="1350">
-                <a:solidFill>
-                  <a:srgbClr val="052B7C"/>
-                </a:solidFill>
-                <a:latin typeface="微软雅黑" panose="020B0503020204020204" charset="-122"/>
-                <a:ea typeface="微软雅黑" panose="020B0503020204020204" charset="-122"/>
-              </a:rPr>
-              <a:t>汇报期间：</a:t>
-            </a:r>
-            <a:r>
-              <a:rPr lang="en-US" sz="1350">
-                <a:solidFill>
-                  <a:srgbClr val="052B7C"/>
-                </a:solidFill>
-                <a:latin typeface="微软雅黑" panose="020B0503020204020204" charset="-122"/>
-                <a:ea typeface="微软雅黑" panose="020B0503020204020204" charset="-122"/>
-              </a:rPr>
-              <a:t>2026.04.15 – 2026.07.31</a:t>
-            </a:r>
-            <a:r>
-              <a:rPr lang="zh-CN" sz="1350">
-                <a:solidFill>
-                  <a:srgbClr val="052B7C"/>
-                </a:solidFill>
-                <a:latin typeface="微软雅黑" panose="020B0503020204020204" charset="-122"/>
-                <a:ea typeface="微软雅黑" panose="020B0503020204020204" charset="-122"/>
-              </a:rPr>
-              <a:t>（入职以来）</a:t>
-            </a:r>
-            <a:endParaRPr lang="zh-CN" sz="1350">
-              <a:solidFill>
-                <a:srgbClr val="052B7C"/>
-              </a:solidFill>
-              <a:latin typeface="微软雅黑" panose="020B0503020204020204" charset="-122"/>
-              <a:ea typeface="微软雅黑" panose="020B0503020204020204" charset="-122"/>
-            </a:endParaRPr>
-          </a:p>
-        </p:txBody>
-      </p:sp>
-      <p:sp>
-        <p:nvSpPr>
-          <p:cNvPr id="76" name="文本框 75" descr="{&quot;isTemplate&quot;:true,&quot;type&quot;:&quot;text&quot;}"/>
-          <p:cNvSpPr txBox="1"/>
-          <p:nvPr/>
-        </p:nvSpPr>
-        <p:spPr>
-          <a:xfrm>
-            <a:off x="10591800" y="6096000"/>
-            <a:ext cx="838200" cy="190500"/>
-          </a:xfrm>
-          <a:prstGeom prst="rect">
-            <a:avLst/>
-          </a:prstGeom>
-        </p:spPr>
-        <p:txBody>
-          <a:bodyPr wrap="none" lIns="0" tIns="0" rIns="0" bIns="0"/>
-          <a:p>
-            <a:pPr>
-              <a:lnSpc>
-                <a:spcPct val="100000"/>
-              </a:lnSpc>
-            </a:pPr>
-            <a:r>
-              <a:rPr lang="en-US" sz="1200" b="1">
-                <a:solidFill>
-                  <a:srgbClr val="052B7C"/>
-                </a:solidFill>
-                <a:latin typeface="微软雅黑" panose="020B0503020204020204" charset="-122"/>
-                <a:ea typeface="微软雅黑" panose="020B0503020204020204" charset="-122"/>
-              </a:rPr>
-              <a:t>- </a:t>
-            </a:r>
-            <a:r>
-              <a:rPr lang="zh-CN" sz="1200" b="1">
-                <a:solidFill>
-                  <a:srgbClr val="052B7C"/>
-                </a:solidFill>
-                <a:latin typeface="微软雅黑" panose="020B0503020204020204" charset="-122"/>
-                <a:ea typeface="微软雅黑" panose="020B0503020204020204" charset="-122"/>
-              </a:rPr>
-              <a:t>机密受控</a:t>
-            </a:r>
-            <a:r>
-              <a:rPr lang="en-US" sz="1200" b="1">
-                <a:solidFill>
-                  <a:srgbClr val="052B7C"/>
-                </a:solidFill>
-                <a:latin typeface="微软雅黑" panose="020B0503020204020204" charset="-122"/>
-                <a:ea typeface="微软雅黑" panose="020B0503020204020204" charset="-122"/>
-              </a:rPr>
-              <a:t> -</a:t>
-            </a:r>
-            <a:endParaRPr lang="en-US" sz="1200" b="1">
-              <a:solidFill>
-                <a:srgbClr val="052B7C"/>
               </a:solidFill>
               <a:latin typeface="微软雅黑" panose="020B0503020204020204" charset="-122"/>
               <a:ea typeface="微软雅黑" panose="020B0503020204020204" charset="-122"/>
@@ -6762,7 +4726,7 @@
                 <a:latin typeface="微软雅黑" panose="020B0503020204020204" charset="-122"/>
                 <a:ea typeface="微软雅黑" panose="020B0503020204020204" charset="-122"/>
               </a:rPr>
-              <a:t>自研应用</a:t>
+              <a:t>开发应用</a:t>
             </a:r>
             <a:r>
               <a:rPr lang="en-US" sz="1350">
@@ -7957,7 +5921,17 @@
                 <a:latin typeface="微软雅黑" panose="020B0503020204020204" charset="-122"/>
                 <a:ea typeface="微软雅黑" panose="020B0503020204020204" charset="-122"/>
               </a:rPr>
-              <a:t>二、自研应用交付总览</a:t>
+              <a:t>二、</a:t>
+            </a:r>
+            <a:r>
+              <a:rPr lang="zh-CN" sz="2250" b="1">
+                <a:solidFill>
+                  <a:srgbClr val="052B7C"/>
+                </a:solidFill>
+                <a:latin typeface="微软雅黑" panose="020B0503020204020204" charset="-122"/>
+                <a:ea typeface="微软雅黑" panose="020B0503020204020204" charset="-122"/>
+              </a:rPr>
+              <a:t>开发应用交付总览</a:t>
             </a:r>
             <a:endParaRPr lang="zh-CN" sz="2250" b="1">
               <a:solidFill>
@@ -9043,7 +7017,7 @@
                           <a:latin typeface="微软雅黑" panose="020B0503020204020204" charset="-122"/>
                           <a:ea typeface="微软雅黑" panose="020B0503020204020204" charset="-122"/>
                         </a:rPr>
-                        <a:t>纯前端 HTML</a:t>
+                        <a:t>纯前端</a:t>
                       </a:r>
                       <a:endParaRPr sz="1125">
                         <a:solidFill>
@@ -14866,7 +12840,7 @@
   <p:cSld>
     <p:spTree>
       <p:nvGrpSpPr>
-        <p:cNvPr id="221" name="" descr="&lt;Slide style={{ width:'1280px', height:'720px', position:'relative', background:'#FFFFFF', fontFamily:'微软雅黑' }}&gt;&#10;  &lt;Box style={{ position:'absolute', left:56, top:36, flexDirection:'row', alignItems:'center', gap:12 }}&gt;&#10;    &lt;Box style={{ width:8, height:34, background:'#4472C4' }} /&gt;&#10;    &lt;Text style={{ fontSize:30, fontWeight:'bold', color:'#052B7C' }}&gt;四、培训与推广&lt;/Text&gt;&#10;  &lt;/Box&gt;&#10;&#10;  &lt;Box style={{ position:'absolute', left:56, top:120, right:56 }}&gt;&#10;    &lt;Table&#10;      style={{ width:'100%', height:430 }}&#10;      defaultTextStyle={{ fontSize:15, textAlign:'center', color:'#1A1A1A' }}&#10;      defaultCellStyle={{ border:{ left:{width:1,color:'#CCCCCC'}, right:{width:1,color:'#CCCCCC'}, top:{width:1,color:'#CCCCCC'}, bottom:{width:1,color:'#CCCCCC'} } }}&#10;      cells={[&#10;        [ {text:'月份', textStyle:{bold:true,color:'#1A1A1A'}, cellStyle:{background:{color:'#DAE3F3'}}},&#10;          {text:'主导', textStyle:{bold:true,color:'#1A1A1A'}, cellStyle:{background:{color:'#DAE3F3'}}},&#10;          {text:'协助 / 参与', textStyle:{bold:true,color:'#1A1A1A'}, cellStyle:{background:{color:'#DAE3F3'}}},&#10;          {text:'主要培训主题', textStyle:{bold:true,color:'#1A1A1A',textAlign:'left'}, cellStyle:{background:{color:'#DAE3F3'}}} ],&#10;        [ '4 月', '1', '2', {text:'Claude Code + 前后端数据库组内培训(04-30)；协助研发部培训；协助采购部 OpenClaw 部署(04-24)', textStyle:{textAlign:'left'}} ],&#10;        [ '5 月', '1', '3', {text:'AI 小组软件开发流程培训 + 作业(05-08)；参与视频生成 / AI 培训助手 / PBC 培训', textStyle:{textAlign:'left'}} ],&#10;        [ '6 月', '3', '1', {text:'月度培训 ×2（AI 工具推荐 / AI 黑话扫盲）、总经办 mmxCode/codex 培训(06-05)；协助销售五部三合一(06-22)', textStyle:{textAlign:'left'}} ],&#10;        [ '7 月', '1', '0', {text:'船务部 shipping-helper 使用培训(07-24)', textStyle:{textAlign:'left'}} ],&#10;        [ {text:'合计', textStyle:{bold:true}, cellStyle:{background:{color:'#FCE4D6'}}},&#10;          {text:'6', textStyle:{bold:true}, cellStyle:{background:{color:'#FCE4D6'}}},&#10;          {text:'6', textStyle:{bold:true}, cellStyle:{background:{color:'#FCE4D6'}}},&#10;          {text:'12 场，覆盖采购 / 船务 / 销售五部 / 研发 / 总经办等多部门', textStyle:{bold:true,textAlign:'left'}, cellStyle:{background:{color:'#FCE4D6'}}} ],&#10;      ]}&#10;    /&gt;&#10;  &lt;/Box&gt;&#10;&#10;  &lt;Box style={{ position:'absolute', left:56, top:565, right:56 }}&gt;&#10;    &lt;Text style={{ fontSize:16, color:'#1A1A1A', lineHeight:1.5 }}&gt;推广与采纳驱动是交付物产生业务价值的「最后一公里」——培训不止「讲」，更含采纳驱动与内部宣推：06-22 销售五部三合一、07-24 船务部使用培训直接对应两个自研工具的上手落地；价格爬取 Skill 以「回采购培训」巩固自建能力。&lt;/Text&gt;&#10;  &lt;/Box&gt;&#10;&#10;  &lt;Box style={{ position:'absolute', left:56, top:668, right:56, flexDirection:'row', justifyContent:'space-between' }}&gt;&#10;    &lt;Text style={{ fontSize:14, color:'#888' }}&gt;入职以来 AI 工作复盘&lt;/Text&gt;&#10;    &lt;Text style={{ fontSize:14, color:'#888' }}&gt;09 / 13&lt;/Text&gt;&#10;  &lt;/Box&gt;&#10;&lt;/Slide&gt;"/>
+        <p:cNvPr id="12" name="" descr="&lt;Slide style={{ width:'1280px', height:'720px', position:'relative', background:'#FFFFFF', fontFamily:'微软雅黑' }}&gt;&#10;  &lt;Box style={{ position:'absolute', left:56, top:36, flexDirection:'row', alignItems:'center', gap:12 }}&gt;&#10;    &lt;Box style={{ width:8, height:34, background:'#4472C4' }} /&gt;&#10;    &lt;Text style={{ fontSize:30, fontWeight:'bold', color:'#052B7C' }}&gt;五、宏昊AI助手 · 验收运营&lt;/Text&gt;&#10;  &lt;/Box&gt;&#10;&#10;  &lt;Box style={{ position:'absolute', left:56, top:130, right:56, flexDirection:'row', gap:22 }}&gt;&#10;    {[['37','平台验收项'],['19','问题反馈闭环'],['93.3%','6 月单月通过率']].map((c, i) =&gt; (&#10;      &lt;Box key={i} style={{ flex:1, background:'#F4F7FC', borderRadius:10, padding:'22px 18px', alignItems:'center' }}&gt;&#10;        &lt;Text style={{ fontSize:56, fontWeight:'bold', color:'#4472C4' }}&gt;{c[0]}&lt;/Text&gt;&#10;        &lt;Text style={{ fontSize:18, color:'#1A1A1A', marginTop:6 }}&gt;{c[1]}&lt;/Text&gt;&#10;      &lt;/Box&gt;&#10;    ))}&#10;  &lt;/Box&gt;&#10;&#10;  &lt;Box style={{ position:'absolute', left:56, top:300, right:56, background:'#052B7C', borderRadius:10, padding:'16px 22px' }}&gt;&#10;    &lt;Text style={{ fontSize:18, color:'#FFFFFF', lineHeight:1.5 }}&gt;入职以来 &lt;span style={{ fontWeight:'bold' }}&gt;37 项验收 + 19 项问题反馈闭环&lt;/span&gt;，6 月单月通过率 93.3% → 把「供应商交付」变「可度量、可追溯、有退回机制」的质量门槛。&lt;/Text&gt;&#10;  &lt;/Box&gt;&#10;&#10;  &lt;Box style={{ position:'absolute', left:56, top:400, right:56 }}&gt;&#10;    &lt;Table&#10;      style={{ width:'100%', height:230 }}&#10;      defaultTextStyle={{ fontSize:15, textAlign:'center', color:'#1A1A1A' }}&#10;      defaultCellStyle={{ border:{ left:{width:1,color:'#CCCCCC'}, right:{width:1,color:'#CCCCCC'}, top:{width:1,color:'#CCCCCC'}, bottom:{width:1,color:'#CCCCCC'} } }}&#10;      cells={[&#10;        [ {text:'周期', textStyle:{bold:true,color:'#1A1A1A'}, cellStyle:{background:{color:'#DAE3F3'}}},&#10;          {text:'验收产出', textStyle:{bold:true,color:'#1A1A1A'}, cellStyle:{background:{color:'#DAE3F3'}}},&#10;          {text:'问题反馈', textStyle:{bold:true,color:'#1A1A1A'}, cellStyle:{background:{color:'#DAE3F3'}}},&#10;          {text:'通过情况', textStyle:{bold:true,color:'#1A1A1A'}, cellStyle:{background:{color:'#DAE3F3'}}} ],&#10;        [ '4 月', '3 测试 + 2 验收（5 项）', '4', '—' ],&#10;        [ '5 月', '9 项测试验收', '3', '—' ],&#10;        [ '6 月', '15 用例（5 批次）', '8', {text:'14/15 通过（93.3%）', textStyle:{bold:true,color:'#4472C4'}} ],&#10;        [ '7 月（2607）', '5 轮验收（8 项）', '4', '—' ],&#10;      ]}&#10;    /&gt;&#10;  &lt;/Box&gt;&#10;&#10;  &lt;Box style={{ position:'absolute', left:56, top:668, right:56, flexDirection:'row', justifyContent:'space-between' }}&gt;&#10;    &lt;Text style={{ fontSize:14, color:'#888' }}&gt;入职以来 AI 工作复盘&lt;/Text&gt;&#10;    &lt;Text style={{ fontSize:14, color:'#888' }}&gt;10 / 13&lt;/Text&gt;&#10;  &lt;/Box&gt;&#10;&lt;/Slide&gt;"/>
         <p:cNvGrpSpPr/>
         <p:nvPr/>
       </p:nvGrpSpPr>
@@ -14880,7 +12854,7 @@
       </p:grpSpPr>
       <p:sp>
         <p:nvSpPr>
-          <p:cNvPr id="222" name="矩形 221"/>
+          <p:cNvPr id="13" name="矩形 12"/>
           <p:cNvSpPr/>
           <p:nvPr/>
         </p:nvSpPr>
@@ -14903,7 +12877,7 @@
       </p:sp>
       <p:sp>
         <p:nvSpPr>
-          <p:cNvPr id="223" name="矩形 222"/>
+          <p:cNvPr id="14" name="矩形 13"/>
           <p:cNvSpPr/>
           <p:nvPr/>
         </p:nvSpPr>
@@ -14926,14 +12900,14 @@
       </p:sp>
       <p:sp>
         <p:nvSpPr>
-          <p:cNvPr id="224" name="文本框 223" descr="{&quot;isTemplate&quot;:true,&quot;type&quot;:&quot;text&quot;}"/>
+          <p:cNvPr id="15" name="文本框 14" descr="{&quot;isTemplate&quot;:true,&quot;type&quot;:&quot;text&quot;}"/>
           <p:cNvSpPr txBox="1"/>
           <p:nvPr/>
         </p:nvSpPr>
         <p:spPr>
           <a:xfrm>
             <a:off x="723900" y="342900"/>
-            <a:ext cx="2000250" cy="342900"/>
+            <a:ext cx="3467100" cy="342900"/>
           </a:xfrm>
           <a:prstGeom prst="rect">
             <a:avLst/>
@@ -14955,7 +12929,47 @@
                 <a:latin typeface="微软雅黑" panose="020B0503020204020204" charset="-122"/>
                 <a:ea typeface="微软雅黑" panose="020B0503020204020204" charset="-122"/>
               </a:rPr>
-              <a:t>四、培训与推广</a:t>
+              <a:t>四、宏昊</a:t>
+            </a:r>
+            <a:r>
+              <a:rPr lang="en-US" sz="2250" b="1">
+                <a:solidFill>
+                  <a:srgbClr val="052B7C"/>
+                </a:solidFill>
+                <a:latin typeface="微软雅黑" panose="020B0503020204020204" charset="-122"/>
+                <a:ea typeface="微软雅黑" panose="020B0503020204020204" charset="-122"/>
+              </a:rPr>
+              <a:t>AI</a:t>
+            </a:r>
+            <a:r>
+              <a:rPr lang="zh-CN" sz="2250" b="1">
+                <a:solidFill>
+                  <a:srgbClr val="052B7C"/>
+                </a:solidFill>
+                <a:latin typeface="微软雅黑" panose="020B0503020204020204" charset="-122"/>
+                <a:ea typeface="微软雅黑" panose="020B0503020204020204" charset="-122"/>
+              </a:rPr>
+              <a:t>助手</a:t>
+            </a:r>
+            <a:r>
+              <a:rPr lang="en-US" sz="2250" b="1">
+                <a:solidFill>
+                  <a:srgbClr val="052B7C"/>
+                </a:solidFill>
+                <a:latin typeface="微软雅黑" panose="020B0503020204020204" charset="-122"/>
+                <a:ea typeface="微软雅黑" panose="020B0503020204020204" charset="-122"/>
+              </a:rPr>
+              <a:t> · </a:t>
+            </a:r>
+            <a:r>
+              <a:rPr lang="zh-CN" sz="2250" b="1">
+                <a:solidFill>
+                  <a:srgbClr val="052B7C"/>
+                </a:solidFill>
+                <a:latin typeface="微软雅黑" panose="020B0503020204020204" charset="-122"/>
+                <a:ea typeface="微软雅黑" panose="020B0503020204020204" charset="-122"/>
+              </a:rPr>
+              <a:t>验收运营</a:t>
             </a:r>
             <a:endParaRPr lang="zh-CN" sz="2250" b="1">
               <a:solidFill>
@@ -14967,27 +12981,538 @@
           </a:p>
         </p:txBody>
       </p:sp>
+      <p:sp>
+        <p:nvSpPr>
+          <p:cNvPr id="16" name="圆角矩形 15"/>
+          <p:cNvSpPr/>
+          <p:nvPr/>
+        </p:nvSpPr>
+        <p:spPr>
+          <a:xfrm>
+            <a:off x="533400" y="1238250"/>
+            <a:ext cx="3571875" cy="1333500"/>
+          </a:xfrm>
+          <a:prstGeom prst="roundRect">
+            <a:avLst>
+              <a:gd name="adj" fmla="val 7143"/>
+            </a:avLst>
+          </a:prstGeom>
+          <a:solidFill>
+            <a:srgbClr val="F4F7FC"/>
+          </a:solidFill>
+        </p:spPr>
+        <p:txBody>
+          <a:bodyPr/>
+          <a:p/>
+        </p:txBody>
+      </p:sp>
+      <p:sp>
+        <p:nvSpPr>
+          <p:cNvPr id="17" name="文本框 16" descr="{&quot;isTemplate&quot;:true,&quot;type&quot;:&quot;text&quot;}"/>
+          <p:cNvSpPr txBox="1"/>
+          <p:nvPr/>
+        </p:nvSpPr>
+        <p:spPr>
+          <a:xfrm>
+            <a:off x="1981200" y="1447800"/>
+            <a:ext cx="685800" cy="647700"/>
+          </a:xfrm>
+          <a:prstGeom prst="rect">
+            <a:avLst/>
+          </a:prstGeom>
+        </p:spPr>
+        <p:txBody>
+          <a:bodyPr wrap="none" lIns="0" tIns="0" rIns="0" bIns="0"/>
+          <a:p>
+            <a:pPr>
+              <a:lnSpc>
+                <a:spcPct val="100000"/>
+              </a:lnSpc>
+            </a:pPr>
+            <a:r>
+              <a:rPr lang="en-US" sz="4200" b="1">
+                <a:solidFill>
+                  <a:srgbClr val="4472C4"/>
+                </a:solidFill>
+                <a:latin typeface="微软雅黑" panose="020B0503020204020204" charset="-122"/>
+                <a:ea typeface="微软雅黑" panose="020B0503020204020204" charset="-122"/>
+              </a:rPr>
+              <a:t>37</a:t>
+            </a:r>
+            <a:endParaRPr lang="en-US" sz="4200" b="1">
+              <a:solidFill>
+                <a:srgbClr val="4472C4"/>
+              </a:solidFill>
+              <a:latin typeface="微软雅黑" panose="020B0503020204020204" charset="-122"/>
+              <a:ea typeface="微软雅黑" panose="020B0503020204020204" charset="-122"/>
+            </a:endParaRPr>
+          </a:p>
+        </p:txBody>
+      </p:sp>
+      <p:sp>
+        <p:nvSpPr>
+          <p:cNvPr id="18" name="文本框 17" descr="{&quot;isTemplate&quot;:true,&quot;type&quot;:&quot;text&quot;}"/>
+          <p:cNvSpPr txBox="1"/>
+          <p:nvPr/>
+        </p:nvSpPr>
+        <p:spPr>
+          <a:xfrm>
+            <a:off x="1895475" y="2152650"/>
+            <a:ext cx="857250" cy="209550"/>
+          </a:xfrm>
+          <a:prstGeom prst="rect">
+            <a:avLst/>
+          </a:prstGeom>
+        </p:spPr>
+        <p:txBody>
+          <a:bodyPr wrap="none" lIns="0" tIns="0" rIns="0" bIns="0"/>
+          <a:p>
+            <a:pPr>
+              <a:lnSpc>
+                <a:spcPct val="100000"/>
+              </a:lnSpc>
+            </a:pPr>
+            <a:r>
+              <a:rPr lang="zh-CN" sz="1350">
+                <a:solidFill>
+                  <a:srgbClr val="1A1A1A"/>
+                </a:solidFill>
+                <a:latin typeface="微软雅黑" panose="020B0503020204020204" charset="-122"/>
+                <a:ea typeface="微软雅黑" panose="020B0503020204020204" charset="-122"/>
+              </a:rPr>
+              <a:t>平台验收项</a:t>
+            </a:r>
+            <a:endParaRPr lang="zh-CN" sz="1350">
+              <a:solidFill>
+                <a:srgbClr val="1A1A1A"/>
+              </a:solidFill>
+              <a:latin typeface="微软雅黑" panose="020B0503020204020204" charset="-122"/>
+              <a:ea typeface="微软雅黑" panose="020B0503020204020204" charset="-122"/>
+            </a:endParaRPr>
+          </a:p>
+        </p:txBody>
+      </p:sp>
+      <p:sp>
+        <p:nvSpPr>
+          <p:cNvPr id="19" name="圆角矩形 18"/>
+          <p:cNvSpPr/>
+          <p:nvPr/>
+        </p:nvSpPr>
+        <p:spPr>
+          <a:xfrm>
+            <a:off x="4314825" y="1238250"/>
+            <a:ext cx="3562350" cy="1333500"/>
+          </a:xfrm>
+          <a:prstGeom prst="roundRect">
+            <a:avLst>
+              <a:gd name="adj" fmla="val 7143"/>
+            </a:avLst>
+          </a:prstGeom>
+          <a:solidFill>
+            <a:srgbClr val="F4F7FC"/>
+          </a:solidFill>
+        </p:spPr>
+        <p:txBody>
+          <a:bodyPr/>
+          <a:p/>
+        </p:txBody>
+      </p:sp>
+      <p:sp>
+        <p:nvSpPr>
+          <p:cNvPr id="20" name="文本框 19" descr="{&quot;isTemplate&quot;:true,&quot;type&quot;:&quot;text&quot;}"/>
+          <p:cNvSpPr txBox="1"/>
+          <p:nvPr/>
+        </p:nvSpPr>
+        <p:spPr>
+          <a:xfrm>
+            <a:off x="5753100" y="1447800"/>
+            <a:ext cx="685800" cy="647700"/>
+          </a:xfrm>
+          <a:prstGeom prst="rect">
+            <a:avLst/>
+          </a:prstGeom>
+        </p:spPr>
+        <p:txBody>
+          <a:bodyPr wrap="none" lIns="0" tIns="0" rIns="0" bIns="0"/>
+          <a:p>
+            <a:pPr>
+              <a:lnSpc>
+                <a:spcPct val="100000"/>
+              </a:lnSpc>
+            </a:pPr>
+            <a:r>
+              <a:rPr lang="en-US" sz="4200" b="1">
+                <a:solidFill>
+                  <a:srgbClr val="4472C4"/>
+                </a:solidFill>
+                <a:latin typeface="微软雅黑" panose="020B0503020204020204" charset="-122"/>
+                <a:ea typeface="微软雅黑" panose="020B0503020204020204" charset="-122"/>
+              </a:rPr>
+              <a:t>19</a:t>
+            </a:r>
+            <a:endParaRPr lang="en-US" sz="4200" b="1">
+              <a:solidFill>
+                <a:srgbClr val="4472C4"/>
+              </a:solidFill>
+              <a:latin typeface="微软雅黑" panose="020B0503020204020204" charset="-122"/>
+              <a:ea typeface="微软雅黑" panose="020B0503020204020204" charset="-122"/>
+            </a:endParaRPr>
+          </a:p>
+        </p:txBody>
+      </p:sp>
+      <p:sp>
+        <p:nvSpPr>
+          <p:cNvPr id="21" name="文本框 20" descr="{&quot;isTemplate&quot;:true,&quot;type&quot;:&quot;text&quot;}"/>
+          <p:cNvSpPr txBox="1"/>
+          <p:nvPr/>
+        </p:nvSpPr>
+        <p:spPr>
+          <a:xfrm>
+            <a:off x="5581650" y="2152650"/>
+            <a:ext cx="1028700" cy="209550"/>
+          </a:xfrm>
+          <a:prstGeom prst="rect">
+            <a:avLst/>
+          </a:prstGeom>
+        </p:spPr>
+        <p:txBody>
+          <a:bodyPr wrap="none" lIns="0" tIns="0" rIns="0" bIns="0"/>
+          <a:p>
+            <a:pPr>
+              <a:lnSpc>
+                <a:spcPct val="100000"/>
+              </a:lnSpc>
+            </a:pPr>
+            <a:r>
+              <a:rPr lang="zh-CN" sz="1350">
+                <a:solidFill>
+                  <a:srgbClr val="1A1A1A"/>
+                </a:solidFill>
+                <a:latin typeface="微软雅黑" panose="020B0503020204020204" charset="-122"/>
+                <a:ea typeface="微软雅黑" panose="020B0503020204020204" charset="-122"/>
+              </a:rPr>
+              <a:t>问题反馈闭环</a:t>
+            </a:r>
+            <a:endParaRPr lang="zh-CN" sz="1350">
+              <a:solidFill>
+                <a:srgbClr val="1A1A1A"/>
+              </a:solidFill>
+              <a:latin typeface="微软雅黑" panose="020B0503020204020204" charset="-122"/>
+              <a:ea typeface="微软雅黑" panose="020B0503020204020204" charset="-122"/>
+            </a:endParaRPr>
+          </a:p>
+        </p:txBody>
+      </p:sp>
+      <p:sp>
+        <p:nvSpPr>
+          <p:cNvPr id="22" name="圆角矩形 21"/>
+          <p:cNvSpPr/>
+          <p:nvPr/>
+        </p:nvSpPr>
+        <p:spPr>
+          <a:xfrm>
+            <a:off x="8086725" y="1238250"/>
+            <a:ext cx="3571875" cy="1333500"/>
+          </a:xfrm>
+          <a:prstGeom prst="roundRect">
+            <a:avLst>
+              <a:gd name="adj" fmla="val 7143"/>
+            </a:avLst>
+          </a:prstGeom>
+          <a:solidFill>
+            <a:srgbClr val="F4F7FC"/>
+          </a:solidFill>
+        </p:spPr>
+        <p:txBody>
+          <a:bodyPr/>
+          <a:p/>
+        </p:txBody>
+      </p:sp>
+      <p:sp>
+        <p:nvSpPr>
+          <p:cNvPr id="23" name="文本框 22" descr="{&quot;isTemplate&quot;:true,&quot;type&quot;:&quot;text&quot;}"/>
+          <p:cNvSpPr txBox="1"/>
+          <p:nvPr/>
+        </p:nvSpPr>
+        <p:spPr>
+          <a:xfrm>
+            <a:off x="8963025" y="1447800"/>
+            <a:ext cx="1828800" cy="647700"/>
+          </a:xfrm>
+          <a:prstGeom prst="rect">
+            <a:avLst/>
+          </a:prstGeom>
+        </p:spPr>
+        <p:txBody>
+          <a:bodyPr wrap="none" lIns="0" tIns="0" rIns="0" bIns="0"/>
+          <a:p>
+            <a:pPr>
+              <a:lnSpc>
+                <a:spcPct val="100000"/>
+              </a:lnSpc>
+            </a:pPr>
+            <a:r>
+              <a:rPr lang="en-US" sz="4200" b="1">
+                <a:solidFill>
+                  <a:srgbClr val="4472C4"/>
+                </a:solidFill>
+                <a:latin typeface="微软雅黑" panose="020B0503020204020204" charset="-122"/>
+                <a:ea typeface="微软雅黑" panose="020B0503020204020204" charset="-122"/>
+              </a:rPr>
+              <a:t>93.3%</a:t>
+            </a:r>
+            <a:endParaRPr lang="en-US" sz="4200" b="1">
+              <a:solidFill>
+                <a:srgbClr val="4472C4"/>
+              </a:solidFill>
+              <a:latin typeface="微软雅黑" panose="020B0503020204020204" charset="-122"/>
+              <a:ea typeface="微软雅黑" panose="020B0503020204020204" charset="-122"/>
+            </a:endParaRPr>
+          </a:p>
+        </p:txBody>
+      </p:sp>
+      <p:sp>
+        <p:nvSpPr>
+          <p:cNvPr id="24" name="文本框 23" descr="{&quot;isTemplate&quot;:true,&quot;type&quot;:&quot;text&quot;}"/>
+          <p:cNvSpPr txBox="1"/>
+          <p:nvPr/>
+        </p:nvSpPr>
+        <p:spPr>
+          <a:xfrm>
+            <a:off x="9286875" y="2152650"/>
+            <a:ext cx="1181100" cy="209550"/>
+          </a:xfrm>
+          <a:prstGeom prst="rect">
+            <a:avLst/>
+          </a:prstGeom>
+        </p:spPr>
+        <p:txBody>
+          <a:bodyPr wrap="none" lIns="0" tIns="0" rIns="0" bIns="0"/>
+          <a:p>
+            <a:pPr>
+              <a:lnSpc>
+                <a:spcPct val="100000"/>
+              </a:lnSpc>
+            </a:pPr>
+            <a:r>
+              <a:rPr lang="en-US" sz="1350">
+                <a:solidFill>
+                  <a:srgbClr val="1A1A1A"/>
+                </a:solidFill>
+                <a:latin typeface="微软雅黑" panose="020B0503020204020204" charset="-122"/>
+                <a:ea typeface="微软雅黑" panose="020B0503020204020204" charset="-122"/>
+              </a:rPr>
+              <a:t>6 </a:t>
+            </a:r>
+            <a:r>
+              <a:rPr lang="zh-CN" sz="1350">
+                <a:solidFill>
+                  <a:srgbClr val="1A1A1A"/>
+                </a:solidFill>
+                <a:latin typeface="微软雅黑" panose="020B0503020204020204" charset="-122"/>
+                <a:ea typeface="微软雅黑" panose="020B0503020204020204" charset="-122"/>
+              </a:rPr>
+              <a:t>月单月通过率</a:t>
+            </a:r>
+            <a:endParaRPr lang="zh-CN" sz="1350">
+              <a:solidFill>
+                <a:srgbClr val="1A1A1A"/>
+              </a:solidFill>
+              <a:latin typeface="微软雅黑" panose="020B0503020204020204" charset="-122"/>
+              <a:ea typeface="微软雅黑" panose="020B0503020204020204" charset="-122"/>
+            </a:endParaRPr>
+          </a:p>
+        </p:txBody>
+      </p:sp>
+      <p:sp>
+        <p:nvSpPr>
+          <p:cNvPr id="25" name="圆角矩形 24"/>
+          <p:cNvSpPr/>
+          <p:nvPr/>
+        </p:nvSpPr>
+        <p:spPr>
+          <a:xfrm>
+            <a:off x="533400" y="2857500"/>
+            <a:ext cx="11125200" cy="619125"/>
+          </a:xfrm>
+          <a:prstGeom prst="roundRect">
+            <a:avLst>
+              <a:gd name="adj" fmla="val 15385"/>
+            </a:avLst>
+          </a:prstGeom>
+          <a:solidFill>
+            <a:srgbClr val="052B7C"/>
+          </a:solidFill>
+        </p:spPr>
+        <p:txBody>
+          <a:bodyPr/>
+          <a:p/>
+        </p:txBody>
+      </p:sp>
+      <p:sp>
+        <p:nvSpPr>
+          <p:cNvPr id="26" name="文本框 25" descr="{&quot;isTemplate&quot;:true,&quot;type&quot;:&quot;text&quot;}"/>
+          <p:cNvSpPr txBox="1"/>
+          <p:nvPr/>
+        </p:nvSpPr>
+        <p:spPr>
+          <a:xfrm>
+            <a:off x="742950" y="3009900"/>
+            <a:ext cx="10706100" cy="314325"/>
+          </a:xfrm>
+          <a:prstGeom prst="rect">
+            <a:avLst/>
+          </a:prstGeom>
+        </p:spPr>
+        <p:txBody>
+          <a:bodyPr wrap="none" lIns="0" tIns="0" rIns="0" bIns="0"/>
+          <a:p>
+            <a:pPr>
+              <a:lnSpc>
+                <a:spcPct val="150000"/>
+              </a:lnSpc>
+            </a:pPr>
+            <a:r>
+              <a:rPr lang="zh-CN" sz="1350">
+                <a:solidFill>
+                  <a:srgbClr val="FFFFFF"/>
+                </a:solidFill>
+                <a:latin typeface="微软雅黑" panose="020B0503020204020204" charset="-122"/>
+                <a:ea typeface="微软雅黑" panose="020B0503020204020204" charset="-122"/>
+              </a:rPr>
+              <a:t>入职以来</a:t>
+            </a:r>
+            <a:r>
+              <a:rPr lang="en-US" sz="1350">
+                <a:solidFill>
+                  <a:srgbClr val="FFFFFF"/>
+                </a:solidFill>
+                <a:latin typeface="微软雅黑" panose="020B0503020204020204" charset="-122"/>
+                <a:ea typeface="微软雅黑" panose="020B0503020204020204" charset="-122"/>
+              </a:rPr>
+              <a:t> </a:t>
+            </a:r>
+            <a:r>
+              <a:rPr lang="en-US" sz="1350" b="1">
+                <a:solidFill>
+                  <a:srgbClr val="FFFFFF"/>
+                </a:solidFill>
+                <a:latin typeface="微软雅黑" panose="020B0503020204020204" charset="-122"/>
+                <a:ea typeface="微软雅黑" panose="020B0503020204020204" charset="-122"/>
+              </a:rPr>
+              <a:t>37 </a:t>
+            </a:r>
+            <a:r>
+              <a:rPr lang="zh-CN" sz="1350" b="1">
+                <a:solidFill>
+                  <a:srgbClr val="FFFFFF"/>
+                </a:solidFill>
+                <a:latin typeface="微软雅黑" panose="020B0503020204020204" charset="-122"/>
+                <a:ea typeface="微软雅黑" panose="020B0503020204020204" charset="-122"/>
+              </a:rPr>
+              <a:t>项验收</a:t>
+            </a:r>
+            <a:r>
+              <a:rPr lang="en-US" sz="1350" b="1">
+                <a:solidFill>
+                  <a:srgbClr val="FFFFFF"/>
+                </a:solidFill>
+                <a:latin typeface="微软雅黑" panose="020B0503020204020204" charset="-122"/>
+                <a:ea typeface="微软雅黑" panose="020B0503020204020204" charset="-122"/>
+              </a:rPr>
+              <a:t> + 19 </a:t>
+            </a:r>
+            <a:r>
+              <a:rPr lang="zh-CN" sz="1350" b="1">
+                <a:solidFill>
+                  <a:srgbClr val="FFFFFF"/>
+                </a:solidFill>
+                <a:latin typeface="微软雅黑" panose="020B0503020204020204" charset="-122"/>
+                <a:ea typeface="微软雅黑" panose="020B0503020204020204" charset="-122"/>
+              </a:rPr>
+              <a:t>项问题反馈闭环</a:t>
+            </a:r>
+            <a:r>
+              <a:rPr lang="zh-CN" sz="1350">
+                <a:solidFill>
+                  <a:srgbClr val="FFFFFF"/>
+                </a:solidFill>
+                <a:latin typeface="微软雅黑" panose="020B0503020204020204" charset="-122"/>
+                <a:ea typeface="微软雅黑" panose="020B0503020204020204" charset="-122"/>
+              </a:rPr>
+              <a:t>，</a:t>
+            </a:r>
+            <a:r>
+              <a:rPr lang="en-US" sz="1350">
+                <a:solidFill>
+                  <a:srgbClr val="FFFFFF"/>
+                </a:solidFill>
+                <a:latin typeface="微软雅黑" panose="020B0503020204020204" charset="-122"/>
+                <a:ea typeface="微软雅黑" panose="020B0503020204020204" charset="-122"/>
+              </a:rPr>
+              <a:t>6 </a:t>
+            </a:r>
+            <a:r>
+              <a:rPr lang="zh-CN" sz="1350">
+                <a:solidFill>
+                  <a:srgbClr val="FFFFFF"/>
+                </a:solidFill>
+                <a:latin typeface="微软雅黑" panose="020B0503020204020204" charset="-122"/>
+                <a:ea typeface="微软雅黑" panose="020B0503020204020204" charset="-122"/>
+              </a:rPr>
+              <a:t>月单月通过率</a:t>
+            </a:r>
+            <a:r>
+              <a:rPr lang="en-US" sz="1350">
+                <a:solidFill>
+                  <a:srgbClr val="FFFFFF"/>
+                </a:solidFill>
+                <a:latin typeface="微软雅黑" panose="020B0503020204020204" charset="-122"/>
+                <a:ea typeface="微软雅黑" panose="020B0503020204020204" charset="-122"/>
+              </a:rPr>
+              <a:t> 93.3% → </a:t>
+            </a:r>
+            <a:r>
+              <a:rPr lang="zh-CN" sz="1350">
+                <a:solidFill>
+                  <a:srgbClr val="FFFFFF"/>
+                </a:solidFill>
+                <a:latin typeface="微软雅黑" panose="020B0503020204020204" charset="-122"/>
+                <a:ea typeface="微软雅黑" panose="020B0503020204020204" charset="-122"/>
+              </a:rPr>
+              <a:t>把「供应商交付」变「可度量、可追溯、有退回机制」的质量门槛。</a:t>
+            </a:r>
+            <a:endParaRPr lang="zh-CN" sz="1350">
+              <a:solidFill>
+                <a:srgbClr val="FFFFFF"/>
+              </a:solidFill>
+              <a:latin typeface="微软雅黑" panose="020B0503020204020204" charset="-122"/>
+              <a:ea typeface="微软雅黑" panose="020B0503020204020204" charset="-122"/>
+            </a:endParaRPr>
+          </a:p>
+        </p:txBody>
+      </p:sp>
       <p:graphicFrame>
         <p:nvGraphicFramePr>
-          <p:cNvPr id="225" name="表格 224"/>
+          <p:cNvPr id="27" name="表格 26"/>
           <p:cNvGraphicFramePr/>
           <p:nvPr/>
         </p:nvGraphicFramePr>
         <p:xfrm>
-          <a:off x="533400" y="1143000"/>
-          <a:ext cx="11125200" cy="4095750"/>
+          <a:off x="533400" y="3810000"/>
+          <a:ext cx="11125200" cy="2190750"/>
         </p:xfrm>
         <a:graphic>
           <a:graphicData uri="http://schemas.openxmlformats.org/drawingml/2006/table">
             <a:tbl>
               <a:tblPr/>
               <a:tblGrid>
-                <a:gridCol w="468978"/>
-                <a:gridCol w="468978"/>
-                <a:gridCol w="1025593"/>
-                <a:gridCol w="9161651"/>
+                <a:gridCol w="2249357"/>
+                <a:gridCol w="3790905"/>
+                <a:gridCol w="1511151"/>
+                <a:gridCol w="3573786"/>
               </a:tblGrid>
-              <a:tr h="682625">
+              <a:tr h="438150">
                 <a:tc>
                   <a:txBody>
                     <a:bodyPr wrap="square">
@@ -15007,7 +13532,7 @@
                           <a:latin typeface="微软雅黑" panose="020B0503020204020204" charset="-122"/>
                           <a:ea typeface="微软雅黑" panose="020B0503020204020204" charset="-122"/>
                         </a:rPr>
-                        <a:t>月份</a:t>
+                        <a:t>周期</a:t>
                       </a:r>
                       <a:endParaRPr sz="1125" b="1">
                         <a:solidFill>
@@ -15055,7 +13580,7 @@
                           <a:latin typeface="微软雅黑" panose="020B0503020204020204" charset="-122"/>
                           <a:ea typeface="微软雅黑" panose="020B0503020204020204" charset="-122"/>
                         </a:rPr>
-                        <a:t>主导</a:t>
+                        <a:t>验收产出</a:t>
                       </a:r>
                       <a:endParaRPr sz="1125" b="1">
                         <a:solidFill>
@@ -15103,7 +13628,7 @@
                           <a:latin typeface="微软雅黑" panose="020B0503020204020204" charset="-122"/>
                           <a:ea typeface="微软雅黑" panose="020B0503020204020204" charset="-122"/>
                         </a:rPr>
-                        <a:t>协助 / 参与</a:t>
+                        <a:t>问题反馈</a:t>
                       </a:r>
                       <a:endParaRPr sz="1125" b="1">
                         <a:solidFill>
@@ -15151,7 +13676,7 @@
                           <a:latin typeface="微软雅黑" panose="020B0503020204020204" charset="-122"/>
                           <a:ea typeface="微软雅黑" panose="020B0503020204020204" charset="-122"/>
                         </a:rPr>
-                        <a:t>主要培训主题</a:t>
+                        <a:t>通过情况</a:t>
                       </a:r>
                       <a:endParaRPr sz="1125" b="1">
                         <a:solidFill>
@@ -15181,7 +13706,7 @@
                   </a:tcPr>
                 </a:tc>
               </a:tr>
-              <a:tr h="682625">
+              <a:tr h="438150">
                 <a:tc>
                   <a:txBody>
                     <a:bodyPr wrap="square">
@@ -15246,7 +13771,7 @@
                           <a:latin typeface="微软雅黑" panose="020B0503020204020204" charset="-122"/>
                           <a:ea typeface="微软雅黑" panose="020B0503020204020204" charset="-122"/>
                         </a:rPr>
-                        <a:t>1</a:t>
+                        <a:t>3 测试 + 2 验收（5 项）</a:t>
                       </a:r>
                       <a:endParaRPr sz="1125">
                         <a:solidFill>
@@ -15291,7 +13816,7 @@
                           <a:latin typeface="微软雅黑" panose="020B0503020204020204" charset="-122"/>
                           <a:ea typeface="微软雅黑" panose="020B0503020204020204" charset="-122"/>
                         </a:rPr>
-                        <a:t>2</a:t>
+                        <a:t>4</a:t>
                       </a:r>
                       <a:endParaRPr sz="1125">
                         <a:solidFill>
@@ -15336,7 +13861,7 @@
                           <a:latin typeface="微软雅黑" panose="020B0503020204020204" charset="-122"/>
                           <a:ea typeface="微软雅黑" panose="020B0503020204020204" charset="-122"/>
                         </a:rPr>
-                        <a:t>Claude Code + 前后端数据库组内培训(04-30)；协助研发部培训；协助采购部 OpenClaw 部署(04-24)</a:t>
+                        <a:t>—</a:t>
                       </a:r>
                       <a:endParaRPr sz="1125">
                         <a:solidFill>
@@ -15363,7 +13888,7 @@
                   </a:tcPr>
                 </a:tc>
               </a:tr>
-              <a:tr h="682625">
+              <a:tr h="438150">
                 <a:tc>
                   <a:txBody>
                     <a:bodyPr wrap="square">
@@ -15428,7 +13953,7 @@
                           <a:latin typeface="微软雅黑" panose="020B0503020204020204" charset="-122"/>
                           <a:ea typeface="微软雅黑" panose="020B0503020204020204" charset="-122"/>
                         </a:rPr>
-                        <a:t>1</a:t>
+                        <a:t>9 项测试验收</a:t>
                       </a:r>
                       <a:endParaRPr sz="1125">
                         <a:solidFill>
@@ -15518,7 +14043,7 @@
                           <a:latin typeface="微软雅黑" panose="020B0503020204020204" charset="-122"/>
                           <a:ea typeface="微软雅黑" panose="020B0503020204020204" charset="-122"/>
                         </a:rPr>
-                        <a:t>AI 小组软件开发流程培训 + 作业(05-08)；参与视频生成 / AI 培训助手 / PBC 培训</a:t>
+                        <a:t>—</a:t>
                       </a:r>
                       <a:endParaRPr sz="1125">
                         <a:solidFill>
@@ -15545,7 +14070,7 @@
                   </a:tcPr>
                 </a:tc>
               </a:tr>
-              <a:tr h="682625">
+              <a:tr h="438150">
                 <a:tc>
                   <a:txBody>
                     <a:bodyPr wrap="square">
@@ -15610,7 +14135,7 @@
                           <a:latin typeface="微软雅黑" panose="020B0503020204020204" charset="-122"/>
                           <a:ea typeface="微软雅黑" panose="020B0503020204020204" charset="-122"/>
                         </a:rPr>
-                        <a:t>3</a:t>
+                        <a:t>15 用例（5 批次）</a:t>
                       </a:r>
                       <a:endParaRPr sz="1125">
                         <a:solidFill>
@@ -15655,7 +14180,99 @@
                           <a:latin typeface="微软雅黑" panose="020B0503020204020204" charset="-122"/>
                           <a:ea typeface="微软雅黑" panose="020B0503020204020204" charset="-122"/>
                         </a:rPr>
-                        <a:t>1</a:t>
+                        <a:t>8</a:t>
+                      </a:r>
+                      <a:endParaRPr sz="1125">
+                        <a:solidFill>
+                          <a:srgbClr val="1A1A1A"/>
+                        </a:solidFill>
+                        <a:latin typeface="微软雅黑" panose="020B0503020204020204" charset="-122"/>
+                        <a:ea typeface="微软雅黑" panose="020B0503020204020204" charset="-122"/>
+                      </a:endParaRPr>
+                    </a:p>
+                  </a:txBody>
+                  <a:tcPr marL="0" marR="0" marT="0" marB="0" anchor="ctr">
+                    <a:lnL>
+                      <a:noFill/>
+                    </a:lnL>
+                    <a:lnR>
+                      <a:noFill/>
+                    </a:lnR>
+                    <a:lnT>
+                      <a:noFill/>
+                    </a:lnT>
+                    <a:lnB>
+                      <a:noFill/>
+                    </a:lnB>
+                  </a:tcPr>
+                </a:tc>
+                <a:tc>
+                  <a:txBody>
+                    <a:bodyPr wrap="square">
+                      <a:spAutoFit/>
+                    </a:bodyPr>
+                    <a:p>
+                      <a:pPr marL="114300" marR="114300" algn="l">
+                        <a:lnSpc>
+                          <a:spcPct val="120000"/>
+                        </a:lnSpc>
+                      </a:pPr>
+                      <a:r>
+                        <a:rPr sz="1125" b="1">
+                          <a:solidFill>
+                            <a:srgbClr val="4472C4"/>
+                          </a:solidFill>
+                          <a:latin typeface="微软雅黑" panose="020B0503020204020204" charset="-122"/>
+                          <a:ea typeface="微软雅黑" panose="020B0503020204020204" charset="-122"/>
+                        </a:rPr>
+                        <a:t>14/15 通过（93.3%）</a:t>
+                      </a:r>
+                      <a:endParaRPr sz="1125" b="1">
+                        <a:solidFill>
+                          <a:srgbClr val="4472C4"/>
+                        </a:solidFill>
+                        <a:latin typeface="微软雅黑" panose="020B0503020204020204" charset="-122"/>
+                        <a:ea typeface="微软雅黑" panose="020B0503020204020204" charset="-122"/>
+                      </a:endParaRPr>
+                    </a:p>
+                  </a:txBody>
+                  <a:tcPr marL="0" marR="0" marT="0" marB="0" anchor="ctr">
+                    <a:lnL>
+                      <a:noFill/>
+                    </a:lnL>
+                    <a:lnR>
+                      <a:noFill/>
+                    </a:lnR>
+                    <a:lnT>
+                      <a:noFill/>
+                    </a:lnT>
+                    <a:lnB>
+                      <a:noFill/>
+                    </a:lnB>
+                  </a:tcPr>
+                </a:tc>
+              </a:tr>
+              <a:tr h="438150">
+                <a:tc>
+                  <a:txBody>
+                    <a:bodyPr wrap="square">
+                      <a:spAutoFit/>
+                    </a:bodyPr>
+                    <a:p>
+                      <a:pPr marL="114300" marR="114300" algn="l">
+                        <a:lnSpc>
+                          <a:spcPct val="120000"/>
+                        </a:lnSpc>
+                      </a:pPr>
+                      <a:r>
+                        <a:rPr sz="1125">
+                          <a:solidFill>
+                            <a:srgbClr val="1A1A1A"/>
+                          </a:solidFill>
+                          <a:latin typeface="微软雅黑" panose="020B0503020204020204" charset="-122"/>
+                          <a:ea typeface="微软雅黑" panose="020B0503020204020204" charset="-122"/>
+                        </a:rPr>
+                        <a:t>7 月（2607）</a:t>
                       </a:r>
                       <a:endParaRPr sz="1125">
                         <a:solidFill>
@@ -15700,54 +14317,7 @@
                           <a:latin typeface="微软雅黑" panose="020B0503020204020204" charset="-122"/>
                           <a:ea typeface="微软雅黑" panose="020B0503020204020204" charset="-122"/>
                         </a:rPr>
-                        <a:t>月度培训 ×2（AI 工具推荐 / AI 黑话扫盲）、总经办 mmxCode/codex 培训(06-05)；协助销售五部三合一(06-22)</a:t>
-                      </a:r>
-                      <a:endParaRPr sz="1125">
-                        <a:solidFill>
-                          <a:srgbClr val="1A1A1A"/>
-                        </a:solidFill>
-                        <a:latin typeface="微软雅黑" panose="020B0503020204020204" charset="-122"/>
-                        <a:ea typeface="微软雅黑" panose="020B0503020204020204" charset="-122"/>
-                      </a:endParaRPr>
-                    </a:p>
-                  </a:txBody>
-                  <a:tcPr marL="0" marR="0" marT="0" marB="0" anchor="ctr">
-                    <a:lnL>
-                      <a:noFill/>
-                    </a:lnL>
-                    <a:lnR>
-                      <a:noFill/>
-                    </a:lnR>
-                    <a:lnT>
-                      <a:noFill/>
-                    </a:lnT>
-                    <a:lnB>
-                      <a:noFill/>
-                    </a:lnB>
-                  </a:tcPr>
-                </a:tc>
-              </a:tr>
-              <a:tr h="682625">
-                <a:tc>
-                  <a:txBody>
-                    <a:bodyPr wrap="square">
-                      <a:spAutoFit/>
-                    </a:bodyPr>
-                    <a:p>
-                      <a:pPr marL="114300" marR="114300" algn="l">
-                        <a:lnSpc>
-                          <a:spcPct val="120000"/>
-                        </a:lnSpc>
-                      </a:pPr>
-                      <a:r>
-                        <a:rPr sz="1125">
-                          <a:solidFill>
-                            <a:srgbClr val="1A1A1A"/>
-                          </a:solidFill>
-                          <a:latin typeface="微软雅黑" panose="020B0503020204020204" charset="-122"/>
-                          <a:ea typeface="微软雅黑" panose="020B0503020204020204" charset="-122"/>
-                        </a:rPr>
-                        <a:t>7 月</a:t>
+                        <a:t>5 轮验收（8 项）</a:t>
                       </a:r>
                       <a:endParaRPr sz="1125">
                         <a:solidFill>
@@ -15792,7 +14362,7 @@
                           <a:latin typeface="微软雅黑" panose="020B0503020204020204" charset="-122"/>
                           <a:ea typeface="微软雅黑" panose="020B0503020204020204" charset="-122"/>
                         </a:rPr>
-                        <a:t>1</a:t>
+                        <a:t>4</a:t>
                       </a:r>
                       <a:endParaRPr sz="1125">
                         <a:solidFill>
@@ -15837,7 +14407,7 @@
                           <a:latin typeface="微软雅黑" panose="020B0503020204020204" charset="-122"/>
                           <a:ea typeface="微软雅黑" panose="020B0503020204020204" charset="-122"/>
                         </a:rPr>
-                        <a:t>0</a:t>
+                        <a:t>—</a:t>
                       </a:r>
                       <a:endParaRPr sz="1125">
                         <a:solidFill>
@@ -15863,245 +14433,6 @@
                     </a:lnB>
                   </a:tcPr>
                 </a:tc>
-                <a:tc>
-                  <a:txBody>
-                    <a:bodyPr wrap="square">
-                      <a:spAutoFit/>
-                    </a:bodyPr>
-                    <a:p>
-                      <a:pPr marL="114300" marR="114300" algn="l">
-                        <a:lnSpc>
-                          <a:spcPct val="120000"/>
-                        </a:lnSpc>
-                      </a:pPr>
-                      <a:r>
-                        <a:rPr sz="1125">
-                          <a:solidFill>
-                            <a:srgbClr val="1A1A1A"/>
-                          </a:solidFill>
-                          <a:latin typeface="微软雅黑" panose="020B0503020204020204" charset="-122"/>
-                          <a:ea typeface="微软雅黑" panose="020B0503020204020204" charset="-122"/>
-                        </a:rPr>
-                        <a:t>船务部 shipping-helper 使用培训(07-24)</a:t>
-                      </a:r>
-                      <a:endParaRPr sz="1125">
-                        <a:solidFill>
-                          <a:srgbClr val="1A1A1A"/>
-                        </a:solidFill>
-                        <a:latin typeface="微软雅黑" panose="020B0503020204020204" charset="-122"/>
-                        <a:ea typeface="微软雅黑" panose="020B0503020204020204" charset="-122"/>
-                      </a:endParaRPr>
-                    </a:p>
-                  </a:txBody>
-                  <a:tcPr marL="0" marR="0" marT="0" marB="0" anchor="ctr">
-                    <a:lnL>
-                      <a:noFill/>
-                    </a:lnL>
-                    <a:lnR>
-                      <a:noFill/>
-                    </a:lnR>
-                    <a:lnT>
-                      <a:noFill/>
-                    </a:lnT>
-                    <a:lnB>
-                      <a:noFill/>
-                    </a:lnB>
-                  </a:tcPr>
-                </a:tc>
-              </a:tr>
-              <a:tr h="682625">
-                <a:tc>
-                  <a:txBody>
-                    <a:bodyPr wrap="square">
-                      <a:spAutoFit/>
-                    </a:bodyPr>
-                    <a:p>
-                      <a:pPr marL="114300" marR="114300" algn="l">
-                        <a:lnSpc>
-                          <a:spcPct val="120000"/>
-                        </a:lnSpc>
-                      </a:pPr>
-                      <a:r>
-                        <a:rPr sz="1125" b="1">
-                          <a:solidFill>
-                            <a:srgbClr val="1A1A1A"/>
-                          </a:solidFill>
-                          <a:latin typeface="微软雅黑" panose="020B0503020204020204" charset="-122"/>
-                          <a:ea typeface="微软雅黑" panose="020B0503020204020204" charset="-122"/>
-                        </a:rPr>
-                        <a:t>合计</a:t>
-                      </a:r>
-                      <a:endParaRPr sz="1125" b="1">
-                        <a:solidFill>
-                          <a:srgbClr val="1A1A1A"/>
-                        </a:solidFill>
-                        <a:latin typeface="微软雅黑" panose="020B0503020204020204" charset="-122"/>
-                        <a:ea typeface="微软雅黑" panose="020B0503020204020204" charset="-122"/>
-                      </a:endParaRPr>
-                    </a:p>
-                  </a:txBody>
-                  <a:tcPr marL="0" marR="0" marT="0" marB="0" anchor="ctr">
-                    <a:lnL>
-                      <a:noFill/>
-                    </a:lnL>
-                    <a:lnR>
-                      <a:noFill/>
-                    </a:lnR>
-                    <a:lnT>
-                      <a:noFill/>
-                    </a:lnT>
-                    <a:lnB>
-                      <a:noFill/>
-                    </a:lnB>
-                    <a:solidFill>
-                      <a:srgbClr val="FCE4D6"/>
-                    </a:solidFill>
-                  </a:tcPr>
-                </a:tc>
-                <a:tc>
-                  <a:txBody>
-                    <a:bodyPr wrap="square">
-                      <a:spAutoFit/>
-                    </a:bodyPr>
-                    <a:p>
-                      <a:pPr marL="114300" marR="114300" algn="l">
-                        <a:lnSpc>
-                          <a:spcPct val="120000"/>
-                        </a:lnSpc>
-                      </a:pPr>
-                      <a:r>
-                        <a:rPr sz="1125" b="1">
-                          <a:solidFill>
-                            <a:srgbClr val="1A1A1A"/>
-                          </a:solidFill>
-                          <a:latin typeface="微软雅黑" panose="020B0503020204020204" charset="-122"/>
-                          <a:ea typeface="微软雅黑" panose="020B0503020204020204" charset="-122"/>
-                        </a:rPr>
-                        <a:t>6</a:t>
-                      </a:r>
-                      <a:endParaRPr sz="1125" b="1">
-                        <a:solidFill>
-                          <a:srgbClr val="1A1A1A"/>
-                        </a:solidFill>
-                        <a:latin typeface="微软雅黑" panose="020B0503020204020204" charset="-122"/>
-                        <a:ea typeface="微软雅黑" panose="020B0503020204020204" charset="-122"/>
-                      </a:endParaRPr>
-                    </a:p>
-                  </a:txBody>
-                  <a:tcPr marL="0" marR="0" marT="0" marB="0" anchor="ctr">
-                    <a:lnL>
-                      <a:noFill/>
-                    </a:lnL>
-                    <a:lnR>
-                      <a:noFill/>
-                    </a:lnR>
-                    <a:lnT>
-                      <a:noFill/>
-                    </a:lnT>
-                    <a:lnB>
-                      <a:noFill/>
-                    </a:lnB>
-                    <a:solidFill>
-                      <a:srgbClr val="FCE4D6"/>
-                    </a:solidFill>
-                  </a:tcPr>
-                </a:tc>
-                <a:tc>
-                  <a:txBody>
-                    <a:bodyPr wrap="square">
-                      <a:spAutoFit/>
-                    </a:bodyPr>
-                    <a:p>
-                      <a:pPr marL="114300" marR="114300" algn="l">
-                        <a:lnSpc>
-                          <a:spcPct val="120000"/>
-                        </a:lnSpc>
-                      </a:pPr>
-                      <a:r>
-                        <a:rPr sz="1125" b="1">
-                          <a:solidFill>
-                            <a:srgbClr val="1A1A1A"/>
-                          </a:solidFill>
-                          <a:latin typeface="微软雅黑" panose="020B0503020204020204" charset="-122"/>
-                          <a:ea typeface="微软雅黑" panose="020B0503020204020204" charset="-122"/>
-                        </a:rPr>
-                        <a:t>6</a:t>
-                      </a:r>
-                      <a:endParaRPr sz="1125" b="1">
-                        <a:solidFill>
-                          <a:srgbClr val="1A1A1A"/>
-                        </a:solidFill>
-                        <a:latin typeface="微软雅黑" panose="020B0503020204020204" charset="-122"/>
-                        <a:ea typeface="微软雅黑" panose="020B0503020204020204" charset="-122"/>
-                      </a:endParaRPr>
-                    </a:p>
-                  </a:txBody>
-                  <a:tcPr marL="0" marR="0" marT="0" marB="0" anchor="ctr">
-                    <a:lnL>
-                      <a:noFill/>
-                    </a:lnL>
-                    <a:lnR>
-                      <a:noFill/>
-                    </a:lnR>
-                    <a:lnT>
-                      <a:noFill/>
-                    </a:lnT>
-                    <a:lnB>
-                      <a:noFill/>
-                    </a:lnB>
-                    <a:solidFill>
-                      <a:srgbClr val="FCE4D6"/>
-                    </a:solidFill>
-                  </a:tcPr>
-                </a:tc>
-                <a:tc>
-                  <a:txBody>
-                    <a:bodyPr wrap="square">
-                      <a:spAutoFit/>
-                    </a:bodyPr>
-                    <a:p>
-                      <a:pPr marL="114300" marR="114300" algn="l">
-                        <a:lnSpc>
-                          <a:spcPct val="120000"/>
-                        </a:lnSpc>
-                      </a:pPr>
-                      <a:r>
-                        <a:rPr sz="1125" b="1">
-                          <a:solidFill>
-                            <a:srgbClr val="1A1A1A"/>
-                          </a:solidFill>
-                          <a:latin typeface="微软雅黑" panose="020B0503020204020204" charset="-122"/>
-                          <a:ea typeface="微软雅黑" panose="020B0503020204020204" charset="-122"/>
-                        </a:rPr>
-                        <a:t>12 场，覆盖采购 / 船务 / 销售五部 / 研发 / 总经办等多部门</a:t>
-                      </a:r>
-                      <a:endParaRPr sz="1125" b="1">
-                        <a:solidFill>
-                          <a:srgbClr val="1A1A1A"/>
-                        </a:solidFill>
-                        <a:latin typeface="微软雅黑" panose="020B0503020204020204" charset="-122"/>
-                        <a:ea typeface="微软雅黑" panose="020B0503020204020204" charset="-122"/>
-                      </a:endParaRPr>
-                    </a:p>
-                  </a:txBody>
-                  <a:tcPr marL="0" marR="0" marT="0" marB="0" anchor="ctr">
-                    <a:lnL>
-                      <a:noFill/>
-                    </a:lnL>
-                    <a:lnR>
-                      <a:noFill/>
-                    </a:lnR>
-                    <a:lnT>
-                      <a:noFill/>
-                    </a:lnT>
-                    <a:lnB>
-                      <a:noFill/>
-                    </a:lnB>
-                    <a:solidFill>
-                      <a:srgbClr val="FCE4D6"/>
-                    </a:solidFill>
-                  </a:tcPr>
-                </a:tc>
               </a:tr>
             </a:tbl>
           </a:graphicData>
@@ -16109,112 +14440,7 @@
       </p:graphicFrame>
       <p:sp>
         <p:nvSpPr>
-          <p:cNvPr id="226" name="文本框 225" descr="{&quot;isTemplate&quot;:true,&quot;type&quot;:&quot;text&quot;}"/>
-          <p:cNvSpPr txBox="1"/>
-          <p:nvPr/>
-        </p:nvSpPr>
-        <p:spPr>
-          <a:xfrm>
-            <a:off x="533400" y="5381625"/>
-            <a:ext cx="11125200" cy="552450"/>
-          </a:xfrm>
-          <a:prstGeom prst="rect">
-            <a:avLst/>
-          </a:prstGeom>
-        </p:spPr>
-        <p:txBody>
-          <a:bodyPr wrap="square" lIns="0" tIns="0" rIns="0" bIns="0">
-            <a:normAutofit/>
-          </a:bodyPr>
-          <a:p>
-            <a:pPr>
-              <a:lnSpc>
-                <a:spcPct val="150000"/>
-              </a:lnSpc>
-            </a:pPr>
-            <a:r>
-              <a:rPr lang="zh-CN" sz="1200">
-                <a:solidFill>
-                  <a:srgbClr val="1A1A1A"/>
-                </a:solidFill>
-                <a:latin typeface="微软雅黑" panose="020B0503020204020204" charset="-122"/>
-                <a:ea typeface="微软雅黑" panose="020B0503020204020204" charset="-122"/>
-              </a:rPr>
-              <a:t>推广与采纳驱动是交付物产生业务价值的「最后一公里」——培训不止「讲」，更含采纳驱动与内部宣推：</a:t>
-            </a:r>
-            <a:r>
-              <a:rPr lang="en-US" sz="1200">
-                <a:solidFill>
-                  <a:srgbClr val="1A1A1A"/>
-                </a:solidFill>
-                <a:latin typeface="微软雅黑" panose="020B0503020204020204" charset="-122"/>
-                <a:ea typeface="微软雅黑" panose="020B0503020204020204" charset="-122"/>
-              </a:rPr>
-              <a:t>06-22 </a:t>
-            </a:r>
-            <a:r>
-              <a:rPr lang="zh-CN" sz="1200">
-                <a:solidFill>
-                  <a:srgbClr val="1A1A1A"/>
-                </a:solidFill>
-                <a:latin typeface="微软雅黑" panose="020B0503020204020204" charset="-122"/>
-                <a:ea typeface="微软雅黑" panose="020B0503020204020204" charset="-122"/>
-              </a:rPr>
-              <a:t>销售五部三合一、</a:t>
-            </a:r>
-            <a:r>
-              <a:rPr lang="en-US" sz="1200">
-                <a:solidFill>
-                  <a:srgbClr val="1A1A1A"/>
-                </a:solidFill>
-                <a:latin typeface="微软雅黑" panose="020B0503020204020204" charset="-122"/>
-                <a:ea typeface="微软雅黑" panose="020B0503020204020204" charset="-122"/>
-              </a:rPr>
-              <a:t>07-24 </a:t>
-            </a:r>
-            <a:r>
-              <a:rPr lang="zh-CN" sz="1200">
-                <a:solidFill>
-                  <a:srgbClr val="1A1A1A"/>
-                </a:solidFill>
-                <a:latin typeface="微软雅黑" panose="020B0503020204020204" charset="-122"/>
-                <a:ea typeface="微软雅黑" panose="020B0503020204020204" charset="-122"/>
-              </a:rPr>
-              <a:t>船务部使用培训直接对应两个自研工具的上手落地；价格爬取</a:t>
-            </a:r>
-            <a:r>
-              <a:rPr lang="en-US" sz="1200">
-                <a:solidFill>
-                  <a:srgbClr val="1A1A1A"/>
-                </a:solidFill>
-                <a:latin typeface="微软雅黑" panose="020B0503020204020204" charset="-122"/>
-                <a:ea typeface="微软雅黑" panose="020B0503020204020204" charset="-122"/>
-              </a:rPr>
-              <a:t> Skill </a:t>
-            </a:r>
-            <a:r>
-              <a:rPr lang="zh-CN" sz="1200">
-                <a:solidFill>
-                  <a:srgbClr val="1A1A1A"/>
-                </a:solidFill>
-                <a:latin typeface="微软雅黑" panose="020B0503020204020204" charset="-122"/>
-                <a:ea typeface="微软雅黑" panose="020B0503020204020204" charset="-122"/>
-              </a:rPr>
-              <a:t>以「回采购培训」巩固自建能力。</a:t>
-            </a:r>
-            <a:endParaRPr lang="zh-CN" sz="1200">
-              <a:solidFill>
-                <a:srgbClr val="1A1A1A"/>
-              </a:solidFill>
-              <a:latin typeface="微软雅黑" panose="020B0503020204020204" charset="-122"/>
-              <a:ea typeface="微软雅黑" panose="020B0503020204020204" charset="-122"/>
-            </a:endParaRPr>
-          </a:p>
-        </p:txBody>
-      </p:sp>
-      <p:sp>
-        <p:nvSpPr>
-          <p:cNvPr id="227" name="文本框 226" descr="{&quot;isTemplate&quot;:true,&quot;type&quot;:&quot;text&quot;}"/>
+          <p:cNvPr id="28" name="文本框 27" descr="{&quot;isTemplate&quot;:true,&quot;type&quot;:&quot;text&quot;}"/>
           <p:cNvSpPr txBox="1"/>
           <p:nvPr/>
         </p:nvSpPr>
@@ -16277,7 +14503,7 @@
       </p:sp>
       <p:sp>
         <p:nvSpPr>
-          <p:cNvPr id="228" name="文本框 227" descr="{&quot;isTemplate&quot;:true,&quot;type&quot;:&quot;text&quot;}"/>
+          <p:cNvPr id="29" name="文本框 28" descr="{&quot;isTemplate&quot;:true,&quot;type&quot;:&quot;text&quot;}"/>
           <p:cNvSpPr txBox="1"/>
           <p:nvPr/>
         </p:nvSpPr>
@@ -16306,7 +14532,7 @@
                 <a:latin typeface="微软雅黑" panose="020B0503020204020204" charset="-122"/>
                 <a:ea typeface="微软雅黑" panose="020B0503020204020204" charset="-122"/>
               </a:rPr>
-              <a:t>09 / 13</a:t>
+              <a:t>10 / 13</a:t>
             </a:r>
             <a:endParaRPr lang="en-US" sz="1050">
               <a:solidFill>

</xml_diff>

<commit_message>
vault backup: 2026-08-18 08:36:40
</commit_message>
<xml_diff>
--- a/PPT/入职以来AI工作复盘/入职以来AI工作复盘.pptx
+++ b/PPT/入职以来AI工作复盘/入职以来AI工作复盘.pptx
@@ -1427,6 +1427,16 @@
                         </a:lnSpc>
                       </a:pPr>
                       <a:r>
+                        <a:rPr lang="zh-CN" sz="1125">
+                          <a:solidFill>
+                            <a:srgbClr val="1A1A1A"/>
+                          </a:solidFill>
+                          <a:latin typeface="微软雅黑" panose="020B0503020204020204" charset="-122"/>
+                          <a:ea typeface="微软雅黑" panose="020B0503020204020204" charset="-122"/>
+                        </a:rPr>
+                        <a:t>目前仅</a:t>
+                      </a:r>
+                      <a:r>
                         <a:rPr sz="1125">
                           <a:solidFill>
                             <a:srgbClr val="1A1A1A"/>
@@ -1434,7 +1444,7 @@
                           <a:latin typeface="微软雅黑" panose="020B0503020204020204" charset="-122"/>
                           <a:ea typeface="微软雅黑" panose="020B0503020204020204" charset="-122"/>
                         </a:rPr>
-                        <a:t>TDS 产品库</a:t>
+                        <a:t>TDS</a:t>
                       </a:r>
                       <a:endParaRPr sz="1125">
                         <a:solidFill>
@@ -1616,7 +1626,7 @@
                           <a:latin typeface="微软雅黑" panose="020B0503020204020204" charset="-122"/>
                           <a:ea typeface="微软雅黑" panose="020B0503020204020204" charset="-122"/>
                         </a:rPr>
-                        <a:t>销售 SOP / 全能助手</a:t>
+                        <a:t>销售 SOP 助手</a:t>
                       </a:r>
                       <a:endParaRPr sz="1125">
                         <a:solidFill>
@@ -1706,7 +1716,7 @@
                           <a:latin typeface="微软雅黑" panose="020B0503020204020204" charset="-122"/>
                           <a:ea typeface="微软雅黑" panose="020B0503020204020204" charset="-122"/>
                         </a:rPr>
-                        <a:t>7 份 SOP 源文件</a:t>
+                        <a:t>SOP 源文件</a:t>
                       </a:r>
                       <a:endParaRPr sz="1125">
                         <a:solidFill>
@@ -2160,7 +2170,27 @@
                           <a:latin typeface="微软雅黑" panose="020B0503020204020204" charset="-122"/>
                           <a:ea typeface="微软雅黑" panose="020B0503020204020204" charset="-122"/>
                         </a:rPr>
-                        <a:t>应用工艺助手</a:t>
+                        <a:t>工艺</a:t>
+                      </a:r>
+                      <a:r>
+                        <a:rPr lang="zh-CN" sz="1125">
+                          <a:solidFill>
+                            <a:srgbClr val="1A1A1A"/>
+                          </a:solidFill>
+                          <a:latin typeface="微软雅黑" panose="020B0503020204020204" charset="-122"/>
+                          <a:ea typeface="微软雅黑" panose="020B0503020204020204" charset="-122"/>
+                        </a:rPr>
+                        <a:t>流程</a:t>
+                      </a:r>
+                      <a:r>
+                        <a:rPr sz="1125">
+                          <a:solidFill>
+                            <a:srgbClr val="1A1A1A"/>
+                          </a:solidFill>
+                          <a:latin typeface="微软雅黑" panose="020B0503020204020204" charset="-122"/>
+                          <a:ea typeface="微软雅黑" panose="020B0503020204020204" charset="-122"/>
+                        </a:rPr>
+                        <a:t>助手</a:t>
                       </a:r>
                       <a:endParaRPr sz="1125">
                         <a:solidFill>
@@ -13500,17 +13530,17 @@
         </p:nvGraphicFramePr>
         <p:xfrm>
           <a:off x="533400" y="3810000"/>
-          <a:ext cx="11125200" cy="2190750"/>
+          <a:ext cx="11094085" cy="2190750"/>
         </p:xfrm>
         <a:graphic>
           <a:graphicData uri="http://schemas.openxmlformats.org/drawingml/2006/table">
             <a:tbl>
               <a:tblPr/>
               <a:tblGrid>
-                <a:gridCol w="2249357"/>
-                <a:gridCol w="3790905"/>
-                <a:gridCol w="1511151"/>
-                <a:gridCol w="3573786"/>
+                <a:gridCol w="1254760"/>
+                <a:gridCol w="1995170"/>
+                <a:gridCol w="1797050"/>
+                <a:gridCol w="6047105"/>
               </a:tblGrid>
               <a:tr h="438150">
                 <a:tc>
@@ -13580,7 +13610,7 @@
                           <a:latin typeface="微软雅黑" panose="020B0503020204020204" charset="-122"/>
                           <a:ea typeface="微软雅黑" panose="020B0503020204020204" charset="-122"/>
                         </a:rPr>
-                        <a:t>验收产出</a:t>
+                        <a:t>问题反馈</a:t>
                       </a:r>
                       <a:endParaRPr sz="1125" b="1">
                         <a:solidFill>
@@ -13611,9 +13641,7 @@
                 </a:tc>
                 <a:tc>
                   <a:txBody>
-                    <a:bodyPr wrap="square">
-                      <a:spAutoFit/>
-                    </a:bodyPr>
+                    <a:bodyPr/>
                     <a:p>
                       <a:pPr marL="114300" marR="114300" algn="l">
                         <a:lnSpc>
@@ -13628,7 +13656,7 @@
                           <a:latin typeface="微软雅黑" panose="020B0503020204020204" charset="-122"/>
                           <a:ea typeface="微软雅黑" panose="020B0503020204020204" charset="-122"/>
                         </a:rPr>
-                        <a:t>问题反馈</a:t>
+                        <a:t>产出</a:t>
                       </a:r>
                       <a:endParaRPr sz="1125" b="1">
                         <a:solidFill>
@@ -13764,16 +13792,89 @@
                         </a:lnSpc>
                       </a:pPr>
                       <a:r>
-                        <a:rPr sz="1125">
+                        <a:rPr lang="en-US" sz="1125">
                           <a:solidFill>
                             <a:srgbClr val="1A1A1A"/>
                           </a:solidFill>
                           <a:latin typeface="微软雅黑" panose="020B0503020204020204" charset="-122"/>
                           <a:ea typeface="微软雅黑" panose="020B0503020204020204" charset="-122"/>
                         </a:rPr>
-                        <a:t>3 测试 + 2 验收（5 项）</a:t>
+                        <a:t>8 </a:t>
                       </a:r>
-                      <a:endParaRPr sz="1125">
+                      <a:r>
+                        <a:rPr lang="zh-CN" altLang="en-US" sz="1125">
+                          <a:solidFill>
+                            <a:srgbClr val="1A1A1A"/>
+                          </a:solidFill>
+                          <a:latin typeface="微软雅黑" panose="020B0503020204020204" charset="-122"/>
+                          <a:ea typeface="微软雅黑" panose="020B0503020204020204" charset="-122"/>
+                        </a:rPr>
+                        <a:t>主要集中在</a:t>
+                      </a:r>
+                      <a:r>
+                        <a:rPr lang="zh-CN" altLang="en-US" sz="1125">
+                          <a:solidFill>
+                            <a:srgbClr val="1A1A1A"/>
+                          </a:solidFill>
+                          <a:latin typeface="微软雅黑" panose="020B0503020204020204" charset="-122"/>
+                          <a:ea typeface="微软雅黑" panose="020B0503020204020204" charset="-122"/>
+                        </a:rPr>
+                        <a:t>培训助手</a:t>
+                      </a:r>
+                      <a:endParaRPr lang="zh-CN" altLang="en-US" sz="1125">
+                        <a:solidFill>
+                          <a:srgbClr val="1A1A1A"/>
+                        </a:solidFill>
+                        <a:latin typeface="微软雅黑" panose="020B0503020204020204" charset="-122"/>
+                        <a:ea typeface="微软雅黑" panose="020B0503020204020204" charset="-122"/>
+                      </a:endParaRPr>
+                    </a:p>
+                  </a:txBody>
+                  <a:tcPr marL="0" marR="0" marT="0" marB="0" anchor="ctr">
+                    <a:lnL>
+                      <a:noFill/>
+                    </a:lnL>
+                    <a:lnR>
+                      <a:noFill/>
+                    </a:lnR>
+                    <a:lnT>
+                      <a:noFill/>
+                    </a:lnT>
+                    <a:lnB>
+                      <a:noFill/>
+                    </a:lnB>
+                  </a:tcPr>
+                </a:tc>
+                <a:tc>
+                  <a:txBody>
+                    <a:bodyPr/>
+                    <a:p>
+                      <a:pPr marL="114300" marR="114300" algn="l">
+                        <a:lnSpc>
+                          <a:spcPct val="120000"/>
+                        </a:lnSpc>
+                      </a:pPr>
+                      <a:r>
+                        <a:rPr lang="en-US" sz="1125">
+                          <a:solidFill>
+                            <a:srgbClr val="1A1A1A"/>
+                          </a:solidFill>
+                          <a:latin typeface="微软雅黑" panose="020B0503020204020204" charset="-122"/>
+                          <a:ea typeface="微软雅黑" panose="020B0503020204020204" charset="-122"/>
+                        </a:rPr>
+                        <a:t>4 </a:t>
+                      </a:r>
+                      <a:r>
+                        <a:rPr lang="zh-CN" altLang="en-US" sz="1125">
+                          <a:solidFill>
+                            <a:srgbClr val="1A1A1A"/>
+                          </a:solidFill>
+                          <a:latin typeface="微软雅黑" panose="020B0503020204020204" charset="-122"/>
+                          <a:ea typeface="微软雅黑" panose="020B0503020204020204" charset="-122"/>
+                        </a:rPr>
+                        <a:t>份测试报告</a:t>
+                      </a:r>
+                      <a:endParaRPr lang="zh-CN" altLang="en-US" sz="1125">
                         <a:solidFill>
                           <a:srgbClr val="1A1A1A"/>
                         </a:solidFill>
@@ -13809,61 +13910,66 @@
                         </a:lnSpc>
                       </a:pPr>
                       <a:r>
-                        <a:rPr sz="1125">
+                        <a:rPr lang="zh-CN" sz="1125">
                           <a:solidFill>
                             <a:srgbClr val="1A1A1A"/>
                           </a:solidFill>
                           <a:latin typeface="微软雅黑" panose="020B0503020204020204" charset="-122"/>
                           <a:ea typeface="微软雅黑" panose="020B0503020204020204" charset="-122"/>
                         </a:rPr>
-                        <a:t>4</a:t>
+                        <a:t>共计</a:t>
                       </a:r>
-                      <a:endParaRPr sz="1125">
-                        <a:solidFill>
-                          <a:srgbClr val="1A1A1A"/>
-                        </a:solidFill>
-                        <a:latin typeface="微软雅黑" panose="020B0503020204020204" charset="-122"/>
-                        <a:ea typeface="微软雅黑" panose="020B0503020204020204" charset="-122"/>
-                      </a:endParaRPr>
-                    </a:p>
-                  </a:txBody>
-                  <a:tcPr marL="0" marR="0" marT="0" marB="0" anchor="ctr">
-                    <a:lnL>
-                      <a:noFill/>
-                    </a:lnL>
-                    <a:lnR>
-                      <a:noFill/>
-                    </a:lnR>
-                    <a:lnT>
-                      <a:noFill/>
-                    </a:lnT>
-                    <a:lnB>
-                      <a:noFill/>
-                    </a:lnB>
-                  </a:tcPr>
-                </a:tc>
-                <a:tc>
-                  <a:txBody>
-                    <a:bodyPr wrap="square">
-                      <a:spAutoFit/>
-                    </a:bodyPr>
-                    <a:p>
-                      <a:pPr marL="114300" marR="114300" algn="l">
-                        <a:lnSpc>
-                          <a:spcPct val="120000"/>
-                        </a:lnSpc>
-                      </a:pPr>
                       <a:r>
-                        <a:rPr sz="1125">
+                        <a:rPr lang="en-US" altLang="zh-CN" sz="1125">
                           <a:solidFill>
                             <a:srgbClr val="1A1A1A"/>
                           </a:solidFill>
                           <a:latin typeface="微软雅黑" panose="020B0503020204020204" charset="-122"/>
                           <a:ea typeface="微软雅黑" panose="020B0503020204020204" charset="-122"/>
                         </a:rPr>
-                        <a:t>—</a:t>
+                        <a:t> 10 </a:t>
                       </a:r>
-                      <a:endParaRPr sz="1125">
+                      <a:r>
+                        <a:rPr lang="zh-CN" altLang="en-US" sz="1125">
+                          <a:solidFill>
+                            <a:srgbClr val="1A1A1A"/>
+                          </a:solidFill>
+                          <a:latin typeface="微软雅黑" panose="020B0503020204020204" charset="-122"/>
+                          <a:ea typeface="微软雅黑" panose="020B0503020204020204" charset="-122"/>
+                        </a:rPr>
+                        <a:t>项，未通过</a:t>
+                      </a:r>
+                      <a:r>
+                        <a:rPr lang="en-US" altLang="zh-CN" sz="1125">
+                          <a:solidFill>
+                            <a:srgbClr val="1A1A1A"/>
+                          </a:solidFill>
+                          <a:latin typeface="微软雅黑" panose="020B0503020204020204" charset="-122"/>
+                          <a:ea typeface="微软雅黑" panose="020B0503020204020204" charset="-122"/>
+                        </a:rPr>
+                        <a:t> 1 </a:t>
+                      </a:r>
+                      <a:r>
+                        <a:rPr lang="zh-CN" altLang="en-US" sz="1125">
+                          <a:solidFill>
+                            <a:srgbClr val="1A1A1A"/>
+                          </a:solidFill>
+                          <a:latin typeface="微软雅黑" panose="020B0503020204020204" charset="-122"/>
+                          <a:ea typeface="微软雅黑" panose="020B0503020204020204" charset="-122"/>
+                        </a:rPr>
+                        <a:t>项（</a:t>
+                      </a:r>
+                      <a:r>
+                        <a:rPr lang="zh-CN" altLang="en-US" sz="1125">
+                          <a:solidFill>
+                            <a:srgbClr val="1A1A1A"/>
+                          </a:solidFill>
+                          <a:latin typeface="微软雅黑" panose="020B0503020204020204" charset="-122"/>
+                          <a:ea typeface="微软雅黑" panose="020B0503020204020204" charset="-122"/>
+                        </a:rPr>
+                        <a:t>视频生成）</a:t>
+                      </a:r>
+                      <a:endParaRPr lang="zh-CN" altLang="en-US" sz="1125">
                         <a:solidFill>
                           <a:srgbClr val="1A1A1A"/>
                         </a:solidFill>
@@ -13953,9 +14059,92 @@
                           <a:latin typeface="微软雅黑" panose="020B0503020204020204" charset="-122"/>
                           <a:ea typeface="微软雅黑" panose="020B0503020204020204" charset="-122"/>
                         </a:rPr>
-                        <a:t>9 项测试验收</a:t>
+                        <a:t>3</a:t>
                       </a:r>
-                      <a:endParaRPr sz="1125">
+                      <a:r>
+                        <a:rPr lang="en-US" sz="1125">
+                          <a:solidFill>
+                            <a:srgbClr val="1A1A1A"/>
+                          </a:solidFill>
+                          <a:latin typeface="微软雅黑" panose="020B0503020204020204" charset="-122"/>
+                          <a:ea typeface="微软雅黑" panose="020B0503020204020204" charset="-122"/>
+                        </a:rPr>
+                        <a:t> </a:t>
+                      </a:r>
+                      <a:r>
+                        <a:rPr lang="zh-CN" altLang="en-US" sz="1125">
+                          <a:solidFill>
+                            <a:srgbClr val="1A1A1A"/>
+                          </a:solidFill>
+                          <a:latin typeface="微软雅黑" panose="020B0503020204020204" charset="-122"/>
+                          <a:ea typeface="微软雅黑" panose="020B0503020204020204" charset="-122"/>
+                        </a:rPr>
+                        <a:t>主要集中在说明书助手</a:t>
+                      </a:r>
+                      <a:endParaRPr lang="zh-CN" altLang="en-US" sz="1125">
+                        <a:solidFill>
+                          <a:srgbClr val="1A1A1A"/>
+                        </a:solidFill>
+                        <a:latin typeface="微软雅黑" panose="020B0503020204020204" charset="-122"/>
+                        <a:ea typeface="微软雅黑" panose="020B0503020204020204" charset="-122"/>
+                      </a:endParaRPr>
+                    </a:p>
+                  </a:txBody>
+                  <a:tcPr marL="0" marR="0" marT="0" marB="0" anchor="ctr">
+                    <a:lnL>
+                      <a:noFill/>
+                    </a:lnL>
+                    <a:lnR>
+                      <a:noFill/>
+                    </a:lnR>
+                    <a:lnT>
+                      <a:noFill/>
+                    </a:lnT>
+                    <a:lnB>
+                      <a:noFill/>
+                    </a:lnB>
+                  </a:tcPr>
+                </a:tc>
+                <a:tc>
+                  <a:txBody>
+                    <a:bodyPr/>
+                    <a:p>
+                      <a:pPr marL="114300" marR="114300" algn="l">
+                        <a:lnSpc>
+                          <a:spcPct val="120000"/>
+                        </a:lnSpc>
+                      </a:pPr>
+                      <a:r>
+                        <a:rPr lang="en-US" sz="1125">
+                          <a:solidFill>
+                            <a:srgbClr val="1A1A1A"/>
+                          </a:solidFill>
+                          <a:latin typeface="微软雅黑" panose="020B0503020204020204" charset="-122"/>
+                          <a:ea typeface="微软雅黑" panose="020B0503020204020204" charset="-122"/>
+                        </a:rPr>
+                        <a:t>9 </a:t>
+                      </a:r>
+                      <a:r>
+                        <a:rPr lang="zh-CN" altLang="en-US" sz="1125">
+                          <a:solidFill>
+                            <a:srgbClr val="1A1A1A"/>
+                          </a:solidFill>
+                          <a:latin typeface="微软雅黑" panose="020B0503020204020204" charset="-122"/>
+                          <a:ea typeface="微软雅黑" panose="020B0503020204020204" charset="-122"/>
+                        </a:rPr>
+                        <a:t>份</a:t>
+                      </a:r>
+                      <a:r>
+                        <a:rPr lang="zh-CN" altLang="en-US" sz="1125">
+                          <a:solidFill>
+                            <a:srgbClr val="1A1A1A"/>
+                          </a:solidFill>
+                          <a:latin typeface="微软雅黑" panose="020B0503020204020204" charset="-122"/>
+                          <a:ea typeface="微软雅黑" panose="020B0503020204020204" charset="-122"/>
+                        </a:rPr>
+                        <a:t>测试报告</a:t>
+                      </a:r>
+                      <a:endParaRPr lang="zh-CN" altLang="en-US" sz="1125">
                         <a:solidFill>
                           <a:srgbClr val="1A1A1A"/>
                         </a:solidFill>
@@ -13991,44 +14180,157 @@
                         </a:lnSpc>
                       </a:pPr>
                       <a:r>
-                        <a:rPr sz="1125">
+                        <a:rPr lang="zh-CN" sz="1125">
                           <a:solidFill>
                             <a:srgbClr val="1A1A1A"/>
                           </a:solidFill>
                           <a:latin typeface="微软雅黑" panose="020B0503020204020204" charset="-122"/>
                           <a:ea typeface="微软雅黑" panose="020B0503020204020204" charset="-122"/>
+                          <a:sym typeface="+mn-ea"/>
                         </a:rPr>
-                        <a:t>3</a:t>
+                        <a:t>共计</a:t>
                       </a:r>
-                      <a:endParaRPr sz="1125">
+                      <a:r>
+                        <a:rPr lang="en-US" altLang="zh-CN" sz="1125">
+                          <a:solidFill>
+                            <a:srgbClr val="1A1A1A"/>
+                          </a:solidFill>
+                          <a:latin typeface="微软雅黑" panose="020B0503020204020204" charset="-122"/>
+                          <a:ea typeface="微软雅黑" panose="020B0503020204020204" charset="-122"/>
+                          <a:sym typeface="+mn-ea"/>
+                        </a:rPr>
+                        <a:t> 176 </a:t>
+                      </a:r>
+                      <a:r>
+                        <a:rPr lang="zh-CN" altLang="en-US" sz="1125">
+                          <a:solidFill>
+                            <a:srgbClr val="1A1A1A"/>
+                          </a:solidFill>
+                          <a:latin typeface="微软雅黑" panose="020B0503020204020204" charset="-122"/>
+                          <a:ea typeface="微软雅黑" panose="020B0503020204020204" charset="-122"/>
+                          <a:sym typeface="+mn-ea"/>
+                        </a:rPr>
+                        <a:t>项（</a:t>
+                      </a:r>
+                      <a:r>
+                        <a:rPr lang="en-US" altLang="zh-CN" sz="1125">
+                          <a:solidFill>
+                            <a:srgbClr val="1A1A1A"/>
+                          </a:solidFill>
+                          <a:latin typeface="微软雅黑" panose="020B0503020204020204" charset="-122"/>
+                          <a:ea typeface="微软雅黑" panose="020B0503020204020204" charset="-122"/>
+                          <a:sym typeface="+mn-ea"/>
+                        </a:rPr>
+                        <a:t> </a:t>
+                      </a:r>
+                      <a:r>
+                        <a:rPr lang="zh-CN" altLang="en-US" sz="1125">
+                          <a:solidFill>
+                            <a:srgbClr val="1A1A1A"/>
+                          </a:solidFill>
+                          <a:latin typeface="微软雅黑" panose="020B0503020204020204" charset="-122"/>
+                          <a:ea typeface="微软雅黑" panose="020B0503020204020204" charset="-122"/>
+                          <a:sym typeface="+mn-ea"/>
+                        </a:rPr>
+                        <a:t>其中：权限模块</a:t>
+                      </a:r>
+                      <a:r>
+                        <a:rPr lang="en-US" altLang="zh-CN" sz="1125">
+                          <a:solidFill>
+                            <a:srgbClr val="1A1A1A"/>
+                          </a:solidFill>
+                          <a:latin typeface="微软雅黑" panose="020B0503020204020204" charset="-122"/>
+                          <a:ea typeface="微软雅黑" panose="020B0503020204020204" charset="-122"/>
+                          <a:sym typeface="+mn-ea"/>
+                        </a:rPr>
+                        <a:t>73</a:t>
+                      </a:r>
+                      <a:r>
+                        <a:rPr lang="zh-CN" altLang="en-US" sz="1125">
+                          <a:solidFill>
+                            <a:srgbClr val="1A1A1A"/>
+                          </a:solidFill>
+                          <a:latin typeface="微软雅黑" panose="020B0503020204020204" charset="-122"/>
+                          <a:ea typeface="微软雅黑" panose="020B0503020204020204" charset="-122"/>
+                          <a:sym typeface="+mn-ea"/>
+                        </a:rPr>
+                        <a:t>项、说明书助手</a:t>
+                      </a:r>
+                      <a:r>
+                        <a:rPr lang="en-US" altLang="zh-CN" sz="1125">
+                          <a:solidFill>
+                            <a:srgbClr val="1A1A1A"/>
+                          </a:solidFill>
+                          <a:latin typeface="微软雅黑" panose="020B0503020204020204" charset="-122"/>
+                          <a:ea typeface="微软雅黑" panose="020B0503020204020204" charset="-122"/>
+                          <a:sym typeface="+mn-ea"/>
+                        </a:rPr>
+                        <a:t>62</a:t>
+                      </a:r>
+                      <a:r>
+                        <a:rPr lang="zh-CN" altLang="en-US" sz="1125">
+                          <a:solidFill>
+                            <a:srgbClr val="1A1A1A"/>
+                          </a:solidFill>
+                          <a:latin typeface="微软雅黑" panose="020B0503020204020204" charset="-122"/>
+                          <a:ea typeface="微软雅黑" panose="020B0503020204020204" charset="-122"/>
+                          <a:sym typeface="+mn-ea"/>
+                        </a:rPr>
+                        <a:t>项、视频生成</a:t>
+                      </a:r>
+                      <a:r>
+                        <a:rPr lang="en-US" altLang="zh-CN" sz="1125">
+                          <a:solidFill>
+                            <a:srgbClr val="1A1A1A"/>
+                          </a:solidFill>
+                          <a:latin typeface="微软雅黑" panose="020B0503020204020204" charset="-122"/>
+                          <a:ea typeface="微软雅黑" panose="020B0503020204020204" charset="-122"/>
+                          <a:sym typeface="+mn-ea"/>
+                        </a:rPr>
+                        <a:t>35</a:t>
+                      </a:r>
+                      <a:r>
+                        <a:rPr lang="zh-CN" altLang="en-US" sz="1125">
+                          <a:solidFill>
+                            <a:srgbClr val="1A1A1A"/>
+                          </a:solidFill>
+                          <a:latin typeface="微软雅黑" panose="020B0503020204020204" charset="-122"/>
+                          <a:ea typeface="微软雅黑" panose="020B0503020204020204" charset="-122"/>
+                          <a:sym typeface="+mn-ea"/>
+                        </a:rPr>
+                        <a:t>项</a:t>
+                      </a:r>
+                      <a:r>
+                        <a:rPr lang="en-US" altLang="zh-CN" sz="1125">
+                          <a:solidFill>
+                            <a:srgbClr val="1A1A1A"/>
+                          </a:solidFill>
+                          <a:latin typeface="微软雅黑" panose="020B0503020204020204" charset="-122"/>
+                          <a:ea typeface="微软雅黑" panose="020B0503020204020204" charset="-122"/>
+                          <a:sym typeface="+mn-ea"/>
+                        </a:rPr>
+                        <a:t> </a:t>
+                      </a:r>
+                      <a:r>
+                        <a:rPr lang="zh-CN" altLang="en-US" sz="1125">
+                          <a:solidFill>
+                            <a:srgbClr val="1A1A1A"/>
+                          </a:solidFill>
+                          <a:latin typeface="微软雅黑" panose="020B0503020204020204" charset="-122"/>
+                          <a:ea typeface="微软雅黑" panose="020B0503020204020204" charset="-122"/>
+                          <a:sym typeface="+mn-ea"/>
+                        </a:rPr>
+                        <a:t>）</a:t>
+                      </a:r>
+                      <a:endParaRPr lang="zh-CN" altLang="en-US" sz="1125">
                         <a:solidFill>
                           <a:srgbClr val="1A1A1A"/>
                         </a:solidFill>
                         <a:latin typeface="微软雅黑" panose="020B0503020204020204" charset="-122"/>
                         <a:ea typeface="微软雅黑" panose="020B0503020204020204" charset="-122"/>
+                        <a:sym typeface="+mn-ea"/>
                       </a:endParaRPr>
                     </a:p>
-                  </a:txBody>
-                  <a:tcPr marL="0" marR="0" marT="0" marB="0" anchor="ctr">
-                    <a:lnL>
-                      <a:noFill/>
-                    </a:lnL>
-                    <a:lnR>
-                      <a:noFill/>
-                    </a:lnR>
-                    <a:lnT>
-                      <a:noFill/>
-                    </a:lnT>
-                    <a:lnB>
-                      <a:noFill/>
-                    </a:lnB>
-                  </a:tcPr>
-                </a:tc>
-                <a:tc>
-                  <a:txBody>
-                    <a:bodyPr wrap="square">
-                      <a:spAutoFit/>
-                    </a:bodyPr>
                     <a:p>
                       <a:pPr marL="114300" marR="114300" algn="l">
                         <a:lnSpc>
@@ -14036,21 +14338,56 @@
                         </a:lnSpc>
                       </a:pPr>
                       <a:r>
-                        <a:rPr sz="1125">
+                        <a:rPr lang="zh-CN" altLang="en-US" sz="1125">
                           <a:solidFill>
                             <a:srgbClr val="1A1A1A"/>
                           </a:solidFill>
                           <a:latin typeface="微软雅黑" panose="020B0503020204020204" charset="-122"/>
                           <a:ea typeface="微软雅黑" panose="020B0503020204020204" charset="-122"/>
+                          <a:sym typeface="+mn-ea"/>
                         </a:rPr>
-                        <a:t>—</a:t>
+                        <a:t>未通过</a:t>
                       </a:r>
-                      <a:endParaRPr sz="1125">
+                      <a:r>
+                        <a:rPr lang="en-US" altLang="zh-CN" sz="1125">
+                          <a:solidFill>
+                            <a:srgbClr val="1A1A1A"/>
+                          </a:solidFill>
+                          <a:latin typeface="微软雅黑" panose="020B0503020204020204" charset="-122"/>
+                          <a:ea typeface="微软雅黑" panose="020B0503020204020204" charset="-122"/>
+                          <a:sym typeface="+mn-ea"/>
+                        </a:rPr>
+                        <a:t> 18 </a:t>
+                      </a:r>
+                      <a:r>
+                        <a:rPr lang="zh-CN" altLang="en-US" sz="1125">
+                          <a:solidFill>
+                            <a:srgbClr val="1A1A1A"/>
+                          </a:solidFill>
+                          <a:latin typeface="微软雅黑" panose="020B0503020204020204" charset="-122"/>
+                          <a:ea typeface="微软雅黑" panose="020B0503020204020204" charset="-122"/>
+                          <a:sym typeface="+mn-ea"/>
+                        </a:rPr>
+                        <a:t>项，集中在说明书助手（文件参数提取、产品对比问题）以及知识库权限</a:t>
+                      </a:r>
+                      <a:r>
+                        <a:rPr lang="zh-CN" altLang="en-US" sz="1125">
+                          <a:solidFill>
+                            <a:srgbClr val="1A1A1A"/>
+                          </a:solidFill>
+                          <a:latin typeface="微软雅黑" panose="020B0503020204020204" charset="-122"/>
+                          <a:ea typeface="微软雅黑" panose="020B0503020204020204" charset="-122"/>
+                          <a:sym typeface="+mn-ea"/>
+                        </a:rPr>
+                        <a:t>模块</a:t>
+                      </a:r>
+                      <a:endParaRPr lang="zh-CN" altLang="en-US" sz="1125">
                         <a:solidFill>
                           <a:srgbClr val="1A1A1A"/>
                         </a:solidFill>
                         <a:latin typeface="微软雅黑" panose="020B0503020204020204" charset="-122"/>
                         <a:ea typeface="微软雅黑" panose="020B0503020204020204" charset="-122"/>
+                        <a:sym typeface="+mn-ea"/>
                       </a:endParaRPr>
                     </a:p>
                   </a:txBody>
@@ -14135,9 +14472,52 @@
                           <a:latin typeface="微软雅黑" panose="020B0503020204020204" charset="-122"/>
                           <a:ea typeface="微软雅黑" panose="020B0503020204020204" charset="-122"/>
                         </a:rPr>
-                        <a:t>15 用例（5 批次）</a:t>
+                        <a:t>8</a:t>
                       </a:r>
                       <a:endParaRPr sz="1125">
+                        <a:solidFill>
+                          <a:srgbClr val="1A1A1A"/>
+                        </a:solidFill>
+                        <a:latin typeface="微软雅黑" panose="020B0503020204020204" charset="-122"/>
+                        <a:ea typeface="微软雅黑" panose="020B0503020204020204" charset="-122"/>
+                      </a:endParaRPr>
+                    </a:p>
+                  </a:txBody>
+                  <a:tcPr marL="0" marR="0" marT="0" marB="0" anchor="ctr">
+                    <a:lnL>
+                      <a:noFill/>
+                    </a:lnL>
+                    <a:lnR>
+                      <a:noFill/>
+                    </a:lnR>
+                    <a:lnT>
+                      <a:noFill/>
+                    </a:lnT>
+                    <a:lnB>
+                      <a:noFill/>
+                    </a:lnB>
+                  </a:tcPr>
+                </a:tc>
+                <a:tc>
+                  <a:txBody>
+                    <a:bodyPr/>
+                    <a:p>
+                      <a:pPr marL="114300" marR="114300" algn="l">
+                        <a:lnSpc>
+                          <a:spcPct val="120000"/>
+                        </a:lnSpc>
+                      </a:pPr>
+                      <a:r>
+                        <a:rPr lang="en-US" sz="1125">
+                          <a:solidFill>
+                            <a:srgbClr val="1A1A1A"/>
+                          </a:solidFill>
+                          <a:latin typeface="微软雅黑" panose="020B0503020204020204" charset="-122"/>
+                          <a:ea typeface="微软雅黑" panose="020B0503020204020204" charset="-122"/>
+                        </a:rPr>
+                        <a:t>18</a:t>
+                      </a:r>
+                      <a:endParaRPr lang="en-US" sz="1125">
                         <a:solidFill>
                           <a:srgbClr val="1A1A1A"/>
                         </a:solidFill>
@@ -14173,61 +14553,61 @@
                         </a:lnSpc>
                       </a:pPr>
                       <a:r>
-                        <a:rPr sz="1125">
+                        <a:rPr lang="zh-CN" sz="1125">
                           <a:solidFill>
                             <a:srgbClr val="1A1A1A"/>
                           </a:solidFill>
                           <a:latin typeface="微软雅黑" panose="020B0503020204020204" charset="-122"/>
                           <a:ea typeface="微软雅黑" panose="020B0503020204020204" charset="-122"/>
+                          <a:sym typeface="+mn-ea"/>
                         </a:rPr>
-                        <a:t>8</a:t>
+                        <a:t>共计</a:t>
                       </a:r>
-                      <a:endParaRPr sz="1125">
-                        <a:solidFill>
-                          <a:srgbClr val="1A1A1A"/>
-                        </a:solidFill>
-                        <a:latin typeface="微软雅黑" panose="020B0503020204020204" charset="-122"/>
-                        <a:ea typeface="微软雅黑" panose="020B0503020204020204" charset="-122"/>
-                      </a:endParaRPr>
-                    </a:p>
-                  </a:txBody>
-                  <a:tcPr marL="0" marR="0" marT="0" marB="0" anchor="ctr">
-                    <a:lnL>
-                      <a:noFill/>
-                    </a:lnL>
-                    <a:lnR>
-                      <a:noFill/>
-                    </a:lnR>
-                    <a:lnT>
-                      <a:noFill/>
-                    </a:lnT>
-                    <a:lnB>
-                      <a:noFill/>
-                    </a:lnB>
-                  </a:tcPr>
-                </a:tc>
-                <a:tc>
-                  <a:txBody>
-                    <a:bodyPr wrap="square">
-                      <a:spAutoFit/>
-                    </a:bodyPr>
-                    <a:p>
-                      <a:pPr marL="114300" marR="114300" algn="l">
-                        <a:lnSpc>
-                          <a:spcPct val="120000"/>
-                        </a:lnSpc>
-                      </a:pPr>
                       <a:r>
-                        <a:rPr sz="1125" b="1">
+                        <a:rPr lang="en-US" altLang="zh-CN" sz="1125">
                           <a:solidFill>
-                            <a:srgbClr val="4472C4"/>
+                            <a:srgbClr val="1A1A1A"/>
                           </a:solidFill>
                           <a:latin typeface="微软雅黑" panose="020B0503020204020204" charset="-122"/>
                           <a:ea typeface="微软雅黑" panose="020B0503020204020204" charset="-122"/>
+                          <a:sym typeface="+mn-ea"/>
                         </a:rPr>
-                        <a:t>14/15 通过（93.3%）</a:t>
+                        <a:t> 21</a:t>
                       </a:r>
-                      <a:endParaRPr sz="1125" b="1">
+                      <a:r>
+                        <a:rPr lang="zh-CN" altLang="en-US" sz="1125">
+                          <a:solidFill>
+                            <a:srgbClr val="1A1A1A"/>
+                          </a:solidFill>
+                          <a:latin typeface="微软雅黑" panose="020B0503020204020204" charset="-122"/>
+                          <a:ea typeface="微软雅黑" panose="020B0503020204020204" charset="-122"/>
+                          <a:sym typeface="+mn-ea"/>
+                        </a:rPr>
+                        <a:t>项，未通过</a:t>
+                      </a:r>
+                      <a:r>
+                        <a:rPr lang="en-US" altLang="zh-CN" sz="1125">
+                          <a:solidFill>
+                            <a:srgbClr val="1A1A1A"/>
+                          </a:solidFill>
+                          <a:latin typeface="微软雅黑" panose="020B0503020204020204" charset="-122"/>
+                          <a:ea typeface="微软雅黑" panose="020B0503020204020204" charset="-122"/>
+                          <a:sym typeface="+mn-ea"/>
+                        </a:rPr>
+                        <a:t> 2 </a:t>
+                      </a:r>
+                      <a:r>
+                        <a:rPr lang="zh-CN" altLang="en-US" sz="1125">
+                          <a:solidFill>
+                            <a:srgbClr val="1A1A1A"/>
+                          </a:solidFill>
+                          <a:latin typeface="微软雅黑" panose="020B0503020204020204" charset="-122"/>
+                          <a:ea typeface="微软雅黑" panose="020B0503020204020204" charset="-122"/>
+                          <a:sym typeface="+mn-ea"/>
+                        </a:rPr>
+                        <a:t>项（智能体管理）</a:t>
+                      </a:r>
+                      <a:endParaRPr lang="en-US" sz="1125" b="1">
                         <a:solidFill>
                           <a:srgbClr val="4472C4"/>
                         </a:solidFill>
@@ -14272,7 +14652,7 @@
                           <a:latin typeface="微软雅黑" panose="020B0503020204020204" charset="-122"/>
                           <a:ea typeface="微软雅黑" panose="020B0503020204020204" charset="-122"/>
                         </a:rPr>
-                        <a:t>7 月（2607）</a:t>
+                        <a:t>7 月</a:t>
                       </a:r>
                       <a:endParaRPr sz="1125">
                         <a:solidFill>
@@ -14310,16 +14690,16 @@
                         </a:lnSpc>
                       </a:pPr>
                       <a:r>
-                        <a:rPr sz="1125">
+                        <a:rPr lang="en-US" sz="1125">
                           <a:solidFill>
                             <a:srgbClr val="1A1A1A"/>
                           </a:solidFill>
                           <a:latin typeface="微软雅黑" panose="020B0503020204020204" charset="-122"/>
                           <a:ea typeface="微软雅黑" panose="020B0503020204020204" charset="-122"/>
                         </a:rPr>
-                        <a:t>5 轮验收（8 项）</a:t>
+                        <a:t>12</a:t>
                       </a:r>
-                      <a:endParaRPr sz="1125">
+                      <a:endParaRPr lang="en-US" sz="1125">
                         <a:solidFill>
                           <a:srgbClr val="1A1A1A"/>
                         </a:solidFill>
@@ -14345,9 +14725,7 @@
                 </a:tc>
                 <a:tc>
                   <a:txBody>
-                    <a:bodyPr wrap="square">
-                      <a:spAutoFit/>
-                    </a:bodyPr>
+                    <a:bodyPr/>
                     <a:p>
                       <a:pPr marL="114300" marR="114300" algn="l">
                         <a:lnSpc>
@@ -14362,7 +14740,7 @@
                           <a:latin typeface="微软雅黑" panose="020B0503020204020204" charset="-122"/>
                           <a:ea typeface="微软雅黑" panose="020B0503020204020204" charset="-122"/>
                         </a:rPr>
-                        <a:t>4</a:t>
+                        <a:t>5 轮验收（8 项）</a:t>
                       </a:r>
                       <a:endParaRPr sz="1125">
                         <a:solidFill>

</xml_diff>

<commit_message>
vault backup: 2026-08-18 09:07:08
</commit_message>
<xml_diff>
--- a/PPT/入职以来AI工作复盘/入职以来AI工作复盘.pptx
+++ b/PPT/入职以来AI工作复盘/入职以来AI工作复盘.pptx
@@ -1582,7 +1582,7 @@
         </p:nvSpPr>
         <p:spPr>
           <a:xfrm>
-            <a:off x="2362200" y="1338580"/>
+            <a:off x="409575" y="1221740"/>
             <a:ext cx="3571875" cy="1333500"/>
           </a:xfrm>
           <a:prstGeom prst="roundRect">
@@ -1611,7 +1611,7 @@
         </p:nvSpPr>
         <p:spPr>
           <a:xfrm>
-            <a:off x="3981450" y="1548130"/>
+            <a:off x="2028825" y="1431290"/>
             <a:ext cx="342900" cy="647700"/>
           </a:xfrm>
           <a:prstGeom prst="rect">
@@ -1658,7 +1658,7 @@
         </p:nvSpPr>
         <p:spPr>
           <a:xfrm>
-            <a:off x="3543300" y="2252980"/>
+            <a:off x="1590675" y="2136140"/>
             <a:ext cx="1209675" cy="209550"/>
           </a:xfrm>
           <a:prstGeom prst="rect">
@@ -1725,7 +1725,7 @@
         </p:nvSpPr>
         <p:spPr>
           <a:xfrm>
-            <a:off x="6143625" y="1338580"/>
+            <a:off x="4191000" y="1221740"/>
             <a:ext cx="3562350" cy="1333500"/>
           </a:xfrm>
           <a:prstGeom prst="roundRect">
@@ -1754,7 +1754,7 @@
         </p:nvSpPr>
         <p:spPr>
           <a:xfrm>
-            <a:off x="7753350" y="1548130"/>
+            <a:off x="5800725" y="1431290"/>
             <a:ext cx="342900" cy="647700"/>
           </a:xfrm>
           <a:prstGeom prst="rect">
@@ -1801,7 +1801,7 @@
         </p:nvSpPr>
         <p:spPr>
           <a:xfrm>
-            <a:off x="7572375" y="2252980"/>
+            <a:off x="5619750" y="2136140"/>
             <a:ext cx="704850" cy="209550"/>
           </a:xfrm>
           <a:prstGeom prst="rect">
@@ -1858,7 +1858,7 @@
         </p:nvSpPr>
         <p:spPr>
           <a:xfrm>
-            <a:off x="6143625" y="2880995"/>
+            <a:off x="7962900" y="1221740"/>
             <a:ext cx="3571875" cy="1333500"/>
           </a:xfrm>
           <a:prstGeom prst="roundRect">
@@ -1887,7 +1887,7 @@
         </p:nvSpPr>
         <p:spPr>
           <a:xfrm>
-            <a:off x="7762875" y="3090545"/>
+            <a:off x="9582150" y="1431290"/>
             <a:ext cx="342900" cy="647700"/>
           </a:xfrm>
           <a:prstGeom prst="rect">
@@ -1934,7 +1934,7 @@
         </p:nvSpPr>
         <p:spPr>
           <a:xfrm>
-            <a:off x="7505700" y="3795395"/>
+            <a:off x="9324975" y="2136140"/>
             <a:ext cx="857250" cy="209550"/>
           </a:xfrm>
           <a:prstGeom prst="rect">
@@ -2010,8 +2010,8 @@
         </p:nvSpPr>
         <p:spPr>
           <a:xfrm>
-            <a:off x="3810000" y="3091180"/>
-            <a:ext cx="685800" cy="647700"/>
+            <a:off x="3543300" y="3091180"/>
+            <a:ext cx="1437640" cy="647700"/>
           </a:xfrm>
           <a:prstGeom prst="rect">
             <a:avLst/>
@@ -2033,7 +2033,7 @@
                 <a:latin typeface="微软雅黑" panose="020B0503020204020204" charset="-122"/>
                 <a:ea typeface="微软雅黑" panose="020B0503020204020204" charset="-122"/>
               </a:rPr>
-              <a:t>37</a:t>
+              <a:t>400+</a:t>
             </a:r>
             <a:endParaRPr lang="en-US" sz="4200" b="1">
               <a:solidFill>
@@ -2080,7 +2080,7 @@
                 <a:latin typeface="微软雅黑" panose="020B0503020204020204" charset="-122"/>
                 <a:ea typeface="微软雅黑" panose="020B0503020204020204" charset="-122"/>
               </a:rPr>
-              <a:t>平台验收项</a:t>
+              <a:t>平台测试项</a:t>
             </a:r>
             <a:endParaRPr lang="zh-CN" sz="1350">
               <a:solidFill>
@@ -2501,6 +2501,129 @@
             <a:endParaRPr lang="en-US" sz="1050">
               <a:solidFill>
                 <a:srgbClr val="888888"/>
+              </a:solidFill>
+              <a:latin typeface="微软雅黑" panose="020B0503020204020204" charset="-122"/>
+              <a:ea typeface="微软雅黑" panose="020B0503020204020204" charset="-122"/>
+            </a:endParaRPr>
+          </a:p>
+        </p:txBody>
+      </p:sp>
+      <p:sp>
+        <p:nvSpPr>
+          <p:cNvPr id="1" name="圆角矩形 0"/>
+          <p:cNvSpPr/>
+          <p:nvPr>
+            <p:custDataLst>
+              <p:tags r:id="rId13"/>
+            </p:custDataLst>
+          </p:nvPr>
+        </p:nvSpPr>
+        <p:spPr>
+          <a:xfrm>
+            <a:off x="6324600" y="2837180"/>
+            <a:ext cx="3571875" cy="1333500"/>
+          </a:xfrm>
+          <a:prstGeom prst="roundRect">
+            <a:avLst>
+              <a:gd name="adj" fmla="val 7143"/>
+            </a:avLst>
+          </a:prstGeom>
+          <a:solidFill>
+            <a:srgbClr val="F4F7FC"/>
+          </a:solidFill>
+        </p:spPr>
+        <p:txBody>
+          <a:bodyPr/>
+          <a:p/>
+        </p:txBody>
+      </p:sp>
+      <p:sp>
+        <p:nvSpPr>
+          <p:cNvPr id="2" name="文本框 1" descr="{&quot;isTemplate&quot;:true,&quot;type&quot;:&quot;text&quot;}"/>
+          <p:cNvSpPr txBox="1"/>
+          <p:nvPr>
+            <p:custDataLst>
+              <p:tags r:id="rId14"/>
+            </p:custDataLst>
+          </p:nvPr>
+        </p:nvSpPr>
+        <p:spPr>
+          <a:xfrm>
+            <a:off x="7391400" y="3046730"/>
+            <a:ext cx="1437640" cy="647700"/>
+          </a:xfrm>
+          <a:prstGeom prst="rect">
+            <a:avLst/>
+          </a:prstGeom>
+        </p:spPr>
+        <p:txBody>
+          <a:bodyPr wrap="none" lIns="0" tIns="0" rIns="0" bIns="0"/>
+          <a:p>
+            <a:pPr algn="ctr">
+              <a:lnSpc>
+                <a:spcPct val="100000"/>
+              </a:lnSpc>
+            </a:pPr>
+            <a:r>
+              <a:rPr lang="en-US" sz="4200" b="1">
+                <a:solidFill>
+                  <a:srgbClr val="4472C4"/>
+                </a:solidFill>
+                <a:latin typeface="微软雅黑" panose="020B0503020204020204" charset="-122"/>
+                <a:ea typeface="微软雅黑" panose="020B0503020204020204" charset="-122"/>
+              </a:rPr>
+              <a:t>50+</a:t>
+            </a:r>
+            <a:endParaRPr lang="en-US" sz="4200" b="1">
+              <a:solidFill>
+                <a:srgbClr val="4472C4"/>
+              </a:solidFill>
+              <a:latin typeface="微软雅黑" panose="020B0503020204020204" charset="-122"/>
+              <a:ea typeface="微软雅黑" panose="020B0503020204020204" charset="-122"/>
+            </a:endParaRPr>
+          </a:p>
+        </p:txBody>
+      </p:sp>
+      <p:sp>
+        <p:nvSpPr>
+          <p:cNvPr id="3" name="文本框 2" descr="{&quot;isTemplate&quot;:true,&quot;type&quot;:&quot;text&quot;}"/>
+          <p:cNvSpPr txBox="1"/>
+          <p:nvPr>
+            <p:custDataLst>
+              <p:tags r:id="rId15"/>
+            </p:custDataLst>
+          </p:nvPr>
+        </p:nvSpPr>
+        <p:spPr>
+          <a:xfrm>
+            <a:off x="7681595" y="3738880"/>
+            <a:ext cx="857250" cy="209550"/>
+          </a:xfrm>
+          <a:prstGeom prst="rect">
+            <a:avLst/>
+          </a:prstGeom>
+        </p:spPr>
+        <p:txBody>
+          <a:bodyPr wrap="none" lIns="0" tIns="0" rIns="0" bIns="0"/>
+          <a:p>
+            <a:pPr algn="ctr">
+              <a:lnSpc>
+                <a:spcPct val="100000"/>
+              </a:lnSpc>
+            </a:pPr>
+            <a:r>
+              <a:rPr lang="zh-CN" sz="1350">
+                <a:solidFill>
+                  <a:srgbClr val="1A1A1A"/>
+                </a:solidFill>
+                <a:latin typeface="微软雅黑" panose="020B0503020204020204" charset="-122"/>
+                <a:ea typeface="微软雅黑" panose="020B0503020204020204" charset="-122"/>
+              </a:rPr>
+              <a:t>验收项</a:t>
+            </a:r>
+            <a:endParaRPr lang="zh-CN" sz="1350">
+              <a:solidFill>
+                <a:srgbClr val="1A1A1A"/>
               </a:solidFill>
               <a:latin typeface="微软雅黑" panose="020B0503020204020204" charset="-122"/>
               <a:ea typeface="微软雅黑" panose="020B0503020204020204" charset="-122"/>
@@ -2639,7 +2762,7 @@
           <p:nvPr/>
         </p:nvGraphicFramePr>
         <p:xfrm>
-          <a:off x="533400" y="1143000"/>
+          <a:off x="533400" y="1435100"/>
           <a:ext cx="11125201" cy="4000500"/>
         </p:xfrm>
         <a:graphic>
@@ -2953,16 +3076,16 @@
                         </a:lnSpc>
                       </a:pPr>
                       <a:r>
-                        <a:rPr sz="1125">
-                          <a:solidFill>
-                            <a:srgbClr val="1A1A1A"/>
-                          </a:solidFill>
-                          <a:latin typeface="微软雅黑" panose="020B0503020204020204" charset="-122"/>
-                          <a:ea typeface="微软雅黑" panose="020B0503020204020204" charset="-122"/>
-                        </a:rPr>
-                        <a:t>05-29</a:t>
-                      </a:r>
-                      <a:endParaRPr sz="1125">
+                        <a:rPr lang="zh-CN" sz="1125">
+                          <a:solidFill>
+                            <a:srgbClr val="1A1A1A"/>
+                          </a:solidFill>
+                          <a:latin typeface="微软雅黑" panose="020B0503020204020204" charset="-122"/>
+                          <a:ea typeface="微软雅黑" panose="020B0503020204020204" charset="-122"/>
+                        </a:rPr>
+                        <a:t>五月下旬</a:t>
+                      </a:r>
+                      <a:endParaRPr lang="zh-CN" sz="1125">
                         <a:solidFill>
                           <a:srgbClr val="1A1A1A"/>
                         </a:solidFill>
@@ -3180,16 +3303,16 @@
                         </a:lnSpc>
                       </a:pPr>
                       <a:r>
-                        <a:rPr sz="1125">
-                          <a:solidFill>
-                            <a:srgbClr val="1A1A1A"/>
-                          </a:solidFill>
-                          <a:latin typeface="微软雅黑" panose="020B0503020204020204" charset="-122"/>
-                          <a:ea typeface="微软雅黑" panose="020B0503020204020204" charset="-122"/>
-                        </a:rPr>
-                        <a:t>06-22</a:t>
-                      </a:r>
-                      <a:endParaRPr sz="1125">
+                        <a:rPr lang="zh-CN" sz="1125">
+                          <a:solidFill>
+                            <a:srgbClr val="1A1A1A"/>
+                          </a:solidFill>
+                          <a:latin typeface="微软雅黑" panose="020B0503020204020204" charset="-122"/>
+                          <a:ea typeface="微软雅黑" panose="020B0503020204020204" charset="-122"/>
+                        </a:rPr>
+                        <a:t>六月中旬</a:t>
+                      </a:r>
+                      <a:endParaRPr lang="zh-CN" sz="1125">
                         <a:solidFill>
                           <a:srgbClr val="1A1A1A"/>
                         </a:solidFill>
@@ -3407,16 +3530,26 @@
                         </a:lnSpc>
                       </a:pPr>
                       <a:r>
-                        <a:rPr sz="1125">
-                          <a:solidFill>
-                            <a:srgbClr val="1A1A1A"/>
-                          </a:solidFill>
-                          <a:latin typeface="微软雅黑" panose="020B0503020204020204" charset="-122"/>
-                          <a:ea typeface="微软雅黑" panose="020B0503020204020204" charset="-122"/>
-                        </a:rPr>
-                        <a:t>07-28</a:t>
-                      </a:r>
-                      <a:endParaRPr sz="1125">
+                        <a:rPr lang="zh-CN" sz="1125">
+                          <a:solidFill>
+                            <a:srgbClr val="1A1A1A"/>
+                          </a:solidFill>
+                          <a:latin typeface="微软雅黑" panose="020B0503020204020204" charset="-122"/>
+                          <a:ea typeface="微软雅黑" panose="020B0503020204020204" charset="-122"/>
+                        </a:rPr>
+                        <a:t>七月</a:t>
+                      </a:r>
+                      <a:r>
+                        <a:rPr lang="zh-CN" sz="1125">
+                          <a:solidFill>
+                            <a:srgbClr val="1A1A1A"/>
+                          </a:solidFill>
+                          <a:latin typeface="微软雅黑" panose="020B0503020204020204" charset="-122"/>
+                          <a:ea typeface="微软雅黑" panose="020B0503020204020204" charset="-122"/>
+                        </a:rPr>
+                        <a:t>下旬</a:t>
+                      </a:r>
+                      <a:endParaRPr lang="zh-CN" sz="1125">
                         <a:solidFill>
                           <a:srgbClr val="1A1A1A"/>
                         </a:solidFill>
@@ -3654,16 +3787,16 @@
                         </a:lnSpc>
                       </a:pPr>
                       <a:r>
-                        <a:rPr sz="1125">
-                          <a:solidFill>
-                            <a:srgbClr val="1A1A1A"/>
-                          </a:solidFill>
-                          <a:latin typeface="微软雅黑" panose="020B0503020204020204" charset="-122"/>
-                          <a:ea typeface="微软雅黑" panose="020B0503020204020204" charset="-122"/>
-                        </a:rPr>
-                        <a:t>已交付</a:t>
-                      </a:r>
-                      <a:endParaRPr sz="1125">
+                        <a:rPr lang="zh-CN" sz="1125">
+                          <a:solidFill>
+                            <a:srgbClr val="1A1A1A"/>
+                          </a:solidFill>
+                          <a:latin typeface="微软雅黑" panose="020B0503020204020204" charset="-122"/>
+                          <a:ea typeface="微软雅黑" panose="020B0503020204020204" charset="-122"/>
+                        </a:rPr>
+                        <a:t>七月</a:t>
+                      </a:r>
+                      <a:endParaRPr lang="zh-CN" sz="1125">
                         <a:solidFill>
                           <a:srgbClr val="1A1A1A"/>
                         </a:solidFill>
@@ -3881,16 +4014,16 @@
                         </a:lnSpc>
                       </a:pPr>
                       <a:r>
-                        <a:rPr sz="1125">
-                          <a:solidFill>
-                            <a:srgbClr val="1A1A1A"/>
-                          </a:solidFill>
-                          <a:latin typeface="微软雅黑" panose="020B0503020204020204" charset="-122"/>
-                          <a:ea typeface="微软雅黑" panose="020B0503020204020204" charset="-122"/>
-                        </a:rPr>
-                        <a:t>08-01</a:t>
-                      </a:r>
-                      <a:endParaRPr sz="1125">
+                        <a:rPr lang="zh-CN" sz="1125">
+                          <a:solidFill>
+                            <a:srgbClr val="1A1A1A"/>
+                          </a:solidFill>
+                          <a:latin typeface="微软雅黑" panose="020B0503020204020204" charset="-122"/>
+                          <a:ea typeface="微软雅黑" panose="020B0503020204020204" charset="-122"/>
+                        </a:rPr>
+                        <a:t>八月初</a:t>
+                      </a:r>
+                      <a:endParaRPr lang="zh-CN" sz="1125">
                         <a:solidFill>
                           <a:srgbClr val="1A1A1A"/>
                         </a:solidFill>
@@ -4054,261 +4187,6 @@
           </a:graphicData>
         </a:graphic>
       </p:graphicFrame>
-      <p:sp>
-        <p:nvSpPr>
-          <p:cNvPr id="121" name="文本框 120" descr="{&quot;isTemplate&quot;:true,&quot;type&quot;:&quot;text&quot;}"/>
-          <p:cNvSpPr txBox="1"/>
-          <p:nvPr/>
-        </p:nvSpPr>
-        <p:spPr>
-          <a:xfrm>
-            <a:off x="533400" y="5334000"/>
-            <a:ext cx="11125200" cy="552450"/>
-          </a:xfrm>
-          <a:prstGeom prst="rect">
-            <a:avLst/>
-          </a:prstGeom>
-        </p:spPr>
-        <p:txBody>
-          <a:bodyPr wrap="square" lIns="0" tIns="0" rIns="0" bIns="0">
-            <a:normAutofit/>
-          </a:bodyPr>
-          <a:p>
-            <a:pPr>
-              <a:lnSpc>
-                <a:spcPct val="150000"/>
-              </a:lnSpc>
-            </a:pPr>
-            <a:r>
-              <a:rPr lang="zh-CN" sz="1200">
-                <a:solidFill>
-                  <a:srgbClr val="1A1A1A"/>
-                </a:solidFill>
-                <a:latin typeface="微软雅黑" panose="020B0503020204020204" charset="-122"/>
-                <a:ea typeface="微软雅黑" panose="020B0503020204020204" charset="-122"/>
-              </a:rPr>
-              <a:t>自研平均</a:t>
-            </a:r>
-            <a:r>
-              <a:rPr lang="en-US" sz="1200">
-                <a:solidFill>
-                  <a:srgbClr val="1A1A1A"/>
-                </a:solidFill>
-                <a:latin typeface="微软雅黑" panose="020B0503020204020204" charset="-122"/>
-                <a:ea typeface="微软雅黑" panose="020B0503020204020204" charset="-122"/>
-              </a:rPr>
-              <a:t> </a:t>
-            </a:r>
-            <a:r>
-              <a:rPr lang="en-US" sz="1200" b="1">
-                <a:solidFill>
-                  <a:srgbClr val="4472C4"/>
-                </a:solidFill>
-                <a:latin typeface="微软雅黑" panose="020B0503020204020204" charset="-122"/>
-                <a:ea typeface="微软雅黑" panose="020B0503020204020204" charset="-122"/>
-              </a:rPr>
-              <a:t>~25 </a:t>
-            </a:r>
-            <a:r>
-              <a:rPr lang="zh-CN" sz="1200" b="1">
-                <a:solidFill>
-                  <a:srgbClr val="4472C4"/>
-                </a:solidFill>
-                <a:latin typeface="微软雅黑" panose="020B0503020204020204" charset="-122"/>
-                <a:ea typeface="微软雅黑" panose="020B0503020204020204" charset="-122"/>
-              </a:rPr>
-              <a:t>天</a:t>
-            </a:r>
-            <a:r>
-              <a:rPr lang="en-US" sz="1200">
-                <a:solidFill>
-                  <a:srgbClr val="1A1A1A"/>
-                </a:solidFill>
-                <a:latin typeface="微软雅黑" panose="020B0503020204020204" charset="-122"/>
-                <a:ea typeface="微软雅黑" panose="020B0503020204020204" charset="-122"/>
-              </a:rPr>
-              <a:t> </a:t>
-            </a:r>
-            <a:r>
-              <a:rPr lang="zh-CN" sz="1200">
-                <a:solidFill>
-                  <a:srgbClr val="1A1A1A"/>
-                </a:solidFill>
-                <a:latin typeface="微软雅黑" panose="020B0503020204020204" charset="-122"/>
-                <a:ea typeface="微软雅黑" panose="020B0503020204020204" charset="-122"/>
-              </a:rPr>
-              <a:t>交付；含</a:t>
-            </a:r>
-            <a:r>
-              <a:rPr lang="en-US" sz="1200">
-                <a:solidFill>
-                  <a:srgbClr val="1A1A1A"/>
-                </a:solidFill>
-                <a:latin typeface="微软雅黑" panose="020B0503020204020204" charset="-122"/>
-                <a:ea typeface="微软雅黑" panose="020B0503020204020204" charset="-122"/>
-              </a:rPr>
-              <a:t> 1 </a:t>
-            </a:r>
-            <a:r>
-              <a:rPr lang="zh-CN" sz="1200">
-                <a:solidFill>
-                  <a:srgbClr val="1A1A1A"/>
-                </a:solidFill>
-                <a:latin typeface="微软雅黑" panose="020B0503020204020204" charset="-122"/>
-                <a:ea typeface="微软雅黑" panose="020B0503020204020204" charset="-122"/>
-              </a:rPr>
-              <a:t>次</a:t>
-            </a:r>
-            <a:r>
-              <a:rPr lang="en-US" sz="1200">
-                <a:solidFill>
-                  <a:srgbClr val="1A1A1A"/>
-                </a:solidFill>
-                <a:latin typeface="微软雅黑" panose="020B0503020204020204" charset="-122"/>
-                <a:ea typeface="微软雅黑" panose="020B0503020204020204" charset="-122"/>
-              </a:rPr>
-              <a:t> PyQt5→Web </a:t>
-            </a:r>
-            <a:r>
-              <a:rPr lang="zh-CN" sz="1200">
-                <a:solidFill>
-                  <a:srgbClr val="1A1A1A"/>
-                </a:solidFill>
-                <a:latin typeface="微软雅黑" panose="020B0503020204020204" charset="-122"/>
-                <a:ea typeface="微软雅黑" panose="020B0503020204020204" charset="-122"/>
-              </a:rPr>
-              <a:t>重构（</a:t>
-            </a:r>
-            <a:r>
-              <a:rPr lang="en-US" sz="1200">
-                <a:solidFill>
-                  <a:srgbClr val="1A1A1A"/>
-                </a:solidFill>
-                <a:latin typeface="微软雅黑" panose="020B0503020204020204" charset="-122"/>
-                <a:ea typeface="微软雅黑" panose="020B0503020204020204" charset="-122"/>
-              </a:rPr>
-              <a:t>05-27</a:t>
-            </a:r>
-            <a:r>
-              <a:rPr lang="zh-CN" sz="1200">
-                <a:solidFill>
-                  <a:srgbClr val="1A1A1A"/>
-                </a:solidFill>
-                <a:latin typeface="微软雅黑" panose="020B0503020204020204" charset="-122"/>
-                <a:ea typeface="微软雅黑" panose="020B0503020204020204" charset="-122"/>
-              </a:rPr>
-              <a:t>）、</a:t>
-            </a:r>
-            <a:r>
-              <a:rPr lang="en-US" sz="1200">
-                <a:solidFill>
-                  <a:srgbClr val="1A1A1A"/>
-                </a:solidFill>
-                <a:latin typeface="微软雅黑" panose="020B0503020204020204" charset="-122"/>
-                <a:ea typeface="微软雅黑" panose="020B0503020204020204" charset="-122"/>
-              </a:rPr>
-              <a:t>2 </a:t>
-            </a:r>
-            <a:r>
-              <a:rPr lang="zh-CN" sz="1200">
-                <a:solidFill>
-                  <a:srgbClr val="1A1A1A"/>
-                </a:solidFill>
-                <a:latin typeface="微软雅黑" panose="020B0503020204020204" charset="-122"/>
-                <a:ea typeface="微软雅黑" panose="020B0503020204020204" charset="-122"/>
-              </a:rPr>
-              <a:t>次架构级重构（采购</a:t>
-            </a:r>
-            <a:r>
-              <a:rPr lang="en-US" sz="1200">
-                <a:solidFill>
-                  <a:srgbClr val="1A1A1A"/>
-                </a:solidFill>
-                <a:latin typeface="微软雅黑" panose="020B0503020204020204" charset="-122"/>
-                <a:ea typeface="微软雅黑" panose="020B0503020204020204" charset="-122"/>
-              </a:rPr>
-              <a:t> 06-27</a:t>
-            </a:r>
-            <a:r>
-              <a:rPr lang="zh-CN" sz="1200">
-                <a:solidFill>
-                  <a:srgbClr val="1A1A1A"/>
-                </a:solidFill>
-                <a:latin typeface="微软雅黑" panose="020B0503020204020204" charset="-122"/>
-                <a:ea typeface="微软雅黑" panose="020B0503020204020204" charset="-122"/>
-              </a:rPr>
-              <a:t>、船务</a:t>
-            </a:r>
-            <a:r>
-              <a:rPr lang="en-US" sz="1200">
-                <a:solidFill>
-                  <a:srgbClr val="1A1A1A"/>
-                </a:solidFill>
-                <a:latin typeface="微软雅黑" panose="020B0503020204020204" charset="-122"/>
-                <a:ea typeface="微软雅黑" panose="020B0503020204020204" charset="-122"/>
-              </a:rPr>
-              <a:t> 08-01 JSON→SQLite</a:t>
-            </a:r>
-            <a:r>
-              <a:rPr lang="zh-CN" sz="1200">
-                <a:solidFill>
-                  <a:srgbClr val="1A1A1A"/>
-                </a:solidFill>
-                <a:latin typeface="微软雅黑" panose="020B0503020204020204" charset="-122"/>
-                <a:ea typeface="微软雅黑" panose="020B0503020204020204" charset="-122"/>
-              </a:rPr>
-              <a:t>）；</a:t>
-            </a:r>
-            <a:r>
-              <a:rPr lang="en-US" sz="1200">
-                <a:solidFill>
-                  <a:srgbClr val="1A1A1A"/>
-                </a:solidFill>
-                <a:latin typeface="微软雅黑" panose="020B0503020204020204" charset="-122"/>
-                <a:ea typeface="微软雅黑" panose="020B0503020204020204" charset="-122"/>
-              </a:rPr>
-              <a:t>110+ </a:t>
-            </a:r>
-            <a:r>
-              <a:rPr lang="zh-CN" sz="1200">
-                <a:solidFill>
-                  <a:srgbClr val="1A1A1A"/>
-                </a:solidFill>
-                <a:latin typeface="微软雅黑" panose="020B0503020204020204" charset="-122"/>
-                <a:ea typeface="微软雅黑" panose="020B0503020204020204" charset="-122"/>
-              </a:rPr>
-              <a:t>条代码迭代。</a:t>
-            </a:r>
-            <a:r>
-              <a:rPr lang="en-US" sz="1200">
-                <a:solidFill>
-                  <a:srgbClr val="1A1A1A"/>
-                </a:solidFill>
-                <a:latin typeface="微软雅黑" panose="020B0503020204020204" charset="-122"/>
-                <a:ea typeface="微软雅黑" panose="020B0503020204020204" charset="-122"/>
-              </a:rPr>
-              <a:t>MSDS </a:t>
-            </a:r>
-            <a:r>
-              <a:rPr lang="zh-CN" sz="1200">
-                <a:solidFill>
-                  <a:srgbClr val="1A1A1A"/>
-                </a:solidFill>
-                <a:latin typeface="微软雅黑" panose="020B0503020204020204" charset="-122"/>
-                <a:ea typeface="微软雅黑" panose="020B0503020204020204" charset="-122"/>
-              </a:rPr>
-              <a:t>中英文双语生成内嵌于船务助手，不作独立交付项。</a:t>
-            </a:r>
-            <a:endParaRPr lang="zh-CN" sz="1200">
-              <a:solidFill>
-                <a:srgbClr val="1A1A1A"/>
-              </a:solidFill>
-              <a:latin typeface="微软雅黑" panose="020B0503020204020204" charset="-122"/>
-              <a:ea typeface="微软雅黑" panose="020B0503020204020204" charset="-122"/>
-            </a:endParaRPr>
-          </a:p>
-        </p:txBody>
-      </p:sp>
       <p:sp>
         <p:nvSpPr>
           <p:cNvPr id="122" name="文本框 121" descr="{&quot;isTemplate&quot;:true,&quot;type&quot;:&quot;text&quot;}"/>
@@ -5763,7 +5641,7 @@
         </p:nvSpPr>
         <p:spPr>
           <a:xfrm>
-            <a:off x="533400" y="1238250"/>
+            <a:off x="533400" y="1104900"/>
             <a:ext cx="3571875" cy="1333500"/>
           </a:xfrm>
           <a:prstGeom prst="roundRect">
@@ -5792,8 +5670,8 @@
         </p:nvSpPr>
         <p:spPr>
           <a:xfrm>
-            <a:off x="1981200" y="1447800"/>
-            <a:ext cx="685800" cy="647700"/>
+            <a:off x="1581150" y="1353185"/>
+            <a:ext cx="1476375" cy="647700"/>
           </a:xfrm>
           <a:prstGeom prst="rect">
             <a:avLst/>
@@ -5815,7 +5693,7 @@
                 <a:latin typeface="微软雅黑" panose="020B0503020204020204" charset="-122"/>
                 <a:ea typeface="微软雅黑" panose="020B0503020204020204" charset="-122"/>
               </a:rPr>
-              <a:t>37</a:t>
+              <a:t>400+</a:t>
             </a:r>
             <a:endParaRPr lang="en-US" sz="4200" b="1">
               <a:solidFill>
@@ -5839,7 +5717,7 @@
         </p:nvSpPr>
         <p:spPr>
           <a:xfrm>
-            <a:off x="1819275" y="2152650"/>
+            <a:off x="1704975" y="2000885"/>
             <a:ext cx="857250" cy="209550"/>
           </a:xfrm>
           <a:prstGeom prst="rect">
@@ -5916,7 +5794,7 @@
         </p:nvSpPr>
         <p:spPr>
           <a:xfrm>
-            <a:off x="4314825" y="1238250"/>
+            <a:off x="4314825" y="1104900"/>
             <a:ext cx="3562350" cy="1333500"/>
           </a:xfrm>
           <a:prstGeom prst="roundRect">
@@ -5945,7 +5823,7 @@
         </p:nvSpPr>
         <p:spPr>
           <a:xfrm>
-            <a:off x="5753100" y="1447800"/>
+            <a:off x="5753100" y="1314450"/>
             <a:ext cx="685800" cy="647700"/>
           </a:xfrm>
           <a:prstGeom prst="rect">
@@ -5968,7 +5846,7 @@
                 <a:latin typeface="微软雅黑" panose="020B0503020204020204" charset="-122"/>
                 <a:ea typeface="微软雅黑" panose="020B0503020204020204" charset="-122"/>
               </a:rPr>
-              <a:t>19</a:t>
+              <a:t>44</a:t>
             </a:r>
             <a:endParaRPr lang="en-US" sz="4200" b="1">
               <a:solidFill>
@@ -5992,7 +5870,7 @@
         </p:nvSpPr>
         <p:spPr>
           <a:xfrm>
-            <a:off x="5581650" y="2152650"/>
+            <a:off x="5565775" y="2019300"/>
             <a:ext cx="1028700" cy="209550"/>
           </a:xfrm>
           <a:prstGeom prst="rect">
@@ -6016,6 +5894,16 @@
                 <a:ea typeface="微软雅黑" panose="020B0503020204020204" charset="-122"/>
               </a:rPr>
               <a:t>问题反馈闭环</a:t>
+            </a:r>
+            <a:r>
+              <a:rPr lang="zh-CN" sz="1350">
+                <a:solidFill>
+                  <a:srgbClr val="1A1A1A"/>
+                </a:solidFill>
+                <a:latin typeface="微软雅黑" panose="020B0503020204020204" charset="-122"/>
+                <a:ea typeface="微软雅黑" panose="020B0503020204020204" charset="-122"/>
+              </a:rPr>
+              <a:t>项</a:t>
             </a:r>
             <a:endParaRPr lang="zh-CN" sz="1350">
               <a:solidFill>
@@ -6039,7 +5927,7 @@
         </p:nvSpPr>
         <p:spPr>
           <a:xfrm>
-            <a:off x="8086725" y="1238250"/>
+            <a:off x="8086725" y="1104900"/>
             <a:ext cx="3571875" cy="1333500"/>
           </a:xfrm>
           <a:prstGeom prst="roundRect">
@@ -6068,7 +5956,7 @@
         </p:nvSpPr>
         <p:spPr>
           <a:xfrm>
-            <a:off x="8963025" y="1447800"/>
+            <a:off x="9134475" y="1314450"/>
             <a:ext cx="1828800" cy="647700"/>
           </a:xfrm>
           <a:prstGeom prst="rect">
@@ -6078,7 +5966,7 @@
         <p:txBody>
           <a:bodyPr wrap="none" lIns="0" tIns="0" rIns="0" bIns="0"/>
           <a:p>
-            <a:pPr>
+            <a:pPr algn="ctr">
               <a:lnSpc>
                 <a:spcPct val="100000"/>
               </a:lnSpc>
@@ -6091,7 +5979,7 @@
                 <a:latin typeface="微软雅黑" panose="020B0503020204020204" charset="-122"/>
                 <a:ea typeface="微软雅黑" panose="020B0503020204020204" charset="-122"/>
               </a:rPr>
-              <a:t>93.3%</a:t>
+              <a:t>94.1%</a:t>
             </a:r>
             <a:endParaRPr lang="en-US" sz="4200" b="1">
               <a:solidFill>
@@ -6115,7 +6003,7 @@
         </p:nvSpPr>
         <p:spPr>
           <a:xfrm>
-            <a:off x="9286875" y="2152650"/>
+            <a:off x="9458325" y="2019300"/>
             <a:ext cx="1181100" cy="209550"/>
           </a:xfrm>
           <a:prstGeom prst="rect">
@@ -6125,20 +6013,20 @@
         <p:txBody>
           <a:bodyPr wrap="none" lIns="0" tIns="0" rIns="0" bIns="0"/>
           <a:p>
-            <a:pPr>
+            <a:pPr algn="ctr">
               <a:lnSpc>
                 <a:spcPct val="100000"/>
               </a:lnSpc>
             </a:pPr>
             <a:r>
-              <a:rPr lang="en-US" sz="1350">
+              <a:rPr lang="zh-CN" altLang="en-US" sz="1350">
                 <a:solidFill>
                   <a:srgbClr val="1A1A1A"/>
                 </a:solidFill>
                 <a:latin typeface="微软雅黑" panose="020B0503020204020204" charset="-122"/>
                 <a:ea typeface="微软雅黑" panose="020B0503020204020204" charset="-122"/>
               </a:rPr>
-              <a:t>6 </a:t>
+              <a:t>总体</a:t>
             </a:r>
             <a:r>
               <a:rPr lang="zh-CN" sz="1350">
@@ -6148,7 +6036,7 @@
                 <a:latin typeface="微软雅黑" panose="020B0503020204020204" charset="-122"/>
                 <a:ea typeface="微软雅黑" panose="020B0503020204020204" charset="-122"/>
               </a:rPr>
-              <a:t>月单月通过率</a:t>
+              <a:t>通过率</a:t>
             </a:r>
             <a:endParaRPr lang="zh-CN" sz="1350">
               <a:solidFill>
@@ -6168,7 +6056,7 @@
         </p:nvSpPr>
         <p:spPr>
           <a:xfrm>
-            <a:off x="533400" y="2857500"/>
+            <a:off x="533400" y="2724150"/>
             <a:ext cx="11125200" cy="619125"/>
           </a:xfrm>
           <a:prstGeom prst="roundRect">
@@ -6193,7 +6081,7 @@
         </p:nvSpPr>
         <p:spPr>
           <a:xfrm>
-            <a:off x="742950" y="3009900"/>
+            <a:off x="742950" y="2876550"/>
             <a:ext cx="10706100" cy="314325"/>
           </a:xfrm>
           <a:prstGeom prst="rect">
@@ -6335,7 +6223,7 @@
           <p:nvPr/>
         </p:nvGraphicFramePr>
         <p:xfrm>
-          <a:off x="533400" y="3667125"/>
+          <a:off x="533400" y="3525520"/>
           <a:ext cx="11094085" cy="2593975"/>
         </p:xfrm>
         <a:graphic>
@@ -8504,7 +8392,7 @@
                           <a:latin typeface="微软雅黑" panose="020B0503020204020204" charset="-122"/>
                           <a:ea typeface="微软雅黑" panose="020B0503020204020204" charset="-122"/>
                         </a:rPr>
-                        <a:t>目前仅</a:t>
+                        <a:t>当前仅</a:t>
                       </a:r>
                       <a:r>
                         <a:rPr sz="1125">
@@ -11050,127 +10938,145 @@
 
 <file path=ppt/tags/tag1.xml><?xml version="1.0" encoding="utf-8"?>
 <p:tagLst xmlns:p="http://schemas.openxmlformats.org/presentationml/2006/main">
-  <p:tag name="KSO_WM_DIAGRAM_VIRTUALLY_FRAME" val="{&quot;height&quot;:234.4,&quot;left&quot;:42,&quot;top&quot;:97.5,&quot;width&quot;:876}"/>
+  <p:tag name="KSO_WM_DIAGRAM_VIRTUALLY_FRAME" val="{&quot;height&quot;:235.7,&quot;left&quot;:32.25,&quot;top&quot;:96.2,&quot;width&quot;:1029.75}"/>
 </p:tagLst>
 </file>
 
 <file path=ppt/tags/tag10.xml><?xml version="1.0" encoding="utf-8"?>
 <p:tagLst xmlns:p="http://schemas.openxmlformats.org/presentationml/2006/main">
-  <p:tag name="KSO_WM_DIAGRAM_VIRTUALLY_FRAME" val="{&quot;height&quot;:234.4,&quot;left&quot;:42,&quot;top&quot;:97.5,&quot;width&quot;:876}"/>
+  <p:tag name="KSO_WM_DIAGRAM_VIRTUALLY_FRAME" val="{&quot;height&quot;:235.7,&quot;left&quot;:32.25,&quot;top&quot;:96.2,&quot;width&quot;:1029.75}"/>
 </p:tagLst>
 </file>
 
 <file path=ppt/tags/tag11.xml><?xml version="1.0" encoding="utf-8"?>
 <p:tagLst xmlns:p="http://schemas.openxmlformats.org/presentationml/2006/main">
-  <p:tag name="KSO_WM_DIAGRAM_VIRTUALLY_FRAME" val="{&quot;height&quot;:234.4,&quot;left&quot;:42,&quot;top&quot;:97.5,&quot;width&quot;:876}"/>
+  <p:tag name="KSO_WM_DIAGRAM_VIRTUALLY_FRAME" val="{&quot;height&quot;:235.7,&quot;left&quot;:32.25,&quot;top&quot;:96.2,&quot;width&quot;:1029.75}"/>
 </p:tagLst>
 </file>
 
 <file path=ppt/tags/tag12.xml><?xml version="1.0" encoding="utf-8"?>
 <p:tagLst xmlns:p="http://schemas.openxmlformats.org/presentationml/2006/main">
-  <p:tag name="KSO_WM_DIAGRAM_VIRTUALLY_FRAME" val="{&quot;height&quot;:234.4,&quot;left&quot;:42,&quot;top&quot;:97.5,&quot;width&quot;:876}"/>
+  <p:tag name="KSO_WM_DIAGRAM_VIRTUALLY_FRAME" val="{&quot;height&quot;:235.7,&quot;left&quot;:32.25,&quot;top&quot;:96.2,&quot;width&quot;:1029.75}"/>
 </p:tagLst>
 </file>
 
 <file path=ppt/tags/tag13.xml><?xml version="1.0" encoding="utf-8"?>
 <p:tagLst xmlns:p="http://schemas.openxmlformats.org/presentationml/2006/main">
-  <p:tag name="KSO_WM_DIAGRAM_VIRTUALLY_FRAME" val="{&quot;height&quot;:105,&quot;left&quot;:42,&quot;top&quot;:97.5,&quot;width&quot;:876}"/>
+  <p:tag name="KSO_WM_DIAGRAM_VIRTUALLY_FRAME" val="{&quot;height&quot;:235.7,&quot;left&quot;:32.25,&quot;top&quot;:96.2,&quot;width&quot;:1029.75}"/>
 </p:tagLst>
 </file>
 
 <file path=ppt/tags/tag14.xml><?xml version="1.0" encoding="utf-8"?>
 <p:tagLst xmlns:p="http://schemas.openxmlformats.org/presentationml/2006/main">
-  <p:tag name="KSO_WM_DIAGRAM_VIRTUALLY_FRAME" val="{&quot;height&quot;:105,&quot;left&quot;:42,&quot;top&quot;:97.5,&quot;width&quot;:876}"/>
+  <p:tag name="KSO_WM_DIAGRAM_VIRTUALLY_FRAME" val="{&quot;height&quot;:235.7,&quot;left&quot;:32.25,&quot;top&quot;:96.2,&quot;width&quot;:1029.75}"/>
 </p:tagLst>
 </file>
 
 <file path=ppt/tags/tag15.xml><?xml version="1.0" encoding="utf-8"?>
 <p:tagLst xmlns:p="http://schemas.openxmlformats.org/presentationml/2006/main">
-  <p:tag name="KSO_WM_DIAGRAM_VIRTUALLY_FRAME" val="{&quot;height&quot;:105,&quot;left&quot;:42,&quot;top&quot;:97.5,&quot;width&quot;:876}"/>
+  <p:tag name="KSO_WM_DIAGRAM_VIRTUALLY_FRAME" val="{&quot;height&quot;:235.7,&quot;left&quot;:32.25,&quot;top&quot;:96.2,&quot;width&quot;:1029.75}"/>
 </p:tagLst>
 </file>
 
 <file path=ppt/tags/tag16.xml><?xml version="1.0" encoding="utf-8"?>
 <p:tagLst xmlns:p="http://schemas.openxmlformats.org/presentationml/2006/main">
-  <p:tag name="KSO_WM_DIAGRAM_VIRTUALLY_FRAME" val="{&quot;height&quot;:105,&quot;left&quot;:42,&quot;top&quot;:97.5,&quot;width&quot;:876}"/>
+  <p:tag name="KSO_WM_DIAGRAM_VIRTUALLY_FRAME" val="{&quot;height&quot;:115.5,&quot;left&quot;:42,&quot;top&quot;:87,&quot;width&quot;:876}"/>
 </p:tagLst>
 </file>
 
 <file path=ppt/tags/tag17.xml><?xml version="1.0" encoding="utf-8"?>
 <p:tagLst xmlns:p="http://schemas.openxmlformats.org/presentationml/2006/main">
-  <p:tag name="KSO_WM_DIAGRAM_VIRTUALLY_FRAME" val="{&quot;height&quot;:105,&quot;left&quot;:42,&quot;top&quot;:97.5,&quot;width&quot;:876}"/>
+  <p:tag name="KSO_WM_DIAGRAM_VIRTUALLY_FRAME" val="{&quot;height&quot;:115.5,&quot;left&quot;:42,&quot;top&quot;:87,&quot;width&quot;:876}"/>
 </p:tagLst>
 </file>
 
 <file path=ppt/tags/tag18.xml><?xml version="1.0" encoding="utf-8"?>
 <p:tagLst xmlns:p="http://schemas.openxmlformats.org/presentationml/2006/main">
-  <p:tag name="KSO_WM_DIAGRAM_VIRTUALLY_FRAME" val="{&quot;height&quot;:105,&quot;left&quot;:42,&quot;top&quot;:97.5,&quot;width&quot;:876}"/>
+  <p:tag name="KSO_WM_DIAGRAM_VIRTUALLY_FRAME" val="{&quot;height&quot;:115.5,&quot;left&quot;:42,&quot;top&quot;:87,&quot;width&quot;:876}"/>
 </p:tagLst>
 </file>
 
 <file path=ppt/tags/tag19.xml><?xml version="1.0" encoding="utf-8"?>
 <p:tagLst xmlns:p="http://schemas.openxmlformats.org/presentationml/2006/main">
-  <p:tag name="KSO_WM_DIAGRAM_VIRTUALLY_FRAME" val="{&quot;height&quot;:105,&quot;left&quot;:42,&quot;top&quot;:97.5,&quot;width&quot;:876}"/>
+  <p:tag name="KSO_WM_DIAGRAM_VIRTUALLY_FRAME" val="{&quot;height&quot;:115.5,&quot;left&quot;:42,&quot;top&quot;:87,&quot;width&quot;:876}"/>
 </p:tagLst>
 </file>
 
 <file path=ppt/tags/tag2.xml><?xml version="1.0" encoding="utf-8"?>
 <p:tagLst xmlns:p="http://schemas.openxmlformats.org/presentationml/2006/main">
-  <p:tag name="KSO_WM_DIAGRAM_VIRTUALLY_FRAME" val="{&quot;height&quot;:234.4,&quot;left&quot;:42,&quot;top&quot;:97.5,&quot;width&quot;:876}"/>
+  <p:tag name="KSO_WM_DIAGRAM_VIRTUALLY_FRAME" val="{&quot;height&quot;:235.7,&quot;left&quot;:32.25,&quot;top&quot;:96.2,&quot;width&quot;:1029.75}"/>
 </p:tagLst>
 </file>
 
 <file path=ppt/tags/tag20.xml><?xml version="1.0" encoding="utf-8"?>
 <p:tagLst xmlns:p="http://schemas.openxmlformats.org/presentationml/2006/main">
-  <p:tag name="KSO_WM_DIAGRAM_VIRTUALLY_FRAME" val="{&quot;height&quot;:105,&quot;left&quot;:42,&quot;top&quot;:97.5,&quot;width&quot;:876}"/>
+  <p:tag name="KSO_WM_DIAGRAM_VIRTUALLY_FRAME" val="{&quot;height&quot;:115.5,&quot;left&quot;:42,&quot;top&quot;:87,&quot;width&quot;:876}"/>
 </p:tagLst>
 </file>
 
 <file path=ppt/tags/tag21.xml><?xml version="1.0" encoding="utf-8"?>
 <p:tagLst xmlns:p="http://schemas.openxmlformats.org/presentationml/2006/main">
-  <p:tag name="KSO_WM_DIAGRAM_VIRTUALLY_FRAME" val="{&quot;height&quot;:105,&quot;left&quot;:42,&quot;top&quot;:97.5,&quot;width&quot;:876}"/>
+  <p:tag name="KSO_WM_DIAGRAM_VIRTUALLY_FRAME" val="{&quot;height&quot;:115.5,&quot;left&quot;:42,&quot;top&quot;:87,&quot;width&quot;:876}"/>
+</p:tagLst>
+</file>
+
+<file path=ppt/tags/tag22.xml><?xml version="1.0" encoding="utf-8"?>
+<p:tagLst xmlns:p="http://schemas.openxmlformats.org/presentationml/2006/main">
+  <p:tag name="KSO_WM_DIAGRAM_VIRTUALLY_FRAME" val="{&quot;height&quot;:115.5,&quot;left&quot;:42,&quot;top&quot;:87,&quot;width&quot;:876}"/>
+</p:tagLst>
+</file>
+
+<file path=ppt/tags/tag23.xml><?xml version="1.0" encoding="utf-8"?>
+<p:tagLst xmlns:p="http://schemas.openxmlformats.org/presentationml/2006/main">
+  <p:tag name="KSO_WM_DIAGRAM_VIRTUALLY_FRAME" val="{&quot;height&quot;:115.5,&quot;left&quot;:42,&quot;top&quot;:87,&quot;width&quot;:876}"/>
+</p:tagLst>
+</file>
+
+<file path=ppt/tags/tag24.xml><?xml version="1.0" encoding="utf-8"?>
+<p:tagLst xmlns:p="http://schemas.openxmlformats.org/presentationml/2006/main">
+  <p:tag name="KSO_WM_DIAGRAM_VIRTUALLY_FRAME" val="{&quot;height&quot;:115.5,&quot;left&quot;:42,&quot;top&quot;:87,&quot;width&quot;:876}"/>
 </p:tagLst>
 </file>
 
 <file path=ppt/tags/tag3.xml><?xml version="1.0" encoding="utf-8"?>
 <p:tagLst xmlns:p="http://schemas.openxmlformats.org/presentationml/2006/main">
-  <p:tag name="KSO_WM_DIAGRAM_VIRTUALLY_FRAME" val="{&quot;height&quot;:234.4,&quot;left&quot;:42,&quot;top&quot;:97.5,&quot;width&quot;:876}"/>
+  <p:tag name="KSO_WM_DIAGRAM_VIRTUALLY_FRAME" val="{&quot;height&quot;:235.7,&quot;left&quot;:32.25,&quot;top&quot;:96.2,&quot;width&quot;:1029.75}"/>
 </p:tagLst>
 </file>
 
 <file path=ppt/tags/tag4.xml><?xml version="1.0" encoding="utf-8"?>
 <p:tagLst xmlns:p="http://schemas.openxmlformats.org/presentationml/2006/main">
-  <p:tag name="KSO_WM_DIAGRAM_VIRTUALLY_FRAME" val="{&quot;height&quot;:234.4,&quot;left&quot;:42,&quot;top&quot;:97.5,&quot;width&quot;:876}"/>
+  <p:tag name="KSO_WM_DIAGRAM_VIRTUALLY_FRAME" val="{&quot;height&quot;:235.7,&quot;left&quot;:32.25,&quot;top&quot;:96.2,&quot;width&quot;:1029.75}"/>
 </p:tagLst>
 </file>
 
 <file path=ppt/tags/tag5.xml><?xml version="1.0" encoding="utf-8"?>
 <p:tagLst xmlns:p="http://schemas.openxmlformats.org/presentationml/2006/main">
-  <p:tag name="KSO_WM_DIAGRAM_VIRTUALLY_FRAME" val="{&quot;height&quot;:234.4,&quot;left&quot;:42,&quot;top&quot;:97.5,&quot;width&quot;:876}"/>
+  <p:tag name="KSO_WM_DIAGRAM_VIRTUALLY_FRAME" val="{&quot;height&quot;:235.7,&quot;left&quot;:32.25,&quot;top&quot;:96.2,&quot;width&quot;:1029.75}"/>
 </p:tagLst>
 </file>
 
 <file path=ppt/tags/tag6.xml><?xml version="1.0" encoding="utf-8"?>
 <p:tagLst xmlns:p="http://schemas.openxmlformats.org/presentationml/2006/main">
-  <p:tag name="KSO_WM_DIAGRAM_VIRTUALLY_FRAME" val="{&quot;height&quot;:234.4,&quot;left&quot;:42,&quot;top&quot;:97.5,&quot;width&quot;:876}"/>
+  <p:tag name="KSO_WM_DIAGRAM_VIRTUALLY_FRAME" val="{&quot;height&quot;:235.7,&quot;left&quot;:32.25,&quot;top&quot;:96.2,&quot;width&quot;:1029.75}"/>
 </p:tagLst>
 </file>
 
 <file path=ppt/tags/tag7.xml><?xml version="1.0" encoding="utf-8"?>
 <p:tagLst xmlns:p="http://schemas.openxmlformats.org/presentationml/2006/main">
-  <p:tag name="KSO_WM_DIAGRAM_VIRTUALLY_FRAME" val="{&quot;height&quot;:234.4,&quot;left&quot;:42,&quot;top&quot;:97.5,&quot;width&quot;:876}"/>
+  <p:tag name="KSO_WM_DIAGRAM_VIRTUALLY_FRAME" val="{&quot;height&quot;:235.7,&quot;left&quot;:32.25,&quot;top&quot;:96.2,&quot;width&quot;:1029.75}"/>
 </p:tagLst>
 </file>
 
 <file path=ppt/tags/tag8.xml><?xml version="1.0" encoding="utf-8"?>
 <p:tagLst xmlns:p="http://schemas.openxmlformats.org/presentationml/2006/main">
-  <p:tag name="KSO_WM_DIAGRAM_VIRTUALLY_FRAME" val="{&quot;height&quot;:234.4,&quot;left&quot;:42,&quot;top&quot;:97.5,&quot;width&quot;:876}"/>
+  <p:tag name="KSO_WM_DIAGRAM_VIRTUALLY_FRAME" val="{&quot;height&quot;:235.7,&quot;left&quot;:32.25,&quot;top&quot;:96.2,&quot;width&quot;:1029.75}"/>
 </p:tagLst>
 </file>
 
 <file path=ppt/tags/tag9.xml><?xml version="1.0" encoding="utf-8"?>
 <p:tagLst xmlns:p="http://schemas.openxmlformats.org/presentationml/2006/main">
-  <p:tag name="KSO_WM_DIAGRAM_VIRTUALLY_FRAME" val="{&quot;height&quot;:234.4,&quot;left&quot;:42,&quot;top&quot;:97.5,&quot;width&quot;:876}"/>
+  <p:tag name="KSO_WM_DIAGRAM_VIRTUALLY_FRAME" val="{&quot;height&quot;:235.7,&quot;left&quot;:32.25,&quot;top&quot;:96.2,&quot;width&quot;:1029.75}"/>
 </p:tagLst>
 </file>
 

</xml_diff>

<commit_message>
vault backup: 2026-08-18 09:17:19
</commit_message>
<xml_diff>
--- a/PPT/入职以来AI工作复盘/入职以来AI工作复盘.pptx
+++ b/PPT/入职以来AI工作复盘/入职以来AI工作复盘.pptx
@@ -5,18 +5,17 @@
     <p:sldMasterId id="2147483648" r:id="rId1"/>
   </p:sldMasterIdLst>
   <p:notesMasterIdLst>
-    <p:notesMasterId r:id="rId12"/>
+    <p:notesMasterId r:id="rId11"/>
   </p:notesMasterIdLst>
   <p:sldIdLst>
     <p:sldId id="256" r:id="rId3"/>
     <p:sldId id="257" r:id="rId4"/>
     <p:sldId id="258" r:id="rId5"/>
     <p:sldId id="259" r:id="rId6"/>
-    <p:sldId id="263" r:id="rId7"/>
-    <p:sldId id="265" r:id="rId8"/>
-    <p:sldId id="266" r:id="rId9"/>
-    <p:sldId id="267" r:id="rId10"/>
-    <p:sldId id="268" r:id="rId11"/>
+    <p:sldId id="265" r:id="rId7"/>
+    <p:sldId id="266" r:id="rId8"/>
+    <p:sldId id="267" r:id="rId9"/>
+    <p:sldId id="268" r:id="rId10"/>
   </p:sldIdLst>
   <p:sldSz cx="12192000" cy="6858000"/>
   <p:notesSz cx="6858000" cy="12192000"/>
@@ -1060,7 +1059,7 @@
         </p:nvSpPr>
         <p:spPr>
           <a:xfrm>
-            <a:off x="4324350" y="1933575"/>
+            <a:off x="4324350" y="2238375"/>
             <a:ext cx="7334250" cy="276225"/>
           </a:xfrm>
           <a:prstGeom prst="rect">
@@ -1103,7 +1102,7 @@
         </p:nvSpPr>
         <p:spPr>
           <a:xfrm>
-            <a:off x="4324350" y="2400300"/>
+            <a:off x="4324350" y="2705100"/>
             <a:ext cx="7334250" cy="276225"/>
           </a:xfrm>
           <a:prstGeom prst="rect">
@@ -1126,7 +1125,7 @@
                 <a:latin typeface="微软雅黑" panose="020B0503020204020204" charset="-122"/>
                 <a:ea typeface="微软雅黑" panose="020B0503020204020204" charset="-122"/>
               </a:rPr>
-              <a:t>二、内部工作：自研应用交付</a:t>
+              <a:t>二、开发应用交付</a:t>
             </a:r>
             <a:endParaRPr lang="zh-CN" sz="1800" b="1">
               <a:solidFill>
@@ -1146,7 +1145,7 @@
         </p:nvSpPr>
         <p:spPr>
           <a:xfrm>
-            <a:off x="4324350" y="2867025"/>
+            <a:off x="4324350" y="3171825"/>
             <a:ext cx="7334250" cy="276225"/>
           </a:xfrm>
           <a:prstGeom prst="rect">
@@ -1156,7 +1155,7 @@
         <p:txBody>
           <a:bodyPr wrap="none" lIns="0" tIns="0" rIns="0" bIns="0"/>
           <a:p>
-            <a:pPr>
+            <a:pPr algn="l">
               <a:lnSpc>
                 <a:spcPct val="100000"/>
               </a:lnSpc>
@@ -1169,131 +1168,38 @@
                 <a:latin typeface="微软雅黑" panose="020B0503020204020204" charset="-122"/>
                 <a:ea typeface="微软雅黑" panose="020B0503020204020204" charset="-122"/>
               </a:rPr>
-              <a:t>三、内部工作：</a:t>
-            </a:r>
-            <a:r>
-              <a:rPr lang="en-US" sz="1800" b="1">
+              <a:t>三、</a:t>
+            </a:r>
+            <a:r>
+              <a:rPr lang="zh-CN" b="1">
                 <a:solidFill>
                   <a:srgbClr val="1A1A1A"/>
                 </a:solidFill>
                 <a:latin typeface="微软雅黑" panose="020B0503020204020204" charset="-122"/>
                 <a:ea typeface="微软雅黑" panose="020B0503020204020204" charset="-122"/>
-              </a:rPr>
-              <a:t>Skill </a:t>
-            </a:r>
-            <a:r>
-              <a:rPr lang="zh-CN" sz="1800" b="1">
+                <a:sym typeface="+mn-ea"/>
+              </a:rPr>
+              <a:t>宏昊</a:t>
+            </a:r>
+            <a:r>
+              <a:rPr lang="en-US" b="1">
                 <a:solidFill>
                   <a:srgbClr val="1A1A1A"/>
                 </a:solidFill>
                 <a:latin typeface="微软雅黑" panose="020B0503020204020204" charset="-122"/>
                 <a:ea typeface="微软雅黑" panose="020B0503020204020204" charset="-122"/>
-              </a:rPr>
-              <a:t>抽象与复用</a:t>
-            </a:r>
-            <a:endParaRPr lang="zh-CN" sz="1800" b="1">
-              <a:solidFill>
-                <a:srgbClr val="1A1A1A"/>
-              </a:solidFill>
-              <a:latin typeface="微软雅黑" panose="020B0503020204020204" charset="-122"/>
-              <a:ea typeface="微软雅黑" panose="020B0503020204020204" charset="-122"/>
-            </a:endParaRPr>
-          </a:p>
-        </p:txBody>
-      </p:sp>
-      <p:sp>
-        <p:nvSpPr>
-          <p:cNvPr id="85" name="文本框 84" descr="{&quot;isTemplate&quot;:true,&quot;type&quot;:&quot;text&quot;}"/>
-          <p:cNvSpPr txBox="1"/>
-          <p:nvPr/>
-        </p:nvSpPr>
-        <p:spPr>
-          <a:xfrm>
-            <a:off x="4324350" y="3333750"/>
-            <a:ext cx="7334250" cy="276225"/>
-          </a:xfrm>
-          <a:prstGeom prst="rect">
-            <a:avLst/>
-          </a:prstGeom>
-        </p:spPr>
-        <p:txBody>
-          <a:bodyPr wrap="none" lIns="0" tIns="0" rIns="0" bIns="0"/>
-          <a:p>
-            <a:pPr>
-              <a:lnSpc>
-                <a:spcPct val="100000"/>
-              </a:lnSpc>
-            </a:pPr>
-            <a:r>
-              <a:rPr lang="zh-CN" sz="1800" b="1">
+                <a:sym typeface="+mn-ea"/>
+              </a:rPr>
+              <a:t>AI</a:t>
+            </a:r>
+            <a:r>
+              <a:rPr lang="zh-CN" b="1">
                 <a:solidFill>
                   <a:srgbClr val="1A1A1A"/>
                 </a:solidFill>
                 <a:latin typeface="微软雅黑" panose="020B0503020204020204" charset="-122"/>
                 <a:ea typeface="微软雅黑" panose="020B0503020204020204" charset="-122"/>
-              </a:rPr>
-              <a:t>四、内部工作：培训与推广</a:t>
-            </a:r>
-            <a:endParaRPr lang="zh-CN" sz="1800" b="1">
-              <a:solidFill>
-                <a:srgbClr val="1A1A1A"/>
-              </a:solidFill>
-              <a:latin typeface="微软雅黑" panose="020B0503020204020204" charset="-122"/>
-              <a:ea typeface="微软雅黑" panose="020B0503020204020204" charset="-122"/>
-            </a:endParaRPr>
-          </a:p>
-        </p:txBody>
-      </p:sp>
-      <p:sp>
-        <p:nvSpPr>
-          <p:cNvPr id="86" name="文本框 85" descr="{&quot;isTemplate&quot;:true,&quot;type&quot;:&quot;text&quot;}"/>
-          <p:cNvSpPr txBox="1"/>
-          <p:nvPr/>
-        </p:nvSpPr>
-        <p:spPr>
-          <a:xfrm>
-            <a:off x="4324350" y="3800475"/>
-            <a:ext cx="7334250" cy="276225"/>
-          </a:xfrm>
-          <a:prstGeom prst="rect">
-            <a:avLst/>
-          </a:prstGeom>
-        </p:spPr>
-        <p:txBody>
-          <a:bodyPr wrap="none" lIns="0" tIns="0" rIns="0" bIns="0"/>
-          <a:p>
-            <a:pPr>
-              <a:lnSpc>
-                <a:spcPct val="100000"/>
-              </a:lnSpc>
-            </a:pPr>
-            <a:r>
-              <a:rPr lang="zh-CN" sz="1800" b="1">
-                <a:solidFill>
-                  <a:srgbClr val="1A1A1A"/>
-                </a:solidFill>
-                <a:latin typeface="微软雅黑" panose="020B0503020204020204" charset="-122"/>
-                <a:ea typeface="微软雅黑" panose="020B0503020204020204" charset="-122"/>
-              </a:rPr>
-              <a:t>五、外部工作：宏昊</a:t>
-            </a:r>
-            <a:r>
-              <a:rPr lang="en-US" sz="1800" b="1">
-                <a:solidFill>
-                  <a:srgbClr val="1A1A1A"/>
-                </a:solidFill>
-                <a:latin typeface="微软雅黑" panose="020B0503020204020204" charset="-122"/>
-                <a:ea typeface="微软雅黑" panose="020B0503020204020204" charset="-122"/>
-              </a:rPr>
-              <a:t>AI</a:t>
-            </a:r>
-            <a:r>
-              <a:rPr lang="zh-CN" sz="1800" b="1">
-                <a:solidFill>
-                  <a:srgbClr val="1A1A1A"/>
-                </a:solidFill>
-                <a:latin typeface="微软雅黑" panose="020B0503020204020204" charset="-122"/>
-                <a:ea typeface="微软雅黑" panose="020B0503020204020204" charset="-122"/>
+                <a:sym typeface="+mn-ea"/>
               </a:rPr>
               <a:t>助手平台</a:t>
             </a:r>
@@ -1315,7 +1221,7 @@
         </p:nvSpPr>
         <p:spPr>
           <a:xfrm>
-            <a:off x="4324350" y="4267200"/>
+            <a:off x="4324350" y="3638550"/>
             <a:ext cx="7334250" cy="276225"/>
           </a:xfrm>
           <a:prstGeom prst="rect">
@@ -1338,7 +1244,7 @@
                 <a:latin typeface="微软雅黑" panose="020B0503020204020204" charset="-122"/>
                 <a:ea typeface="微软雅黑" panose="020B0503020204020204" charset="-122"/>
               </a:rPr>
-              <a:t>六、下阶段计划与需支持事项</a:t>
+              <a:t>四、下阶段计划与需支持事项</a:t>
             </a:r>
             <a:endParaRPr lang="zh-CN" sz="1800" b="1">
               <a:solidFill>
@@ -4306,1188 +4212,6 @@
   <p:cSld>
     <p:spTree>
       <p:nvGrpSpPr>
-        <p:cNvPr id="199" name="" descr="&lt;Slide style={{ width:'1280px', height:'720px', position:'relative', background:'#FFFFFF', fontFamily:'微软雅黑' }}&gt;&#10;  &lt;Box style={{ position:'absolute', left:56, top:36, flexDirection:'row', alignItems:'center', gap:12 }}&gt;&#10;    &lt;Box style={{ width:8, height:34, background:'#4472C4' }} /&gt;&#10;    &lt;Text style={{ fontSize:30, fontWeight:'bold', color:'#052B7C' }}&gt;三、Skill 抽象与复用&lt;/Text&gt;&#10;  &lt;/Box&gt;&#10;&#10;  &lt;Box style={{ position:'absolute', left:56, top:118, right:56, background:'#052B7C', borderRadius:10, padding:'14px 22px' }}&gt;&#10;    &lt;Text style={{ fontSize:17, color:'#FFFFFF', lineHeight:1.5 }}&gt;与「建应用」并列的内部第二条交付路径：复现工作场景 → 抽象输入输出 → 复用 / 赋能业务自建。&lt;/Text&gt;&#10;  &lt;/Box&gt;&#10;&#10;  &lt;Box style={{ position:'absolute', left:56, top:200, right:56, flexDirection:'row', gap:28 }}&gt;&#10;    &lt;Box style={{ flex:1, background:'#F4F7FC', borderRadius:12, padding:24, flexDirection:'column', gap:12 }}&gt;&#10;      &lt;Text style={{ fontSize:22, fontWeight:'bold', color:'#4472C4' }}&gt;tax-refund-audit（退税审单 Skill）&lt;/Text&gt;&#10;      &lt;Text style={{ fontSize:17, color:'#1A1A1A', lineHeight:1.7 }}&gt;· 抽象退税审单工作流为可复用 Skill，交付财务部&lt;/Text&gt;&#10;      &lt;Text style={{ fontSize:17, color:'#1A1A1A', lineHeight:1.7 }}&gt;· 与 Tax_check 应用互补：应用做 OCR + 条款矩阵「体检」，Skill 做审单流程复用与下沉&lt;/Text&gt;&#10;      &lt;Text style={{ fontSize:17, color:'#1A1A1A', lineHeight:1.7 }}&gt;· 降低对专人 / 专工具的依赖&lt;/Text&gt;&#10;      &lt;Box style={{ marginTop:4, background:'#DAE3F3', borderRadius:6, padding:'6px 12px', alignSelf:'flex-start' }}&gt;&lt;Text style={{ fontSize:15, fontWeight:'bold', color:'#052B7C' }}&gt;状态：已交付财务使用&lt;/Text&gt;&lt;/Box&gt;&#10;    &lt;/Box&gt;&#10;    &lt;Box style={{ flex:1, background:'#F4F7FC', borderRadius:12, padding:24, flexDirection:'column', gap:12 }}&gt;&#10;      &lt;Text style={{ fontSize:22, fontWeight:'bold', color:'#4472C4' }}&gt;daily-commodity-price-scraper（价格爬取 Skill）&lt;/Text&gt;&#10;      &lt;Text style={{ fontSize:17, color:'#1A1A1A', lineHeight:1.7 }}&gt;· 作为「钩子」培养采购部门自主制作 Skill 的能力&lt;/Text&gt;&#10;      &lt;Text style={{ fontSize:17, color:'#1A1A1A', lineHeight:1.7 }}&gt;· 后续仍回采购部门培训，巩固「自建 Skill」能力&lt;/Text&gt;&#10;      &lt;Text style={{ fontSize:17, color:'#1A1A1A', lineHeight:1.7 }}&gt;· 体现理念：赋能业务自建，AI 小组退后为把关角色&lt;/Text&gt;&#10;      &lt;Box style={{ marginTop:4, background:'#DAE3F3', borderRadius:6, padding:'6px 12px', alignSelf:'flex-start' }}&gt;&lt;Text style={{ fontSize:15, fontWeight:'bold', color:'#052B7C' }}&gt;状态：赋能中（回培训）&lt;/Text&gt;&lt;/Box&gt;&#10;    &lt;/Box&gt;&#10;  &lt;/Box&gt;&#10;&#10;  &lt;Box style={{ position:'absolute', left:56, top:668, right:56, flexDirection:'row', justifyContent:'space-between' }}&gt;&#10;    &lt;Text style={{ fontSize:14, color:'#888' }}&gt;入职以来 AI 工作复盘&lt;/Text&gt;&#10;    &lt;Text style={{ fontSize:14, color:'#888' }}&gt;08 / 13&lt;/Text&gt;&#10;  &lt;/Box&gt;&#10;&lt;/Slide&gt;"/>
-        <p:cNvGrpSpPr/>
-        <p:nvPr/>
-      </p:nvGrpSpPr>
-      <p:grpSpPr>
-        <a:xfrm>
-          <a:off x="0" y="0"/>
-          <a:ext cx="0" cy="0"/>
-          <a:chOff x="0" y="0"/>
-          <a:chExt cx="0" cy="0"/>
-        </a:xfrm>
-      </p:grpSpPr>
-      <p:sp>
-        <p:nvSpPr>
-          <p:cNvPr id="200" name="矩形 199"/>
-          <p:cNvSpPr/>
-          <p:nvPr/>
-        </p:nvSpPr>
-        <p:spPr>
-          <a:xfrm>
-            <a:off x="0" y="0"/>
-            <a:ext cx="12192000" cy="6858000"/>
-          </a:xfrm>
-          <a:prstGeom prst="rect">
-            <a:avLst/>
-          </a:prstGeom>
-          <a:solidFill>
-            <a:srgbClr val="FFFFFF"/>
-          </a:solidFill>
-        </p:spPr>
-        <p:txBody>
-          <a:bodyPr/>
-          <a:p/>
-        </p:txBody>
-      </p:sp>
-      <p:sp>
-        <p:nvSpPr>
-          <p:cNvPr id="201" name="矩形 200"/>
-          <p:cNvSpPr/>
-          <p:nvPr/>
-        </p:nvSpPr>
-        <p:spPr>
-          <a:xfrm>
-            <a:off x="533400" y="352425"/>
-            <a:ext cx="76200" cy="323850"/>
-          </a:xfrm>
-          <a:prstGeom prst="rect">
-            <a:avLst/>
-          </a:prstGeom>
-          <a:solidFill>
-            <a:srgbClr val="4472C4"/>
-          </a:solidFill>
-        </p:spPr>
-        <p:txBody>
-          <a:bodyPr/>
-          <a:p/>
-        </p:txBody>
-      </p:sp>
-      <p:sp>
-        <p:nvSpPr>
-          <p:cNvPr id="202" name="文本框 201" descr="{&quot;isTemplate&quot;:true,&quot;type&quot;:&quot;text&quot;}"/>
-          <p:cNvSpPr txBox="1"/>
-          <p:nvPr/>
-        </p:nvSpPr>
-        <p:spPr>
-          <a:xfrm>
-            <a:off x="723900" y="342900"/>
-            <a:ext cx="2705100" cy="342900"/>
-          </a:xfrm>
-          <a:prstGeom prst="rect">
-            <a:avLst/>
-          </a:prstGeom>
-        </p:spPr>
-        <p:txBody>
-          <a:bodyPr wrap="none" lIns="0" tIns="0" rIns="0" bIns="0"/>
-          <a:p>
-            <a:pPr>
-              <a:lnSpc>
-                <a:spcPct val="100000"/>
-              </a:lnSpc>
-            </a:pPr>
-            <a:r>
-              <a:rPr lang="zh-CN" sz="2250" b="1">
-                <a:solidFill>
-                  <a:srgbClr val="052B7C"/>
-                </a:solidFill>
-                <a:latin typeface="微软雅黑" panose="020B0503020204020204" charset="-122"/>
-                <a:ea typeface="微软雅黑" panose="020B0503020204020204" charset="-122"/>
-              </a:rPr>
-              <a:t>三、</a:t>
-            </a:r>
-            <a:r>
-              <a:rPr lang="en-US" sz="2250" b="1">
-                <a:solidFill>
-                  <a:srgbClr val="052B7C"/>
-                </a:solidFill>
-                <a:latin typeface="微软雅黑" panose="020B0503020204020204" charset="-122"/>
-                <a:ea typeface="微软雅黑" panose="020B0503020204020204" charset="-122"/>
-              </a:rPr>
-              <a:t>Skill </a:t>
-            </a:r>
-            <a:r>
-              <a:rPr lang="zh-CN" sz="2250" b="1">
-                <a:solidFill>
-                  <a:srgbClr val="052B7C"/>
-                </a:solidFill>
-                <a:latin typeface="微软雅黑" panose="020B0503020204020204" charset="-122"/>
-                <a:ea typeface="微软雅黑" panose="020B0503020204020204" charset="-122"/>
-              </a:rPr>
-              <a:t>抽象与复用</a:t>
-            </a:r>
-            <a:endParaRPr lang="zh-CN" sz="2250" b="1">
-              <a:solidFill>
-                <a:srgbClr val="052B7C"/>
-              </a:solidFill>
-              <a:latin typeface="微软雅黑" panose="020B0503020204020204" charset="-122"/>
-              <a:ea typeface="微软雅黑" panose="020B0503020204020204" charset="-122"/>
-            </a:endParaRPr>
-          </a:p>
-        </p:txBody>
-      </p:sp>
-      <p:sp>
-        <p:nvSpPr>
-          <p:cNvPr id="203" name="圆角矩形 202"/>
-          <p:cNvSpPr/>
-          <p:nvPr/>
-        </p:nvSpPr>
-        <p:spPr>
-          <a:xfrm>
-            <a:off x="533400" y="1123950"/>
-            <a:ext cx="11125200" cy="561975"/>
-          </a:xfrm>
-          <a:prstGeom prst="roundRect">
-            <a:avLst>
-              <a:gd name="adj" fmla="val 16949"/>
-            </a:avLst>
-          </a:prstGeom>
-          <a:solidFill>
-            <a:srgbClr val="052B7C"/>
-          </a:solidFill>
-        </p:spPr>
-        <p:txBody>
-          <a:bodyPr/>
-          <a:p/>
-        </p:txBody>
-      </p:sp>
-      <p:sp>
-        <p:nvSpPr>
-          <p:cNvPr id="204" name="文本框 203" descr="{&quot;isTemplate&quot;:true,&quot;type&quot;:&quot;text&quot;}"/>
-          <p:cNvSpPr txBox="1"/>
-          <p:nvPr/>
-        </p:nvSpPr>
-        <p:spPr>
-          <a:xfrm>
-            <a:off x="742950" y="1257300"/>
-            <a:ext cx="10706100" cy="295275"/>
-          </a:xfrm>
-          <a:prstGeom prst="rect">
-            <a:avLst/>
-          </a:prstGeom>
-        </p:spPr>
-        <p:txBody>
-          <a:bodyPr wrap="none" lIns="0" tIns="0" rIns="0" bIns="0"/>
-          <a:p>
-            <a:pPr>
-              <a:lnSpc>
-                <a:spcPct val="150000"/>
-              </a:lnSpc>
-            </a:pPr>
-            <a:r>
-              <a:rPr lang="zh-CN" sz="1275">
-                <a:solidFill>
-                  <a:srgbClr val="FFFFFF"/>
-                </a:solidFill>
-                <a:latin typeface="微软雅黑" panose="020B0503020204020204" charset="-122"/>
-                <a:ea typeface="微软雅黑" panose="020B0503020204020204" charset="-122"/>
-              </a:rPr>
-              <a:t>与「建应用」并列的内部第二条交付路径：复现工作场景</a:t>
-            </a:r>
-            <a:r>
-              <a:rPr lang="en-US" sz="1275">
-                <a:solidFill>
-                  <a:srgbClr val="FFFFFF"/>
-                </a:solidFill>
-                <a:latin typeface="微软雅黑" panose="020B0503020204020204" charset="-122"/>
-                <a:ea typeface="微软雅黑" panose="020B0503020204020204" charset="-122"/>
-              </a:rPr>
-              <a:t> → </a:t>
-            </a:r>
-            <a:r>
-              <a:rPr lang="zh-CN" sz="1275">
-                <a:solidFill>
-                  <a:srgbClr val="FFFFFF"/>
-                </a:solidFill>
-                <a:latin typeface="微软雅黑" panose="020B0503020204020204" charset="-122"/>
-                <a:ea typeface="微软雅黑" panose="020B0503020204020204" charset="-122"/>
-              </a:rPr>
-              <a:t>抽象输入输出</a:t>
-            </a:r>
-            <a:r>
-              <a:rPr lang="en-US" sz="1275">
-                <a:solidFill>
-                  <a:srgbClr val="FFFFFF"/>
-                </a:solidFill>
-                <a:latin typeface="微软雅黑" panose="020B0503020204020204" charset="-122"/>
-                <a:ea typeface="微软雅黑" panose="020B0503020204020204" charset="-122"/>
-              </a:rPr>
-              <a:t> → </a:t>
-            </a:r>
-            <a:r>
-              <a:rPr lang="zh-CN" sz="1275">
-                <a:solidFill>
-                  <a:srgbClr val="FFFFFF"/>
-                </a:solidFill>
-                <a:latin typeface="微软雅黑" panose="020B0503020204020204" charset="-122"/>
-                <a:ea typeface="微软雅黑" panose="020B0503020204020204" charset="-122"/>
-              </a:rPr>
-              <a:t>复用</a:t>
-            </a:r>
-            <a:r>
-              <a:rPr lang="en-US" sz="1275">
-                <a:solidFill>
-                  <a:srgbClr val="FFFFFF"/>
-                </a:solidFill>
-                <a:latin typeface="微软雅黑" panose="020B0503020204020204" charset="-122"/>
-                <a:ea typeface="微软雅黑" panose="020B0503020204020204" charset="-122"/>
-              </a:rPr>
-              <a:t> / </a:t>
-            </a:r>
-            <a:r>
-              <a:rPr lang="zh-CN" sz="1275">
-                <a:solidFill>
-                  <a:srgbClr val="FFFFFF"/>
-                </a:solidFill>
-                <a:latin typeface="微软雅黑" panose="020B0503020204020204" charset="-122"/>
-                <a:ea typeface="微软雅黑" panose="020B0503020204020204" charset="-122"/>
-              </a:rPr>
-              <a:t>赋能业务自建。</a:t>
-            </a:r>
-            <a:endParaRPr lang="zh-CN" sz="1275">
-              <a:solidFill>
-                <a:srgbClr val="FFFFFF"/>
-              </a:solidFill>
-              <a:latin typeface="微软雅黑" panose="020B0503020204020204" charset="-122"/>
-              <a:ea typeface="微软雅黑" panose="020B0503020204020204" charset="-122"/>
-            </a:endParaRPr>
-          </a:p>
-        </p:txBody>
-      </p:sp>
-      <p:sp>
-        <p:nvSpPr>
-          <p:cNvPr id="205" name="圆角矩形 204"/>
-          <p:cNvSpPr/>
-          <p:nvPr/>
-        </p:nvSpPr>
-        <p:spPr>
-          <a:xfrm>
-            <a:off x="533400" y="1905000"/>
-            <a:ext cx="5429250" cy="2828925"/>
-          </a:xfrm>
-          <a:prstGeom prst="roundRect">
-            <a:avLst>
-              <a:gd name="adj" fmla="val 4040"/>
-            </a:avLst>
-          </a:prstGeom>
-          <a:solidFill>
-            <a:srgbClr val="F4F7FC"/>
-          </a:solidFill>
-        </p:spPr>
-        <p:txBody>
-          <a:bodyPr/>
-          <a:p/>
-        </p:txBody>
-      </p:sp>
-      <p:sp>
-        <p:nvSpPr>
-          <p:cNvPr id="206" name="文本框 205" descr="{&quot;isTemplate&quot;:true,&quot;type&quot;:&quot;text&quot;}"/>
-          <p:cNvSpPr txBox="1"/>
-          <p:nvPr/>
-        </p:nvSpPr>
-        <p:spPr>
-          <a:xfrm>
-            <a:off x="762000" y="2133600"/>
-            <a:ext cx="4972050" cy="257175"/>
-          </a:xfrm>
-          <a:prstGeom prst="rect">
-            <a:avLst/>
-          </a:prstGeom>
-        </p:spPr>
-        <p:txBody>
-          <a:bodyPr wrap="none" lIns="0" tIns="0" rIns="0" bIns="0"/>
-          <a:p>
-            <a:pPr>
-              <a:lnSpc>
-                <a:spcPct val="100000"/>
-              </a:lnSpc>
-            </a:pPr>
-            <a:r>
-              <a:rPr lang="en-US" sz="1650" b="1">
-                <a:solidFill>
-                  <a:srgbClr val="4472C4"/>
-                </a:solidFill>
-                <a:latin typeface="微软雅黑" panose="020B0503020204020204" charset="-122"/>
-                <a:ea typeface="微软雅黑" panose="020B0503020204020204" charset="-122"/>
-              </a:rPr>
-              <a:t>tax-refund-audit</a:t>
-            </a:r>
-            <a:r>
-              <a:rPr lang="zh-CN" sz="1650" b="1">
-                <a:solidFill>
-                  <a:srgbClr val="4472C4"/>
-                </a:solidFill>
-                <a:latin typeface="微软雅黑" panose="020B0503020204020204" charset="-122"/>
-                <a:ea typeface="微软雅黑" panose="020B0503020204020204" charset="-122"/>
-              </a:rPr>
-              <a:t>（退税审单</a:t>
-            </a:r>
-            <a:r>
-              <a:rPr lang="en-US" sz="1650" b="1">
-                <a:solidFill>
-                  <a:srgbClr val="4472C4"/>
-                </a:solidFill>
-                <a:latin typeface="微软雅黑" panose="020B0503020204020204" charset="-122"/>
-                <a:ea typeface="微软雅黑" panose="020B0503020204020204" charset="-122"/>
-              </a:rPr>
-              <a:t> Skill</a:t>
-            </a:r>
-            <a:r>
-              <a:rPr lang="zh-CN" sz="1650" b="1">
-                <a:solidFill>
-                  <a:srgbClr val="4472C4"/>
-                </a:solidFill>
-                <a:latin typeface="微软雅黑" panose="020B0503020204020204" charset="-122"/>
-                <a:ea typeface="微软雅黑" panose="020B0503020204020204" charset="-122"/>
-              </a:rPr>
-              <a:t>）</a:t>
-            </a:r>
-            <a:endParaRPr lang="zh-CN" sz="1650" b="1">
-              <a:solidFill>
-                <a:srgbClr val="4472C4"/>
-              </a:solidFill>
-              <a:latin typeface="微软雅黑" panose="020B0503020204020204" charset="-122"/>
-              <a:ea typeface="微软雅黑" panose="020B0503020204020204" charset="-122"/>
-            </a:endParaRPr>
-          </a:p>
-        </p:txBody>
-      </p:sp>
-      <p:sp>
-        <p:nvSpPr>
-          <p:cNvPr id="207" name="文本框 206" descr="{&quot;isTemplate&quot;:true,&quot;type&quot;:&quot;text&quot;}"/>
-          <p:cNvSpPr txBox="1"/>
-          <p:nvPr/>
-        </p:nvSpPr>
-        <p:spPr>
-          <a:xfrm>
-            <a:off x="762000" y="2505075"/>
-            <a:ext cx="4972050" cy="333375"/>
-          </a:xfrm>
-          <a:prstGeom prst="rect">
-            <a:avLst/>
-          </a:prstGeom>
-        </p:spPr>
-        <p:txBody>
-          <a:bodyPr wrap="none" lIns="0" tIns="0" rIns="0" bIns="0"/>
-          <a:p>
-            <a:pPr>
-              <a:lnSpc>
-                <a:spcPct val="170000"/>
-              </a:lnSpc>
-            </a:pPr>
-            <a:r>
-              <a:rPr lang="en-US" sz="1275">
-                <a:solidFill>
-                  <a:srgbClr val="1A1A1A"/>
-                </a:solidFill>
-                <a:latin typeface="微软雅黑" panose="020B0503020204020204" charset="-122"/>
-                <a:ea typeface="微软雅黑" panose="020B0503020204020204" charset="-122"/>
-              </a:rPr>
-              <a:t>· </a:t>
-            </a:r>
-            <a:r>
-              <a:rPr lang="zh-CN" sz="1275">
-                <a:solidFill>
-                  <a:srgbClr val="1A1A1A"/>
-                </a:solidFill>
-                <a:latin typeface="微软雅黑" panose="020B0503020204020204" charset="-122"/>
-                <a:ea typeface="微软雅黑" panose="020B0503020204020204" charset="-122"/>
-              </a:rPr>
-              <a:t>抽象退税审单工作流为可复用</a:t>
-            </a:r>
-            <a:r>
-              <a:rPr lang="en-US" sz="1275">
-                <a:solidFill>
-                  <a:srgbClr val="1A1A1A"/>
-                </a:solidFill>
-                <a:latin typeface="微软雅黑" panose="020B0503020204020204" charset="-122"/>
-                <a:ea typeface="微软雅黑" panose="020B0503020204020204" charset="-122"/>
-              </a:rPr>
-              <a:t> Skill</a:t>
-            </a:r>
-            <a:r>
-              <a:rPr lang="zh-CN" sz="1275">
-                <a:solidFill>
-                  <a:srgbClr val="1A1A1A"/>
-                </a:solidFill>
-                <a:latin typeface="微软雅黑" panose="020B0503020204020204" charset="-122"/>
-                <a:ea typeface="微软雅黑" panose="020B0503020204020204" charset="-122"/>
-              </a:rPr>
-              <a:t>，交付财务部</a:t>
-            </a:r>
-            <a:endParaRPr lang="zh-CN" sz="1275">
-              <a:solidFill>
-                <a:srgbClr val="1A1A1A"/>
-              </a:solidFill>
-              <a:latin typeface="微软雅黑" panose="020B0503020204020204" charset="-122"/>
-              <a:ea typeface="微软雅黑" panose="020B0503020204020204" charset="-122"/>
-            </a:endParaRPr>
-          </a:p>
-        </p:txBody>
-      </p:sp>
-      <p:sp>
-        <p:nvSpPr>
-          <p:cNvPr id="208" name="文本框 207" descr="{&quot;isTemplate&quot;:true,&quot;type&quot;:&quot;text&quot;}"/>
-          <p:cNvSpPr txBox="1"/>
-          <p:nvPr/>
-        </p:nvSpPr>
-        <p:spPr>
-          <a:xfrm>
-            <a:off x="762000" y="2952750"/>
-            <a:ext cx="4972050" cy="666750"/>
-          </a:xfrm>
-          <a:prstGeom prst="rect">
-            <a:avLst/>
-          </a:prstGeom>
-        </p:spPr>
-        <p:txBody>
-          <a:bodyPr wrap="square" lIns="0" tIns="0" rIns="0" bIns="0">
-            <a:normAutofit/>
-          </a:bodyPr>
-          <a:p>
-            <a:pPr>
-              <a:lnSpc>
-                <a:spcPct val="170000"/>
-              </a:lnSpc>
-            </a:pPr>
-            <a:r>
-              <a:rPr lang="en-US" sz="1275">
-                <a:solidFill>
-                  <a:srgbClr val="1A1A1A"/>
-                </a:solidFill>
-                <a:latin typeface="微软雅黑" panose="020B0503020204020204" charset="-122"/>
-                <a:ea typeface="微软雅黑" panose="020B0503020204020204" charset="-122"/>
-              </a:rPr>
-              <a:t>· </a:t>
-            </a:r>
-            <a:r>
-              <a:rPr lang="zh-CN" sz="1275">
-                <a:solidFill>
-                  <a:srgbClr val="1A1A1A"/>
-                </a:solidFill>
-                <a:latin typeface="微软雅黑" panose="020B0503020204020204" charset="-122"/>
-                <a:ea typeface="微软雅黑" panose="020B0503020204020204" charset="-122"/>
-              </a:rPr>
-              <a:t>与</a:t>
-            </a:r>
-            <a:r>
-              <a:rPr lang="en-US" sz="1275">
-                <a:solidFill>
-                  <a:srgbClr val="1A1A1A"/>
-                </a:solidFill>
-                <a:latin typeface="微软雅黑" panose="020B0503020204020204" charset="-122"/>
-                <a:ea typeface="微软雅黑" panose="020B0503020204020204" charset="-122"/>
-              </a:rPr>
-              <a:t> Tax_check </a:t>
-            </a:r>
-            <a:r>
-              <a:rPr lang="zh-CN" sz="1275">
-                <a:solidFill>
-                  <a:srgbClr val="1A1A1A"/>
-                </a:solidFill>
-                <a:latin typeface="微软雅黑" panose="020B0503020204020204" charset="-122"/>
-                <a:ea typeface="微软雅黑" panose="020B0503020204020204" charset="-122"/>
-              </a:rPr>
-              <a:t>应用互补：应用做</a:t>
-            </a:r>
-            <a:r>
-              <a:rPr lang="en-US" sz="1275">
-                <a:solidFill>
-                  <a:srgbClr val="1A1A1A"/>
-                </a:solidFill>
-                <a:latin typeface="微软雅黑" panose="020B0503020204020204" charset="-122"/>
-                <a:ea typeface="微软雅黑" panose="020B0503020204020204" charset="-122"/>
-              </a:rPr>
-              <a:t> OCR + </a:t>
-            </a:r>
-            <a:r>
-              <a:rPr lang="zh-CN" sz="1275">
-                <a:solidFill>
-                  <a:srgbClr val="1A1A1A"/>
-                </a:solidFill>
-                <a:latin typeface="微软雅黑" panose="020B0503020204020204" charset="-122"/>
-                <a:ea typeface="微软雅黑" panose="020B0503020204020204" charset="-122"/>
-              </a:rPr>
-              <a:t>条款矩阵「体检」，</a:t>
-            </a:r>
-            <a:r>
-              <a:rPr lang="en-US" sz="1275">
-                <a:solidFill>
-                  <a:srgbClr val="1A1A1A"/>
-                </a:solidFill>
-                <a:latin typeface="微软雅黑" panose="020B0503020204020204" charset="-122"/>
-                <a:ea typeface="微软雅黑" panose="020B0503020204020204" charset="-122"/>
-              </a:rPr>
-              <a:t>Skill </a:t>
-            </a:r>
-            <a:r>
-              <a:rPr lang="zh-CN" sz="1275">
-                <a:solidFill>
-                  <a:srgbClr val="1A1A1A"/>
-                </a:solidFill>
-                <a:latin typeface="微软雅黑" panose="020B0503020204020204" charset="-122"/>
-                <a:ea typeface="微软雅黑" panose="020B0503020204020204" charset="-122"/>
-              </a:rPr>
-              <a:t>做审单流程复用与下沉</a:t>
-            </a:r>
-            <a:endParaRPr lang="zh-CN" sz="1275">
-              <a:solidFill>
-                <a:srgbClr val="1A1A1A"/>
-              </a:solidFill>
-              <a:latin typeface="微软雅黑" panose="020B0503020204020204" charset="-122"/>
-              <a:ea typeface="微软雅黑" panose="020B0503020204020204" charset="-122"/>
-            </a:endParaRPr>
-          </a:p>
-        </p:txBody>
-      </p:sp>
-      <p:sp>
-        <p:nvSpPr>
-          <p:cNvPr id="209" name="文本框 208" descr="{&quot;isTemplate&quot;:true,&quot;type&quot;:&quot;text&quot;}"/>
-          <p:cNvSpPr txBox="1"/>
-          <p:nvPr/>
-        </p:nvSpPr>
-        <p:spPr>
-          <a:xfrm>
-            <a:off x="762000" y="3733800"/>
-            <a:ext cx="4972050" cy="333375"/>
-          </a:xfrm>
-          <a:prstGeom prst="rect">
-            <a:avLst/>
-          </a:prstGeom>
-        </p:spPr>
-        <p:txBody>
-          <a:bodyPr wrap="none" lIns="0" tIns="0" rIns="0" bIns="0"/>
-          <a:p>
-            <a:pPr>
-              <a:lnSpc>
-                <a:spcPct val="170000"/>
-              </a:lnSpc>
-            </a:pPr>
-            <a:r>
-              <a:rPr lang="en-US" sz="1275">
-                <a:solidFill>
-                  <a:srgbClr val="1A1A1A"/>
-                </a:solidFill>
-                <a:latin typeface="微软雅黑" panose="020B0503020204020204" charset="-122"/>
-                <a:ea typeface="微软雅黑" panose="020B0503020204020204" charset="-122"/>
-              </a:rPr>
-              <a:t>· </a:t>
-            </a:r>
-            <a:r>
-              <a:rPr lang="zh-CN" sz="1275">
-                <a:solidFill>
-                  <a:srgbClr val="1A1A1A"/>
-                </a:solidFill>
-                <a:latin typeface="微软雅黑" panose="020B0503020204020204" charset="-122"/>
-                <a:ea typeface="微软雅黑" panose="020B0503020204020204" charset="-122"/>
-              </a:rPr>
-              <a:t>降低对专人</a:t>
-            </a:r>
-            <a:r>
-              <a:rPr lang="en-US" sz="1275">
-                <a:solidFill>
-                  <a:srgbClr val="1A1A1A"/>
-                </a:solidFill>
-                <a:latin typeface="微软雅黑" panose="020B0503020204020204" charset="-122"/>
-                <a:ea typeface="微软雅黑" panose="020B0503020204020204" charset="-122"/>
-              </a:rPr>
-              <a:t> / </a:t>
-            </a:r>
-            <a:r>
-              <a:rPr lang="zh-CN" sz="1275">
-                <a:solidFill>
-                  <a:srgbClr val="1A1A1A"/>
-                </a:solidFill>
-                <a:latin typeface="微软雅黑" panose="020B0503020204020204" charset="-122"/>
-                <a:ea typeface="微软雅黑" panose="020B0503020204020204" charset="-122"/>
-              </a:rPr>
-              <a:t>专工具的依赖</a:t>
-            </a:r>
-            <a:endParaRPr lang="zh-CN" sz="1275">
-              <a:solidFill>
-                <a:srgbClr val="1A1A1A"/>
-              </a:solidFill>
-              <a:latin typeface="微软雅黑" panose="020B0503020204020204" charset="-122"/>
-              <a:ea typeface="微软雅黑" panose="020B0503020204020204" charset="-122"/>
-            </a:endParaRPr>
-          </a:p>
-        </p:txBody>
-      </p:sp>
-      <p:sp>
-        <p:nvSpPr>
-          <p:cNvPr id="210" name="圆角矩形 209"/>
-          <p:cNvSpPr/>
-          <p:nvPr/>
-        </p:nvSpPr>
-        <p:spPr>
-          <a:xfrm>
-            <a:off x="762000" y="4219575"/>
-            <a:ext cx="1657350" cy="285750"/>
-          </a:xfrm>
-          <a:prstGeom prst="roundRect">
-            <a:avLst>
-              <a:gd name="adj" fmla="val 20000"/>
-            </a:avLst>
-          </a:prstGeom>
-          <a:solidFill>
-            <a:srgbClr val="DAE3F3"/>
-          </a:solidFill>
-        </p:spPr>
-        <p:txBody>
-          <a:bodyPr/>
-          <a:p/>
-        </p:txBody>
-      </p:sp>
-      <p:sp>
-        <p:nvSpPr>
-          <p:cNvPr id="211" name="文本框 210" descr="{&quot;isTemplate&quot;:true,&quot;type&quot;:&quot;text&quot;}"/>
-          <p:cNvSpPr txBox="1"/>
-          <p:nvPr/>
-        </p:nvSpPr>
-        <p:spPr>
-          <a:xfrm>
-            <a:off x="876300" y="4276725"/>
-            <a:ext cx="1428750" cy="171450"/>
-          </a:xfrm>
-          <a:prstGeom prst="rect">
-            <a:avLst/>
-          </a:prstGeom>
-        </p:spPr>
-        <p:txBody>
-          <a:bodyPr wrap="none" lIns="0" tIns="0" rIns="0" bIns="0"/>
-          <a:p>
-            <a:pPr>
-              <a:lnSpc>
-                <a:spcPct val="100000"/>
-              </a:lnSpc>
-            </a:pPr>
-            <a:r>
-              <a:rPr lang="zh-CN" sz="1125" b="1">
-                <a:solidFill>
-                  <a:srgbClr val="052B7C"/>
-                </a:solidFill>
-                <a:latin typeface="微软雅黑" panose="020B0503020204020204" charset="-122"/>
-                <a:ea typeface="微软雅黑" panose="020B0503020204020204" charset="-122"/>
-              </a:rPr>
-              <a:t>状态：已交付财务使用</a:t>
-            </a:r>
-            <a:endParaRPr lang="zh-CN" sz="1125" b="1">
-              <a:solidFill>
-                <a:srgbClr val="052B7C"/>
-              </a:solidFill>
-              <a:latin typeface="微软雅黑" panose="020B0503020204020204" charset="-122"/>
-              <a:ea typeface="微软雅黑" panose="020B0503020204020204" charset="-122"/>
-            </a:endParaRPr>
-          </a:p>
-        </p:txBody>
-      </p:sp>
-      <p:sp>
-        <p:nvSpPr>
-          <p:cNvPr id="212" name="圆角矩形 211"/>
-          <p:cNvSpPr/>
-          <p:nvPr/>
-        </p:nvSpPr>
-        <p:spPr>
-          <a:xfrm>
-            <a:off x="6229350" y="1905000"/>
-            <a:ext cx="5429250" cy="2828925"/>
-          </a:xfrm>
-          <a:prstGeom prst="roundRect">
-            <a:avLst>
-              <a:gd name="adj" fmla="val 4040"/>
-            </a:avLst>
-          </a:prstGeom>
-          <a:solidFill>
-            <a:srgbClr val="F4F7FC"/>
-          </a:solidFill>
-        </p:spPr>
-        <p:txBody>
-          <a:bodyPr/>
-          <a:p/>
-        </p:txBody>
-      </p:sp>
-      <p:sp>
-        <p:nvSpPr>
-          <p:cNvPr id="213" name="文本框 212" descr="{&quot;isTemplate&quot;:true,&quot;type&quot;:&quot;text&quot;}"/>
-          <p:cNvSpPr txBox="1"/>
-          <p:nvPr/>
-        </p:nvSpPr>
-        <p:spPr>
-          <a:xfrm>
-            <a:off x="6457950" y="2133600"/>
-            <a:ext cx="4972050" cy="504825"/>
-          </a:xfrm>
-          <a:prstGeom prst="rect">
-            <a:avLst/>
-          </a:prstGeom>
-        </p:spPr>
-        <p:txBody>
-          <a:bodyPr wrap="square" lIns="0" tIns="0" rIns="0" bIns="0">
-            <a:normAutofit/>
-          </a:bodyPr>
-          <a:p>
-            <a:pPr>
-              <a:lnSpc>
-                <a:spcPct val="100000"/>
-              </a:lnSpc>
-            </a:pPr>
-            <a:r>
-              <a:rPr lang="en-US" sz="1650" b="1">
-                <a:solidFill>
-                  <a:srgbClr val="4472C4"/>
-                </a:solidFill>
-                <a:latin typeface="微软雅黑" panose="020B0503020204020204" charset="-122"/>
-                <a:ea typeface="微软雅黑" panose="020B0503020204020204" charset="-122"/>
-              </a:rPr>
-              <a:t>daily-commodity-price-scraper</a:t>
-            </a:r>
-            <a:r>
-              <a:rPr lang="zh-CN" sz="1650" b="1">
-                <a:solidFill>
-                  <a:srgbClr val="4472C4"/>
-                </a:solidFill>
-                <a:latin typeface="微软雅黑" panose="020B0503020204020204" charset="-122"/>
-                <a:ea typeface="微软雅黑" panose="020B0503020204020204" charset="-122"/>
-              </a:rPr>
-              <a:t>（价格爬取</a:t>
-            </a:r>
-            <a:r>
-              <a:rPr lang="en-US" sz="1650" b="1">
-                <a:solidFill>
-                  <a:srgbClr val="4472C4"/>
-                </a:solidFill>
-                <a:latin typeface="微软雅黑" panose="020B0503020204020204" charset="-122"/>
-                <a:ea typeface="微软雅黑" panose="020B0503020204020204" charset="-122"/>
-              </a:rPr>
-              <a:t> Skill</a:t>
-            </a:r>
-            <a:r>
-              <a:rPr lang="zh-CN" sz="1650" b="1">
-                <a:solidFill>
-                  <a:srgbClr val="4472C4"/>
-                </a:solidFill>
-                <a:latin typeface="微软雅黑" panose="020B0503020204020204" charset="-122"/>
-                <a:ea typeface="微软雅黑" panose="020B0503020204020204" charset="-122"/>
-              </a:rPr>
-              <a:t>）</a:t>
-            </a:r>
-            <a:endParaRPr lang="zh-CN" sz="1650" b="1">
-              <a:solidFill>
-                <a:srgbClr val="4472C4"/>
-              </a:solidFill>
-              <a:latin typeface="微软雅黑" panose="020B0503020204020204" charset="-122"/>
-              <a:ea typeface="微软雅黑" panose="020B0503020204020204" charset="-122"/>
-            </a:endParaRPr>
-          </a:p>
-        </p:txBody>
-      </p:sp>
-      <p:sp>
-        <p:nvSpPr>
-          <p:cNvPr id="214" name="文本框 213" descr="{&quot;isTemplate&quot;:true,&quot;type&quot;:&quot;text&quot;}"/>
-          <p:cNvSpPr txBox="1"/>
-          <p:nvPr/>
-        </p:nvSpPr>
-        <p:spPr>
-          <a:xfrm>
-            <a:off x="6457950" y="2752725"/>
-            <a:ext cx="4972050" cy="333375"/>
-          </a:xfrm>
-          <a:prstGeom prst="rect">
-            <a:avLst/>
-          </a:prstGeom>
-        </p:spPr>
-        <p:txBody>
-          <a:bodyPr wrap="none" lIns="0" tIns="0" rIns="0" bIns="0"/>
-          <a:p>
-            <a:pPr>
-              <a:lnSpc>
-                <a:spcPct val="170000"/>
-              </a:lnSpc>
-            </a:pPr>
-            <a:r>
-              <a:rPr lang="en-US" sz="1275">
-                <a:solidFill>
-                  <a:srgbClr val="1A1A1A"/>
-                </a:solidFill>
-                <a:latin typeface="微软雅黑" panose="020B0503020204020204" charset="-122"/>
-                <a:ea typeface="微软雅黑" panose="020B0503020204020204" charset="-122"/>
-              </a:rPr>
-              <a:t>· </a:t>
-            </a:r>
-            <a:r>
-              <a:rPr lang="zh-CN" sz="1275">
-                <a:solidFill>
-                  <a:srgbClr val="1A1A1A"/>
-                </a:solidFill>
-                <a:latin typeface="微软雅黑" panose="020B0503020204020204" charset="-122"/>
-                <a:ea typeface="微软雅黑" panose="020B0503020204020204" charset="-122"/>
-              </a:rPr>
-              <a:t>作为「钩子」培养采购部门自主制作</a:t>
-            </a:r>
-            <a:r>
-              <a:rPr lang="en-US" sz="1275">
-                <a:solidFill>
-                  <a:srgbClr val="1A1A1A"/>
-                </a:solidFill>
-                <a:latin typeface="微软雅黑" panose="020B0503020204020204" charset="-122"/>
-                <a:ea typeface="微软雅黑" panose="020B0503020204020204" charset="-122"/>
-              </a:rPr>
-              <a:t> Skill </a:t>
-            </a:r>
-            <a:r>
-              <a:rPr lang="zh-CN" sz="1275">
-                <a:solidFill>
-                  <a:srgbClr val="1A1A1A"/>
-                </a:solidFill>
-                <a:latin typeface="微软雅黑" panose="020B0503020204020204" charset="-122"/>
-                <a:ea typeface="微软雅黑" panose="020B0503020204020204" charset="-122"/>
-              </a:rPr>
-              <a:t>的能力</a:t>
-            </a:r>
-            <a:endParaRPr lang="zh-CN" sz="1275">
-              <a:solidFill>
-                <a:srgbClr val="1A1A1A"/>
-              </a:solidFill>
-              <a:latin typeface="微软雅黑" panose="020B0503020204020204" charset="-122"/>
-              <a:ea typeface="微软雅黑" panose="020B0503020204020204" charset="-122"/>
-            </a:endParaRPr>
-          </a:p>
-        </p:txBody>
-      </p:sp>
-      <p:sp>
-        <p:nvSpPr>
-          <p:cNvPr id="215" name="文本框 214" descr="{&quot;isTemplate&quot;:true,&quot;type&quot;:&quot;text&quot;}"/>
-          <p:cNvSpPr txBox="1"/>
-          <p:nvPr/>
-        </p:nvSpPr>
-        <p:spPr>
-          <a:xfrm>
-            <a:off x="6457950" y="3200400"/>
-            <a:ext cx="4972050" cy="333375"/>
-          </a:xfrm>
-          <a:prstGeom prst="rect">
-            <a:avLst/>
-          </a:prstGeom>
-        </p:spPr>
-        <p:txBody>
-          <a:bodyPr wrap="none" lIns="0" tIns="0" rIns="0" bIns="0"/>
-          <a:p>
-            <a:pPr>
-              <a:lnSpc>
-                <a:spcPct val="170000"/>
-              </a:lnSpc>
-            </a:pPr>
-            <a:r>
-              <a:rPr lang="en-US" sz="1275">
-                <a:solidFill>
-                  <a:srgbClr val="1A1A1A"/>
-                </a:solidFill>
-                <a:latin typeface="微软雅黑" panose="020B0503020204020204" charset="-122"/>
-                <a:ea typeface="微软雅黑" panose="020B0503020204020204" charset="-122"/>
-              </a:rPr>
-              <a:t>· </a:t>
-            </a:r>
-            <a:r>
-              <a:rPr lang="zh-CN" sz="1275">
-                <a:solidFill>
-                  <a:srgbClr val="1A1A1A"/>
-                </a:solidFill>
-                <a:latin typeface="微软雅黑" panose="020B0503020204020204" charset="-122"/>
-                <a:ea typeface="微软雅黑" panose="020B0503020204020204" charset="-122"/>
-              </a:rPr>
-              <a:t>后续仍回采购部门培训，巩固「自建</a:t>
-            </a:r>
-            <a:r>
-              <a:rPr lang="en-US" sz="1275">
-                <a:solidFill>
-                  <a:srgbClr val="1A1A1A"/>
-                </a:solidFill>
-                <a:latin typeface="微软雅黑" panose="020B0503020204020204" charset="-122"/>
-                <a:ea typeface="微软雅黑" panose="020B0503020204020204" charset="-122"/>
-              </a:rPr>
-              <a:t> Skill</a:t>
-            </a:r>
-            <a:r>
-              <a:rPr lang="zh-CN" sz="1275">
-                <a:solidFill>
-                  <a:srgbClr val="1A1A1A"/>
-                </a:solidFill>
-                <a:latin typeface="微软雅黑" panose="020B0503020204020204" charset="-122"/>
-                <a:ea typeface="微软雅黑" panose="020B0503020204020204" charset="-122"/>
-              </a:rPr>
-              <a:t>」能力</a:t>
-            </a:r>
-            <a:endParaRPr lang="zh-CN" sz="1275">
-              <a:solidFill>
-                <a:srgbClr val="1A1A1A"/>
-              </a:solidFill>
-              <a:latin typeface="微软雅黑" panose="020B0503020204020204" charset="-122"/>
-              <a:ea typeface="微软雅黑" panose="020B0503020204020204" charset="-122"/>
-            </a:endParaRPr>
-          </a:p>
-        </p:txBody>
-      </p:sp>
-      <p:sp>
-        <p:nvSpPr>
-          <p:cNvPr id="216" name="文本框 215" descr="{&quot;isTemplate&quot;:true,&quot;type&quot;:&quot;text&quot;}"/>
-          <p:cNvSpPr txBox="1"/>
-          <p:nvPr/>
-        </p:nvSpPr>
-        <p:spPr>
-          <a:xfrm>
-            <a:off x="6457950" y="3648075"/>
-            <a:ext cx="4972050" cy="333375"/>
-          </a:xfrm>
-          <a:prstGeom prst="rect">
-            <a:avLst/>
-          </a:prstGeom>
-        </p:spPr>
-        <p:txBody>
-          <a:bodyPr wrap="none" lIns="0" tIns="0" rIns="0" bIns="0"/>
-          <a:p>
-            <a:pPr>
-              <a:lnSpc>
-                <a:spcPct val="170000"/>
-              </a:lnSpc>
-            </a:pPr>
-            <a:r>
-              <a:rPr lang="en-US" sz="1275">
-                <a:solidFill>
-                  <a:srgbClr val="1A1A1A"/>
-                </a:solidFill>
-                <a:latin typeface="微软雅黑" panose="020B0503020204020204" charset="-122"/>
-                <a:ea typeface="微软雅黑" panose="020B0503020204020204" charset="-122"/>
-              </a:rPr>
-              <a:t>· </a:t>
-            </a:r>
-            <a:r>
-              <a:rPr lang="zh-CN" sz="1275">
-                <a:solidFill>
-                  <a:srgbClr val="1A1A1A"/>
-                </a:solidFill>
-                <a:latin typeface="微软雅黑" panose="020B0503020204020204" charset="-122"/>
-                <a:ea typeface="微软雅黑" panose="020B0503020204020204" charset="-122"/>
-              </a:rPr>
-              <a:t>体现理念：赋能业务自建，</a:t>
-            </a:r>
-            <a:r>
-              <a:rPr lang="en-US" sz="1275">
-                <a:solidFill>
-                  <a:srgbClr val="1A1A1A"/>
-                </a:solidFill>
-                <a:latin typeface="微软雅黑" panose="020B0503020204020204" charset="-122"/>
-                <a:ea typeface="微软雅黑" panose="020B0503020204020204" charset="-122"/>
-              </a:rPr>
-              <a:t>AI </a:t>
-            </a:r>
-            <a:r>
-              <a:rPr lang="zh-CN" sz="1275">
-                <a:solidFill>
-                  <a:srgbClr val="1A1A1A"/>
-                </a:solidFill>
-                <a:latin typeface="微软雅黑" panose="020B0503020204020204" charset="-122"/>
-                <a:ea typeface="微软雅黑" panose="020B0503020204020204" charset="-122"/>
-              </a:rPr>
-              <a:t>小组退后为把关角色</a:t>
-            </a:r>
-            <a:endParaRPr lang="zh-CN" sz="1275">
-              <a:solidFill>
-                <a:srgbClr val="1A1A1A"/>
-              </a:solidFill>
-              <a:latin typeface="微软雅黑" panose="020B0503020204020204" charset="-122"/>
-              <a:ea typeface="微软雅黑" panose="020B0503020204020204" charset="-122"/>
-            </a:endParaRPr>
-          </a:p>
-        </p:txBody>
-      </p:sp>
-      <p:sp>
-        <p:nvSpPr>
-          <p:cNvPr id="217" name="圆角矩形 216"/>
-          <p:cNvSpPr/>
-          <p:nvPr/>
-        </p:nvSpPr>
-        <p:spPr>
-          <a:xfrm>
-            <a:off x="6457950" y="4133850"/>
-            <a:ext cx="1800225" cy="285750"/>
-          </a:xfrm>
-          <a:prstGeom prst="roundRect">
-            <a:avLst>
-              <a:gd name="adj" fmla="val 20000"/>
-            </a:avLst>
-          </a:prstGeom>
-          <a:solidFill>
-            <a:srgbClr val="DAE3F3"/>
-          </a:solidFill>
-        </p:spPr>
-        <p:txBody>
-          <a:bodyPr/>
-          <a:p/>
-        </p:txBody>
-      </p:sp>
-      <p:sp>
-        <p:nvSpPr>
-          <p:cNvPr id="218" name="文本框 217" descr="{&quot;isTemplate&quot;:true,&quot;type&quot;:&quot;text&quot;}"/>
-          <p:cNvSpPr txBox="1"/>
-          <p:nvPr/>
-        </p:nvSpPr>
-        <p:spPr>
-          <a:xfrm>
-            <a:off x="6572250" y="4191000"/>
-            <a:ext cx="1571625" cy="171450"/>
-          </a:xfrm>
-          <a:prstGeom prst="rect">
-            <a:avLst/>
-          </a:prstGeom>
-        </p:spPr>
-        <p:txBody>
-          <a:bodyPr wrap="none" lIns="0" tIns="0" rIns="0" bIns="0"/>
-          <a:p>
-            <a:pPr>
-              <a:lnSpc>
-                <a:spcPct val="100000"/>
-              </a:lnSpc>
-            </a:pPr>
-            <a:r>
-              <a:rPr lang="zh-CN" sz="1125" b="1">
-                <a:solidFill>
-                  <a:srgbClr val="052B7C"/>
-                </a:solidFill>
-                <a:latin typeface="微软雅黑" panose="020B0503020204020204" charset="-122"/>
-                <a:ea typeface="微软雅黑" panose="020B0503020204020204" charset="-122"/>
-              </a:rPr>
-              <a:t>状态：赋能中（回培训）</a:t>
-            </a:r>
-            <a:endParaRPr lang="zh-CN" sz="1125" b="1">
-              <a:solidFill>
-                <a:srgbClr val="052B7C"/>
-              </a:solidFill>
-              <a:latin typeface="微软雅黑" panose="020B0503020204020204" charset="-122"/>
-              <a:ea typeface="微软雅黑" panose="020B0503020204020204" charset="-122"/>
-            </a:endParaRPr>
-          </a:p>
-        </p:txBody>
-      </p:sp>
-      <p:sp>
-        <p:nvSpPr>
-          <p:cNvPr id="219" name="文本框 218" descr="{&quot;isTemplate&quot;:true,&quot;type&quot;:&quot;text&quot;}"/>
-          <p:cNvSpPr txBox="1"/>
-          <p:nvPr/>
-        </p:nvSpPr>
-        <p:spPr>
-          <a:xfrm>
-            <a:off x="533400" y="6362700"/>
-            <a:ext cx="1285875" cy="161925"/>
-          </a:xfrm>
-          <a:prstGeom prst="rect">
-            <a:avLst/>
-          </a:prstGeom>
-        </p:spPr>
-        <p:txBody>
-          <a:bodyPr wrap="none" lIns="0" tIns="0" rIns="0" bIns="0"/>
-          <a:p>
-            <a:pPr>
-              <a:lnSpc>
-                <a:spcPct val="100000"/>
-              </a:lnSpc>
-            </a:pPr>
-            <a:r>
-              <a:rPr lang="zh-CN" sz="1050">
-                <a:solidFill>
-                  <a:srgbClr val="888888"/>
-                </a:solidFill>
-                <a:latin typeface="微软雅黑" panose="020B0503020204020204" charset="-122"/>
-                <a:ea typeface="微软雅黑" panose="020B0503020204020204" charset="-122"/>
-              </a:rPr>
-              <a:t>入职以来</a:t>
-            </a:r>
-            <a:r>
-              <a:rPr lang="en-US" sz="1050">
-                <a:solidFill>
-                  <a:srgbClr val="888888"/>
-                </a:solidFill>
-                <a:latin typeface="微软雅黑" panose="020B0503020204020204" charset="-122"/>
-                <a:ea typeface="微软雅黑" panose="020B0503020204020204" charset="-122"/>
-              </a:rPr>
-              <a:t> AI </a:t>
-            </a:r>
-            <a:r>
-              <a:rPr lang="zh-CN" sz="1050">
-                <a:solidFill>
-                  <a:srgbClr val="888888"/>
-                </a:solidFill>
-                <a:latin typeface="微软雅黑" panose="020B0503020204020204" charset="-122"/>
-                <a:ea typeface="微软雅黑" panose="020B0503020204020204" charset="-122"/>
-              </a:rPr>
-              <a:t>工作复盘</a:t>
-            </a:r>
-            <a:endParaRPr lang="zh-CN" sz="1050">
-              <a:solidFill>
-                <a:srgbClr val="888888"/>
-              </a:solidFill>
-              <a:latin typeface="微软雅黑" panose="020B0503020204020204" charset="-122"/>
-              <a:ea typeface="微软雅黑" panose="020B0503020204020204" charset="-122"/>
-            </a:endParaRPr>
-          </a:p>
-        </p:txBody>
-      </p:sp>
-      <p:sp>
-        <p:nvSpPr>
-          <p:cNvPr id="220" name="文本框 219" descr="{&quot;isTemplate&quot;:true,&quot;type&quot;:&quot;text&quot;}"/>
-          <p:cNvSpPr txBox="1"/>
-          <p:nvPr/>
-        </p:nvSpPr>
-        <p:spPr>
-          <a:xfrm>
-            <a:off x="11229975" y="6362700"/>
-            <a:ext cx="428625" cy="161925"/>
-          </a:xfrm>
-          <a:prstGeom prst="rect">
-            <a:avLst/>
-          </a:prstGeom>
-        </p:spPr>
-        <p:txBody>
-          <a:bodyPr wrap="none" lIns="0" tIns="0" rIns="0" bIns="0"/>
-          <a:p>
-            <a:pPr>
-              <a:lnSpc>
-                <a:spcPct val="100000"/>
-              </a:lnSpc>
-            </a:pPr>
-            <a:r>
-              <a:rPr lang="en-US" sz="1050">
-                <a:solidFill>
-                  <a:srgbClr val="888888"/>
-                </a:solidFill>
-                <a:latin typeface="微软雅黑" panose="020B0503020204020204" charset="-122"/>
-                <a:ea typeface="微软雅黑" panose="020B0503020204020204" charset="-122"/>
-              </a:rPr>
-              <a:t>08 / 13</a:t>
-            </a:r>
-            <a:endParaRPr lang="en-US" sz="1050">
-              <a:solidFill>
-                <a:srgbClr val="888888"/>
-              </a:solidFill>
-              <a:latin typeface="微软雅黑" panose="020B0503020204020204" charset="-122"/>
-              <a:ea typeface="微软雅黑" panose="020B0503020204020204" charset="-122"/>
-            </a:endParaRPr>
-          </a:p>
-        </p:txBody>
-      </p:sp>
-    </p:spTree>
-  </p:cSld>
-  <p:clrMapOvr>
-    <a:masterClrMapping/>
-  </p:clrMapOvr>
-</p:sld>
-</file>
-
-<file path=ppt/slides/slide6.xml><?xml version="1.0" encoding="utf-8"?>
-<p:sld xmlns:a="http://schemas.openxmlformats.org/drawingml/2006/main" xmlns:r="http://schemas.openxmlformats.org/officeDocument/2006/relationships" xmlns:p="http://schemas.openxmlformats.org/presentationml/2006/main">
-  <p:cSld>
-    <p:spTree>
-      <p:nvGrpSpPr>
         <p:cNvPr id="12" name="" descr="&lt;Slide style={{ width:'1280px', height:'720px', position:'relative', background:'#FFFFFF', fontFamily:'微软雅黑' }}&gt;&#10;  &lt;Box style={{ position:'absolute', left:56, top:36, flexDirection:'row', alignItems:'center', gap:12 }}&gt;&#10;    &lt;Box style={{ width:8, height:34, background:'#4472C4' }} /&gt;&#10;    &lt;Text style={{ fontSize:30, fontWeight:'bold', color:'#052B7C' }}&gt;五、宏昊AI助手 · 验收运营&lt;/Text&gt;&#10;  &lt;/Box&gt;&#10;&#10;  &lt;Box style={{ position:'absolute', left:56, top:130, right:56, flexDirection:'row', gap:22 }}&gt;&#10;    {[['37','平台验收项'],['19','问题反馈闭环'],['93.3%','6 月单月通过率']].map((c, i) =&gt; (&#10;      &lt;Box key={i} style={{ flex:1, background:'#F4F7FC', borderRadius:10, padding:'22px 18px', alignItems:'center' }}&gt;&#10;        &lt;Text style={{ fontSize:56, fontWeight:'bold', color:'#4472C4' }}&gt;{c[0]}&lt;/Text&gt;&#10;        &lt;Text style={{ fontSize:18, color:'#1A1A1A', marginTop:6 }}&gt;{c[1]}&lt;/Text&gt;&#10;      &lt;/Box&gt;&#10;    ))}&#10;  &lt;/Box&gt;&#10;&#10;  &lt;Box style={{ position:'absolute', left:56, top:300, right:56, background:'#052B7C', borderRadius:10, padding:'16px 22px' }}&gt;&#10;    &lt;Text style={{ fontSize:18, color:'#FFFFFF', lineHeight:1.5 }}&gt;入职以来 &lt;span style={{ fontWeight:'bold' }}&gt;37 项验收 + 19 项问题反馈闭环&lt;/span&gt;，6 月单月通过率 93.3% → 把「供应商交付」变「可度量、可追溯、有退回机制」的质量门槛。&lt;/Text&gt;&#10;  &lt;/Box&gt;&#10;&#10;  &lt;Box style={{ position:'absolute', left:56, top:400, right:56 }}&gt;&#10;    &lt;Table&#10;      style={{ width:'100%', height:230 }}&#10;      defaultTextStyle={{ fontSize:15, textAlign:'center', color:'#1A1A1A' }}&#10;      defaultCellStyle={{ border:{ left:{width:1,color:'#CCCCCC'}, right:{width:1,color:'#CCCCCC'}, top:{width:1,color:'#CCCCCC'}, bottom:{width:1,color:'#CCCCCC'} } }}&#10;      cells={[&#10;        [ {text:'周期', textStyle:{bold:true,color:'#1A1A1A'}, cellStyle:{background:{color:'#DAE3F3'}}},&#10;          {text:'验收产出', textStyle:{bold:true,color:'#1A1A1A'}, cellStyle:{background:{color:'#DAE3F3'}}},&#10;          {text:'问题反馈', textStyle:{bold:true,color:'#1A1A1A'}, cellStyle:{background:{color:'#DAE3F3'}}},&#10;          {text:'通过情况', textStyle:{bold:true,color:'#1A1A1A'}, cellStyle:{background:{color:'#DAE3F3'}}} ],&#10;        [ '4 月', '3 测试 + 2 验收（5 项）', '4', '—' ],&#10;        [ '5 月', '9 项测试验收', '3', '—' ],&#10;        [ '6 月', '15 用例（5 批次）', '8', {text:'14/15 通过（93.3%）', textStyle:{bold:true,color:'#4472C4'}} ],&#10;        [ '7 月（2607）', '5 轮验收（8 项）', '4', '—' ],&#10;      ]}&#10;    /&gt;&#10;  &lt;/Box&gt;&#10;&#10;  &lt;Box style={{ position:'absolute', left:56, top:668, right:56, flexDirection:'row', justifyContent:'space-between' }}&gt;&#10;    &lt;Text style={{ fontSize:14, color:'#888' }}&gt;入职以来 AI 工作复盘&lt;/Text&gt;&#10;    &lt;Text style={{ fontSize:14, color:'#888' }}&gt;10 / 13&lt;/Text&gt;&#10;  &lt;/Box&gt;&#10;&lt;/Slide&gt;"/>
         <p:cNvGrpSpPr/>
         <p:nvPr/>
@@ -5577,7 +4301,7 @@
                 <a:latin typeface="微软雅黑" panose="020B0503020204020204" charset="-122"/>
                 <a:ea typeface="微软雅黑" panose="020B0503020204020204" charset="-122"/>
               </a:rPr>
-              <a:t>四、宏昊</a:t>
+              <a:t>三、宏昊</a:t>
             </a:r>
             <a:r>
               <a:rPr lang="en-US" sz="2250" b="1">
@@ -7864,7 +6588,7 @@
 </p:sld>
 </file>
 
-<file path=ppt/slides/slide7.xml><?xml version="1.0" encoding="utf-8"?>
+<file path=ppt/slides/slide6.xml><?xml version="1.0" encoding="utf-8"?>
 <p:sld xmlns:a="http://schemas.openxmlformats.org/drawingml/2006/main" xmlns:r="http://schemas.openxmlformats.org/officeDocument/2006/relationships" xmlns:p="http://schemas.openxmlformats.org/presentationml/2006/main">
   <p:cSld>
     <p:spTree>
@@ -7958,7 +6682,7 @@
                 <a:latin typeface="微软雅黑" panose="020B0503020204020204" charset="-122"/>
                 <a:ea typeface="微软雅黑" panose="020B0503020204020204" charset="-122"/>
               </a:rPr>
-              <a:t>五、智能体矩阵与内容生成</a:t>
+              <a:t>三、智能体矩阵与内容生成</a:t>
             </a:r>
             <a:endParaRPr lang="zh-CN" sz="2250" b="1">
               <a:solidFill>
@@ -7977,7 +6701,7 @@
           <p:nvPr/>
         </p:nvGraphicFramePr>
         <p:xfrm>
-          <a:off x="533400" y="1143000"/>
+          <a:off x="533400" y="1308100"/>
           <a:ext cx="11125200" cy="4191000"/>
         </p:xfrm>
         <a:graphic>
@@ -8537,7 +7261,7 @@
                           <a:latin typeface="微软雅黑" panose="020B0503020204020204" charset="-122"/>
                           <a:ea typeface="微软雅黑" panose="020B0503020204020204" charset="-122"/>
                         </a:rPr>
-                        <a:t>TDS 咨询秒级应答、选型有据不误导客户</a:t>
+                        <a:t>TDS 咨询应答、选型有据不误导客户</a:t>
                       </a:r>
                       <a:endParaRPr sz="1125">
                         <a:solidFill>
@@ -8809,7 +7533,7 @@
                           <a:latin typeface="微软雅黑" panose="020B0503020204020204" charset="-122"/>
                           <a:ea typeface="微软雅黑" panose="020B0503020204020204" charset="-122"/>
                         </a:rPr>
-                        <a:t>销售动作标准化、话术统一、新人即上手</a:t>
+                        <a:t>销售动作标准、话术统一、新人即上手</a:t>
                       </a:r>
                       <a:endParaRPr sz="1125">
                         <a:solidFill>
@@ -8901,7 +7625,7 @@
                           <a:latin typeface="微软雅黑" panose="020B0503020204020204" charset="-122"/>
                           <a:ea typeface="微软雅黑" panose="020B0503020204020204" charset="-122"/>
                         </a:rPr>
-                        <a:t>营销中心 / 业务</a:t>
+                        <a:t>营销中心</a:t>
                       </a:r>
                       <a:endParaRPr sz="1125">
                         <a:solidFill>
@@ -8939,16 +7663,26 @@
                         </a:lnSpc>
                       </a:pPr>
                       <a:r>
-                        <a:rPr sz="1125">
-                          <a:solidFill>
-                            <a:srgbClr val="1A1A1A"/>
-                          </a:solidFill>
-                          <a:latin typeface="微软雅黑" panose="020B0503020204020204" charset="-122"/>
-                          <a:ea typeface="微软雅黑" panose="020B0503020204020204" charset="-122"/>
-                        </a:rPr>
-                        <a:t>SKILL.md + templates + role</a:t>
-                      </a:r>
-                      <a:endParaRPr sz="1125">
+                        <a:rPr lang="en-US" altLang="zh-CN" sz="1125">
+                          <a:solidFill>
+                            <a:srgbClr val="1A1A1A"/>
+                          </a:solidFill>
+                          <a:latin typeface="微软雅黑" panose="020B0503020204020204" charset="-122"/>
+                          <a:ea typeface="微软雅黑" panose="020B0503020204020204" charset="-122"/>
+                        </a:rPr>
+                        <a:t>TDS + SOP </a:t>
+                      </a:r>
+                      <a:r>
+                        <a:rPr lang="zh-CN" altLang="en-US" sz="1125">
+                          <a:solidFill>
+                            <a:srgbClr val="1A1A1A"/>
+                          </a:solidFill>
+                          <a:latin typeface="微软雅黑" panose="020B0503020204020204" charset="-122"/>
+                          <a:ea typeface="微软雅黑" panose="020B0503020204020204" charset="-122"/>
+                        </a:rPr>
+                        <a:t>源文件</a:t>
+                      </a:r>
+                      <a:endParaRPr lang="en-US" altLang="zh-CN" sz="1125">
                         <a:solidFill>
                           <a:srgbClr val="1A1A1A"/>
                         </a:solidFill>
@@ -9027,20 +7761,23 @@
                         <a:lnSpc>
                           <a:spcPct val="120000"/>
                         </a:lnSpc>
+                        <a:buClrTx/>
+                        <a:buSzTx/>
+                        <a:buFontTx/>
                       </a:pPr>
                       <a:r>
-                        <a:rPr sz="1125" b="1">
-                          <a:solidFill>
-                            <a:srgbClr val="C0504D"/>
-                          </a:solidFill>
-                          <a:latin typeface="微软雅黑" panose="020B0503020204020204" charset="-122"/>
-                          <a:ea typeface="微软雅黑" panose="020B0503020204020204" charset="-122"/>
-                        </a:rPr>
-                        <a:t>迭代中 v5</a:t>
-                      </a:r>
-                      <a:endParaRPr sz="1125" b="1">
+                        <a:rPr sz="1125">
+                          <a:solidFill>
+                            <a:srgbClr val="1A1A1A"/>
+                          </a:solidFill>
+                          <a:latin typeface="微软雅黑" panose="020B0503020204020204" charset="-122"/>
+                          <a:ea typeface="微软雅黑" panose="020B0503020204020204" charset="-122"/>
+                        </a:rPr>
+                        <a:t>已上线</a:t>
+                      </a:r>
+                      <a:endParaRPr sz="1125">
                         <a:solidFill>
-                          <a:srgbClr val="C0504D"/>
+                          <a:srgbClr val="1A1A1A"/>
                         </a:solidFill>
                         <a:latin typeface="微软雅黑" panose="020B0503020204020204" charset="-122"/>
                         <a:ea typeface="微软雅黑" panose="020B0503020204020204" charset="-122"/>
@@ -9081,7 +7818,7 @@
                           <a:latin typeface="微软雅黑" panose="020B0503020204020204" charset="-122"/>
                           <a:ea typeface="微软雅黑" panose="020B0503020204020204" charset="-122"/>
                         </a:rPr>
-                        <a:t>客户问题全流程 AI 化 + 合规红线校验</a:t>
+                        <a:t>客户问题 + 合规红线校验</a:t>
                       </a:r>
                       <a:endParaRPr sz="1125">
                         <a:solidFill>
@@ -9404,171 +8141,6 @@
           </a:graphicData>
         </a:graphic>
       </p:graphicFrame>
-      <p:sp>
-        <p:nvSpPr>
-          <p:cNvPr id="35" name="文本框 34" descr="{&quot;isTemplate&quot;:true,&quot;type&quot;:&quot;text&quot;}"/>
-          <p:cNvSpPr txBox="1"/>
-          <p:nvPr/>
-        </p:nvSpPr>
-        <p:spPr>
-          <a:xfrm>
-            <a:off x="533400" y="5410200"/>
-            <a:ext cx="11125200" cy="552450"/>
-          </a:xfrm>
-          <a:prstGeom prst="rect">
-            <a:avLst/>
-          </a:prstGeom>
-        </p:spPr>
-        <p:txBody>
-          <a:bodyPr wrap="square" lIns="0" tIns="0" rIns="0" bIns="0">
-            <a:normAutofit/>
-          </a:bodyPr>
-          <a:p>
-            <a:pPr>
-              <a:lnSpc>
-                <a:spcPct val="150000"/>
-              </a:lnSpc>
-            </a:pPr>
-            <a:r>
-              <a:rPr lang="zh-CN" sz="1200">
-                <a:solidFill>
-                  <a:srgbClr val="1A1A1A"/>
-                </a:solidFill>
-                <a:latin typeface="微软雅黑" panose="020B0503020204020204" charset="-122"/>
-                <a:ea typeface="微软雅黑" panose="020B0503020204020204" charset="-122"/>
-              </a:rPr>
-              <a:t>另有「培训助手」「视频</a:t>
-            </a:r>
-            <a:r>
-              <a:rPr lang="en-US" sz="1200">
-                <a:solidFill>
-                  <a:srgbClr val="1A1A1A"/>
-                </a:solidFill>
-                <a:latin typeface="微软雅黑" panose="020B0503020204020204" charset="-122"/>
-                <a:ea typeface="微软雅黑" panose="020B0503020204020204" charset="-122"/>
-              </a:rPr>
-              <a:t> / </a:t>
-            </a:r>
-            <a:r>
-              <a:rPr lang="zh-CN" sz="1200">
-                <a:solidFill>
-                  <a:srgbClr val="1A1A1A"/>
-                </a:solidFill>
-                <a:latin typeface="微软雅黑" panose="020B0503020204020204" charset="-122"/>
-                <a:ea typeface="微软雅黑" panose="020B0503020204020204" charset="-122"/>
-              </a:rPr>
-              <a:t>图片生成助手」等能力，构成平台智能体矩阵；</a:t>
-            </a:r>
-            <a:r>
-              <a:rPr lang="en-US" sz="1200">
-                <a:solidFill>
-                  <a:srgbClr val="1A1A1A"/>
-                </a:solidFill>
-                <a:latin typeface="微软雅黑" panose="020B0503020204020204" charset="-122"/>
-                <a:ea typeface="微软雅黑" panose="020B0503020204020204" charset="-122"/>
-              </a:rPr>
-              <a:t>06-12 </a:t>
-            </a:r>
-            <a:r>
-              <a:rPr lang="zh-CN" sz="1200">
-                <a:solidFill>
-                  <a:srgbClr val="1A1A1A"/>
-                </a:solidFill>
-                <a:latin typeface="微软雅黑" panose="020B0503020204020204" charset="-122"/>
-                <a:ea typeface="微软雅黑" panose="020B0503020204020204" charset="-122"/>
-              </a:rPr>
-              <a:t>提出</a:t>
-            </a:r>
-            <a:r>
-              <a:rPr lang="en-US" sz="1200">
-                <a:solidFill>
-                  <a:srgbClr val="1A1A1A"/>
-                </a:solidFill>
-                <a:latin typeface="微软雅黑" panose="020B0503020204020204" charset="-122"/>
-                <a:ea typeface="微软雅黑" panose="020B0503020204020204" charset="-122"/>
-              </a:rPr>
-              <a:t> seedance/seedream </a:t>
-            </a:r>
-            <a:r>
-              <a:rPr lang="zh-CN" sz="1200">
-                <a:solidFill>
-                  <a:srgbClr val="1A1A1A"/>
-                </a:solidFill>
-                <a:latin typeface="微软雅黑" panose="020B0503020204020204" charset="-122"/>
-                <a:ea typeface="微软雅黑" panose="020B0503020204020204" charset="-122"/>
-              </a:rPr>
-              <a:t>独立化诉求，</a:t>
-            </a:r>
-            <a:r>
-              <a:rPr lang="en-US" sz="1200">
-                <a:solidFill>
-                  <a:srgbClr val="1A1A1A"/>
-                </a:solidFill>
-                <a:latin typeface="微软雅黑" panose="020B0503020204020204" charset="-122"/>
-                <a:ea typeface="微软雅黑" panose="020B0503020204020204" charset="-122"/>
-              </a:rPr>
-              <a:t>07-14 </a:t>
-            </a:r>
-            <a:r>
-              <a:rPr lang="zh-CN" sz="1200">
-                <a:solidFill>
-                  <a:srgbClr val="1A1A1A"/>
-                </a:solidFill>
-                <a:latin typeface="微软雅黑" panose="020B0503020204020204" charset="-122"/>
-                <a:ea typeface="微软雅黑" panose="020B0503020204020204" charset="-122"/>
-              </a:rPr>
-              <a:t>图片</a:t>
-            </a:r>
-            <a:r>
-              <a:rPr lang="en-US" sz="1200">
-                <a:solidFill>
-                  <a:srgbClr val="1A1A1A"/>
-                </a:solidFill>
-                <a:latin typeface="微软雅黑" panose="020B0503020204020204" charset="-122"/>
-                <a:ea typeface="微软雅黑" panose="020B0503020204020204" charset="-122"/>
-              </a:rPr>
-              <a:t> · </a:t>
-            </a:r>
-            <a:r>
-              <a:rPr lang="zh-CN" sz="1200">
-                <a:solidFill>
-                  <a:srgbClr val="1A1A1A"/>
-                </a:solidFill>
-                <a:latin typeface="微软雅黑" panose="020B0503020204020204" charset="-122"/>
-                <a:ea typeface="微软雅黑" panose="020B0503020204020204" charset="-122"/>
-              </a:rPr>
-              <a:t>视频生成独立应用落地（营销</a:t>
-            </a:r>
-            <a:r>
-              <a:rPr lang="en-US" sz="1200">
-                <a:solidFill>
-                  <a:srgbClr val="1A1A1A"/>
-                </a:solidFill>
-                <a:latin typeface="微软雅黑" panose="020B0503020204020204" charset="-122"/>
-                <a:ea typeface="微软雅黑" panose="020B0503020204020204" charset="-122"/>
-              </a:rPr>
-              <a:t> / </a:t>
-            </a:r>
-            <a:r>
-              <a:rPr lang="zh-CN" sz="1200">
-                <a:solidFill>
-                  <a:srgbClr val="1A1A1A"/>
-                </a:solidFill>
-                <a:latin typeface="微软雅黑" panose="020B0503020204020204" charset="-122"/>
-                <a:ea typeface="微软雅黑" panose="020B0503020204020204" charset="-122"/>
-              </a:rPr>
-              <a:t>销售自助生产素材）。</a:t>
-            </a:r>
-            <a:endParaRPr lang="zh-CN" sz="1200">
-              <a:solidFill>
-                <a:srgbClr val="1A1A1A"/>
-              </a:solidFill>
-              <a:latin typeface="微软雅黑" panose="020B0503020204020204" charset="-122"/>
-              <a:ea typeface="微软雅黑" panose="020B0503020204020204" charset="-122"/>
-            </a:endParaRPr>
-          </a:p>
-        </p:txBody>
-      </p:sp>
       <p:sp>
         <p:nvSpPr>
           <p:cNvPr id="36" name="文本框 35" descr="{&quot;isTemplate&quot;:true,&quot;type&quot;:&quot;text&quot;}"/>
@@ -9683,7 +8255,7 @@
 </p:sld>
 </file>
 
-<file path=ppt/slides/slide8.xml><?xml version="1.0" encoding="utf-8"?>
+<file path=ppt/slides/slide7.xml><?xml version="1.0" encoding="utf-8"?>
 <p:sld xmlns:a="http://schemas.openxmlformats.org/drawingml/2006/main" xmlns:r="http://schemas.openxmlformats.org/officeDocument/2006/relationships" xmlns:p="http://schemas.openxmlformats.org/presentationml/2006/main">
   <p:cSld>
     <p:spTree>
@@ -9777,7 +8349,7 @@
                 <a:latin typeface="微软雅黑" panose="020B0503020204020204" charset="-122"/>
                 <a:ea typeface="微软雅黑" panose="020B0503020204020204" charset="-122"/>
               </a:rPr>
-              <a:t>六、下阶段计划与需支持事项</a:t>
+              <a:t>五、下阶段计划与需支持事项</a:t>
             </a:r>
             <a:endParaRPr lang="zh-CN" sz="2250" b="1">
               <a:solidFill>
@@ -9797,7 +8369,7 @@
         </p:nvSpPr>
         <p:spPr>
           <a:xfrm>
-            <a:off x="533400" y="1238250"/>
+            <a:off x="533400" y="1678940"/>
             <a:ext cx="6286500" cy="228600"/>
           </a:xfrm>
           <a:prstGeom prst="rect">
@@ -9813,7 +8385,7 @@
               </a:lnSpc>
             </a:pPr>
             <a:r>
-              <a:rPr lang="zh-CN" sz="1500" b="1">
+              <a:rPr lang="zh-CN" sz="1600" b="1">
                 <a:solidFill>
                   <a:srgbClr val="052B7C"/>
                 </a:solidFill>
@@ -9822,77 +8394,9 @@
               </a:rPr>
               <a:t>下阶段计划</a:t>
             </a:r>
-            <a:endParaRPr lang="zh-CN" sz="1500" b="1">
+            <a:endParaRPr lang="zh-CN" sz="1600" b="1">
               <a:solidFill>
                 <a:srgbClr val="052B7C"/>
-              </a:solidFill>
-              <a:latin typeface="微软雅黑" panose="020B0503020204020204" charset="-122"/>
-              <a:ea typeface="微软雅黑" panose="020B0503020204020204" charset="-122"/>
-            </a:endParaRPr>
-          </a:p>
-        </p:txBody>
-      </p:sp>
-      <p:sp>
-        <p:nvSpPr>
-          <p:cNvPr id="43" name="圆角矩形 42"/>
-          <p:cNvSpPr/>
-          <p:nvPr/>
-        </p:nvSpPr>
-        <p:spPr>
-          <a:xfrm>
-            <a:off x="533400" y="1676400"/>
-            <a:ext cx="76200" cy="76200"/>
-          </a:xfrm>
-          <a:prstGeom prst="roundRect">
-            <a:avLst>
-              <a:gd name="adj" fmla="val 25000"/>
-            </a:avLst>
-          </a:prstGeom>
-          <a:solidFill>
-            <a:srgbClr val="4472C4"/>
-          </a:solidFill>
-        </p:spPr>
-        <p:txBody>
-          <a:bodyPr/>
-          <a:p/>
-        </p:txBody>
-      </p:sp>
-      <p:sp>
-        <p:nvSpPr>
-          <p:cNvPr id="44" name="文本框 43" descr="{&quot;isTemplate&quot;:true,&quot;type&quot;:&quot;text&quot;}"/>
-          <p:cNvSpPr txBox="1"/>
-          <p:nvPr/>
-        </p:nvSpPr>
-        <p:spPr>
-          <a:xfrm>
-            <a:off x="723900" y="1600200"/>
-            <a:ext cx="4724400" cy="276225"/>
-          </a:xfrm>
-          <a:prstGeom prst="rect">
-            <a:avLst/>
-          </a:prstGeom>
-        </p:spPr>
-        <p:txBody>
-          <a:bodyPr wrap="none" lIns="0" tIns="0" rIns="0" bIns="0"/>
-          <a:p>
-            <a:pPr>
-              <a:lnSpc>
-                <a:spcPct val="150000"/>
-              </a:lnSpc>
-            </a:pPr>
-            <a:r>
-              <a:rPr lang="zh-CN" sz="1200">
-                <a:solidFill>
-                  <a:srgbClr val="1A1A1A"/>
-                </a:solidFill>
-                <a:latin typeface="微软雅黑" panose="020B0503020204020204" charset="-122"/>
-                <a:ea typeface="微软雅黑" panose="020B0503020204020204" charset="-122"/>
-              </a:rPr>
-              <a:t>业务智能助理上线前完成检索稳定性测试，沉淀为营销中心标准智能体</a:t>
-            </a:r>
-            <a:endParaRPr lang="zh-CN" sz="1200">
-              <a:solidFill>
-                <a:srgbClr val="1A1A1A"/>
               </a:solidFill>
               <a:latin typeface="微软雅黑" panose="020B0503020204020204" charset="-122"/>
               <a:ea typeface="微软雅黑" panose="020B0503020204020204" charset="-122"/>
@@ -9908,7 +8412,7 @@
         </p:nvSpPr>
         <p:spPr>
           <a:xfrm>
-            <a:off x="533400" y="2085975"/>
+            <a:off x="533400" y="2117090"/>
             <a:ext cx="76200" cy="76200"/>
           </a:xfrm>
           <a:prstGeom prst="roundRect">
@@ -9922,7 +8426,9 @@
         </p:spPr>
         <p:txBody>
           <a:bodyPr/>
-          <a:p/>
+          <a:p>
+            <a:endParaRPr sz="2000" b="1"/>
+          </a:p>
         </p:txBody>
       </p:sp>
       <p:sp>
@@ -9933,7 +8439,7 @@
         </p:nvSpPr>
         <p:spPr>
           <a:xfrm>
-            <a:off x="723900" y="2009775"/>
+            <a:off x="723900" y="2040890"/>
             <a:ext cx="3810000" cy="276225"/>
           </a:xfrm>
           <a:prstGeom prst="rect">
@@ -9949,7 +8455,7 @@
               </a:lnSpc>
             </a:pPr>
             <a:r>
-              <a:rPr lang="zh-CN" sz="1200">
+              <a:rPr lang="zh-CN" sz="1400" b="1">
                 <a:solidFill>
                   <a:srgbClr val="1A1A1A"/>
                 </a:solidFill>
@@ -9958,369 +8464,7 @@
               </a:rPr>
               <a:t>推动供应商修复待解项（图片变视频范围、竖屏不支持）</a:t>
             </a:r>
-            <a:endParaRPr lang="zh-CN" sz="1200">
-              <a:solidFill>
-                <a:srgbClr val="1A1A1A"/>
-              </a:solidFill>
-              <a:latin typeface="微软雅黑" panose="020B0503020204020204" charset="-122"/>
-              <a:ea typeface="微软雅黑" panose="020B0503020204020204" charset="-122"/>
-            </a:endParaRPr>
-          </a:p>
-        </p:txBody>
-      </p:sp>
-      <p:sp>
-        <p:nvSpPr>
-          <p:cNvPr id="47" name="圆角矩形 46"/>
-          <p:cNvSpPr/>
-          <p:nvPr/>
-        </p:nvSpPr>
-        <p:spPr>
-          <a:xfrm>
-            <a:off x="533400" y="2495550"/>
-            <a:ext cx="76200" cy="76200"/>
-          </a:xfrm>
-          <a:prstGeom prst="roundRect">
-            <a:avLst>
-              <a:gd name="adj" fmla="val 25000"/>
-            </a:avLst>
-          </a:prstGeom>
-          <a:solidFill>
-            <a:srgbClr val="4472C4"/>
-          </a:solidFill>
-        </p:spPr>
-        <p:txBody>
-          <a:bodyPr/>
-          <a:p/>
-        </p:txBody>
-      </p:sp>
-      <p:sp>
-        <p:nvSpPr>
-          <p:cNvPr id="48" name="文本框 47" descr="{&quot;isTemplate&quot;:true,&quot;type&quot;:&quot;text&quot;}"/>
-          <p:cNvSpPr txBox="1"/>
-          <p:nvPr/>
-        </p:nvSpPr>
-        <p:spPr>
-          <a:xfrm>
-            <a:off x="723900" y="2419350"/>
-            <a:ext cx="2295525" cy="276225"/>
-          </a:xfrm>
-          <a:prstGeom prst="rect">
-            <a:avLst/>
-          </a:prstGeom>
-        </p:spPr>
-        <p:txBody>
-          <a:bodyPr wrap="none" lIns="0" tIns="0" rIns="0" bIns="0"/>
-          <a:p>
-            <a:pPr>
-              <a:lnSpc>
-                <a:spcPct val="150000"/>
-              </a:lnSpc>
-            </a:pPr>
-            <a:r>
-              <a:rPr lang="zh-CN" sz="1200">
-                <a:solidFill>
-                  <a:srgbClr val="1A1A1A"/>
-                </a:solidFill>
-                <a:latin typeface="微软雅黑" panose="020B0503020204020204" charset="-122"/>
-                <a:ea typeface="微软雅黑" panose="020B0503020204020204" charset="-122"/>
-              </a:rPr>
-              <a:t>建立工具活跃度</a:t>
-            </a:r>
-            <a:r>
-              <a:rPr lang="en-US" sz="1200">
-                <a:solidFill>
-                  <a:srgbClr val="1A1A1A"/>
-                </a:solidFill>
-                <a:latin typeface="微软雅黑" panose="020B0503020204020204" charset="-122"/>
-                <a:ea typeface="微软雅黑" panose="020B0503020204020204" charset="-122"/>
-              </a:rPr>
-              <a:t> / </a:t>
-            </a:r>
-            <a:r>
-              <a:rPr lang="zh-CN" sz="1200">
-                <a:solidFill>
-                  <a:srgbClr val="1A1A1A"/>
-                </a:solidFill>
-                <a:latin typeface="微软雅黑" panose="020B0503020204020204" charset="-122"/>
-                <a:ea typeface="微软雅黑" panose="020B0503020204020204" charset="-122"/>
-              </a:rPr>
-              <a:t>采纳率轻量看板</a:t>
-            </a:r>
-            <a:endParaRPr lang="zh-CN" sz="1200">
-              <a:solidFill>
-                <a:srgbClr val="1A1A1A"/>
-              </a:solidFill>
-              <a:latin typeface="微软雅黑" panose="020B0503020204020204" charset="-122"/>
-              <a:ea typeface="微软雅黑" panose="020B0503020204020204" charset="-122"/>
-            </a:endParaRPr>
-          </a:p>
-        </p:txBody>
-      </p:sp>
-      <p:sp>
-        <p:nvSpPr>
-          <p:cNvPr id="49" name="圆角矩形 48"/>
-          <p:cNvSpPr/>
-          <p:nvPr/>
-        </p:nvSpPr>
-        <p:spPr>
-          <a:xfrm>
-            <a:off x="533400" y="2905125"/>
-            <a:ext cx="76200" cy="76200"/>
-          </a:xfrm>
-          <a:prstGeom prst="roundRect">
-            <a:avLst>
-              <a:gd name="adj" fmla="val 25000"/>
-            </a:avLst>
-          </a:prstGeom>
-          <a:solidFill>
-            <a:srgbClr val="4472C4"/>
-          </a:solidFill>
-        </p:spPr>
-        <p:txBody>
-          <a:bodyPr/>
-          <a:p/>
-        </p:txBody>
-      </p:sp>
-      <p:sp>
-        <p:nvSpPr>
-          <p:cNvPr id="50" name="文本框 49" descr="{&quot;isTemplate&quot;:true,&quot;type&quot;:&quot;text&quot;}"/>
-          <p:cNvSpPr txBox="1"/>
-          <p:nvPr/>
-        </p:nvSpPr>
-        <p:spPr>
-          <a:xfrm>
-            <a:off x="723900" y="2828925"/>
-            <a:ext cx="3667125" cy="276225"/>
-          </a:xfrm>
-          <a:prstGeom prst="rect">
-            <a:avLst/>
-          </a:prstGeom>
-        </p:spPr>
-        <p:txBody>
-          <a:bodyPr wrap="none" lIns="0" tIns="0" rIns="0" bIns="0"/>
-          <a:p>
-            <a:pPr>
-              <a:lnSpc>
-                <a:spcPct val="150000"/>
-              </a:lnSpc>
-            </a:pPr>
-            <a:r>
-              <a:rPr lang="zh-CN" sz="1200">
-                <a:solidFill>
-                  <a:srgbClr val="1A1A1A"/>
-                </a:solidFill>
-                <a:latin typeface="微软雅黑" panose="020B0503020204020204" charset="-122"/>
-                <a:ea typeface="微软雅黑" panose="020B0503020204020204" charset="-122"/>
-              </a:rPr>
-              <a:t>补采采购</a:t>
-            </a:r>
-            <a:r>
-              <a:rPr lang="en-US" sz="1200">
-                <a:solidFill>
-                  <a:srgbClr val="1A1A1A"/>
-                </a:solidFill>
-                <a:latin typeface="微软雅黑" panose="020B0503020204020204" charset="-122"/>
-                <a:ea typeface="微软雅黑" panose="020B0503020204020204" charset="-122"/>
-              </a:rPr>
-              <a:t> / </a:t>
-            </a:r>
-            <a:r>
-              <a:rPr lang="zh-CN" sz="1200">
-                <a:solidFill>
-                  <a:srgbClr val="1A1A1A"/>
-                </a:solidFill>
-                <a:latin typeface="微软雅黑" panose="020B0503020204020204" charset="-122"/>
-                <a:ea typeface="微软雅黑" panose="020B0503020204020204" charset="-122"/>
-              </a:rPr>
-              <a:t>船务「节省工时」量化，用于增量价值申报</a:t>
-            </a:r>
-            <a:endParaRPr lang="zh-CN" sz="1200">
-              <a:solidFill>
-                <a:srgbClr val="1A1A1A"/>
-              </a:solidFill>
-              <a:latin typeface="微软雅黑" panose="020B0503020204020204" charset="-122"/>
-              <a:ea typeface="微软雅黑" panose="020B0503020204020204" charset="-122"/>
-            </a:endParaRPr>
-          </a:p>
-        </p:txBody>
-      </p:sp>
-      <p:sp>
-        <p:nvSpPr>
-          <p:cNvPr id="51" name="圆角矩形 50"/>
-          <p:cNvSpPr/>
-          <p:nvPr/>
-        </p:nvSpPr>
-        <p:spPr>
-          <a:xfrm>
-            <a:off x="533400" y="3314700"/>
-            <a:ext cx="76200" cy="76200"/>
-          </a:xfrm>
-          <a:prstGeom prst="roundRect">
-            <a:avLst>
-              <a:gd name="adj" fmla="val 25000"/>
-            </a:avLst>
-          </a:prstGeom>
-          <a:solidFill>
-            <a:srgbClr val="4472C4"/>
-          </a:solidFill>
-        </p:spPr>
-        <p:txBody>
-          <a:bodyPr/>
-          <a:p/>
-        </p:txBody>
-      </p:sp>
-      <p:sp>
-        <p:nvSpPr>
-          <p:cNvPr id="52" name="文本框 51" descr="{&quot;isTemplate&quot;:true,&quot;type&quot;:&quot;text&quot;}"/>
-          <p:cNvSpPr txBox="1"/>
-          <p:nvPr/>
-        </p:nvSpPr>
-        <p:spPr>
-          <a:xfrm>
-            <a:off x="723900" y="3238500"/>
-            <a:ext cx="2762250" cy="276225"/>
-          </a:xfrm>
-          <a:prstGeom prst="rect">
-            <a:avLst/>
-          </a:prstGeom>
-        </p:spPr>
-        <p:txBody>
-          <a:bodyPr wrap="none" lIns="0" tIns="0" rIns="0" bIns="0"/>
-          <a:p>
-            <a:pPr>
-              <a:lnSpc>
-                <a:spcPct val="150000"/>
-              </a:lnSpc>
-            </a:pPr>
-            <a:r>
-              <a:rPr lang="en-US" sz="1200">
-                <a:solidFill>
-                  <a:srgbClr val="1A1A1A"/>
-                </a:solidFill>
-                <a:latin typeface="微软雅黑" panose="020B0503020204020204" charset="-122"/>
-                <a:ea typeface="微软雅黑" panose="020B0503020204020204" charset="-122"/>
-              </a:rPr>
-              <a:t>Tax_check / Data_masking </a:t>
-            </a:r>
-            <a:r>
-              <a:rPr lang="zh-CN" sz="1200">
-                <a:solidFill>
-                  <a:srgbClr val="1A1A1A"/>
-                </a:solidFill>
-                <a:latin typeface="微软雅黑" panose="020B0503020204020204" charset="-122"/>
-                <a:ea typeface="微软雅黑" panose="020B0503020204020204" charset="-122"/>
-              </a:rPr>
-              <a:t>持续运营深化</a:t>
-            </a:r>
-            <a:endParaRPr lang="zh-CN" sz="1200">
-              <a:solidFill>
-                <a:srgbClr val="1A1A1A"/>
-              </a:solidFill>
-              <a:latin typeface="微软雅黑" panose="020B0503020204020204" charset="-122"/>
-              <a:ea typeface="微软雅黑" panose="020B0503020204020204" charset="-122"/>
-            </a:endParaRPr>
-          </a:p>
-        </p:txBody>
-      </p:sp>
-      <p:sp>
-        <p:nvSpPr>
-          <p:cNvPr id="53" name="圆角矩形 52"/>
-          <p:cNvSpPr/>
-          <p:nvPr/>
-        </p:nvSpPr>
-        <p:spPr>
-          <a:xfrm>
-            <a:off x="533400" y="3724275"/>
-            <a:ext cx="76200" cy="76200"/>
-          </a:xfrm>
-          <a:prstGeom prst="roundRect">
-            <a:avLst>
-              <a:gd name="adj" fmla="val 25000"/>
-            </a:avLst>
-          </a:prstGeom>
-          <a:solidFill>
-            <a:srgbClr val="4472C4"/>
-          </a:solidFill>
-        </p:spPr>
-        <p:txBody>
-          <a:bodyPr/>
-          <a:p/>
-        </p:txBody>
-      </p:sp>
-      <p:sp>
-        <p:nvSpPr>
-          <p:cNvPr id="54" name="文本框 53" descr="{&quot;isTemplate&quot;:true,&quot;type&quot;:&quot;text&quot;}"/>
-          <p:cNvSpPr txBox="1"/>
-          <p:nvPr/>
-        </p:nvSpPr>
-        <p:spPr>
-          <a:xfrm>
-            <a:off x="723900" y="3648075"/>
-            <a:ext cx="3419475" cy="276225"/>
-          </a:xfrm>
-          <a:prstGeom prst="rect">
-            <a:avLst/>
-          </a:prstGeom>
-        </p:spPr>
-        <p:txBody>
-          <a:bodyPr wrap="none" lIns="0" tIns="0" rIns="0" bIns="0"/>
-          <a:p>
-            <a:pPr>
-              <a:lnSpc>
-                <a:spcPct val="150000"/>
-              </a:lnSpc>
-            </a:pPr>
-            <a:r>
-              <a:rPr lang="zh-CN" sz="1200">
-                <a:solidFill>
-                  <a:srgbClr val="1A1A1A"/>
-                </a:solidFill>
-                <a:latin typeface="微软雅黑" panose="020B0503020204020204" charset="-122"/>
-                <a:ea typeface="微软雅黑" panose="020B0503020204020204" charset="-122"/>
-              </a:rPr>
-              <a:t>价格爬取</a:t>
-            </a:r>
-            <a:r>
-              <a:rPr lang="en-US" sz="1200">
-                <a:solidFill>
-                  <a:srgbClr val="1A1A1A"/>
-                </a:solidFill>
-                <a:latin typeface="微软雅黑" panose="020B0503020204020204" charset="-122"/>
-                <a:ea typeface="微软雅黑" panose="020B0503020204020204" charset="-122"/>
-              </a:rPr>
-              <a:t> Skill </a:t>
-            </a:r>
-            <a:r>
-              <a:rPr lang="zh-CN" sz="1200">
-                <a:solidFill>
-                  <a:srgbClr val="1A1A1A"/>
-                </a:solidFill>
-                <a:latin typeface="微软雅黑" panose="020B0503020204020204" charset="-122"/>
-                <a:ea typeface="微软雅黑" panose="020B0503020204020204" charset="-122"/>
-              </a:rPr>
-              <a:t>回采购培训，巩固「自建</a:t>
-            </a:r>
-            <a:r>
-              <a:rPr lang="en-US" sz="1200">
-                <a:solidFill>
-                  <a:srgbClr val="1A1A1A"/>
-                </a:solidFill>
-                <a:latin typeface="微软雅黑" panose="020B0503020204020204" charset="-122"/>
-                <a:ea typeface="微软雅黑" panose="020B0503020204020204" charset="-122"/>
-              </a:rPr>
-              <a:t> Skill</a:t>
-            </a:r>
-            <a:r>
-              <a:rPr lang="zh-CN" sz="1200">
-                <a:solidFill>
-                  <a:srgbClr val="1A1A1A"/>
-                </a:solidFill>
-                <a:latin typeface="微软雅黑" panose="020B0503020204020204" charset="-122"/>
-                <a:ea typeface="微软雅黑" panose="020B0503020204020204" charset="-122"/>
-              </a:rPr>
-              <a:t>」能力</a:t>
-            </a:r>
-            <a:endParaRPr lang="zh-CN" sz="1200">
+            <a:endParaRPr lang="zh-CN" sz="1400" b="1">
               <a:solidFill>
                 <a:srgbClr val="1A1A1A"/>
               </a:solidFill>
@@ -10338,7 +8482,7 @@
         </p:nvSpPr>
         <p:spPr>
           <a:xfrm>
-            <a:off x="7162800" y="1238250"/>
+            <a:off x="6734175" y="1678940"/>
             <a:ext cx="4495800" cy="228600"/>
           </a:xfrm>
           <a:prstGeom prst="rect">
@@ -10354,7 +8498,7 @@
               </a:lnSpc>
             </a:pPr>
             <a:r>
-              <a:rPr lang="zh-CN" sz="1500" b="1">
+              <a:rPr lang="zh-CN" sz="1600" b="1">
                 <a:solidFill>
                   <a:srgbClr val="C0504D"/>
                 </a:solidFill>
@@ -10363,7 +8507,7 @@
               </a:rPr>
               <a:t>需支持事项</a:t>
             </a:r>
-            <a:endParaRPr lang="zh-CN" sz="1500" b="1">
+            <a:endParaRPr lang="zh-CN" sz="1600" b="1">
               <a:solidFill>
                 <a:srgbClr val="C0504D"/>
               </a:solidFill>
@@ -10381,7 +8525,7 @@
         </p:nvSpPr>
         <p:spPr>
           <a:xfrm>
-            <a:off x="7162800" y="1676400"/>
+            <a:off x="6734175" y="2117090"/>
             <a:ext cx="76200" cy="76200"/>
           </a:xfrm>
           <a:prstGeom prst="roundRect">
@@ -10395,7 +8539,9 @@
         </p:spPr>
         <p:txBody>
           <a:bodyPr/>
-          <a:p/>
+          <a:p>
+            <a:endParaRPr sz="2000" b="1"/>
+          </a:p>
         </p:txBody>
       </p:sp>
       <p:sp>
@@ -10406,7 +8552,7 @@
         </p:nvSpPr>
         <p:spPr>
           <a:xfrm>
-            <a:off x="7353300" y="1600200"/>
+            <a:off x="6924675" y="2040890"/>
             <a:ext cx="3810000" cy="276225"/>
           </a:xfrm>
           <a:prstGeom prst="rect">
@@ -10422,7 +8568,7 @@
               </a:lnSpc>
             </a:pPr>
             <a:r>
-              <a:rPr lang="zh-CN" sz="1200">
+              <a:rPr lang="zh-CN" sz="1400" b="1">
                 <a:solidFill>
                   <a:srgbClr val="1A1A1A"/>
                 </a:solidFill>
@@ -10431,7 +8577,7 @@
               </a:rPr>
               <a:t>业务智能助理检索测试需营销中心提供真实客户问题样本</a:t>
             </a:r>
-            <a:endParaRPr lang="zh-CN" sz="1200">
+            <a:endParaRPr lang="zh-CN" sz="1400" b="1">
               <a:solidFill>
                 <a:srgbClr val="1A1A1A"/>
               </a:solidFill>
@@ -10449,7 +8595,7 @@
         </p:nvSpPr>
         <p:spPr>
           <a:xfrm>
-            <a:off x="7162800" y="2085975"/>
+            <a:off x="6734175" y="2526665"/>
             <a:ext cx="76200" cy="76200"/>
           </a:xfrm>
           <a:prstGeom prst="roundRect">
@@ -10463,7 +8609,9 @@
         </p:spPr>
         <p:txBody>
           <a:bodyPr/>
-          <a:p/>
+          <a:p>
+            <a:endParaRPr sz="2000" b="1"/>
+          </a:p>
         </p:txBody>
       </p:sp>
       <p:sp>
@@ -10474,7 +8622,7 @@
         </p:nvSpPr>
         <p:spPr>
           <a:xfrm>
-            <a:off x="7353300" y="2009775"/>
+            <a:off x="6924675" y="2450465"/>
             <a:ext cx="3200400" cy="276225"/>
           </a:xfrm>
           <a:prstGeom prst="rect">
@@ -10490,7 +8638,7 @@
               </a:lnSpc>
             </a:pPr>
             <a:r>
-              <a:rPr lang="zh-CN" sz="1200">
+              <a:rPr lang="zh-CN" sz="1400" b="1">
                 <a:solidFill>
                   <a:srgbClr val="1A1A1A"/>
                 </a:solidFill>
@@ -10499,7 +8647,7 @@
               </a:rPr>
               <a:t>待解项修复依赖供应商排期，需领导推动优先级</a:t>
             </a:r>
-            <a:endParaRPr lang="zh-CN" sz="1200">
+            <a:endParaRPr lang="zh-CN" sz="1400" b="1">
               <a:solidFill>
                 <a:srgbClr val="1A1A1A"/>
               </a:solidFill>
@@ -10517,7 +8665,7 @@
         </p:nvSpPr>
         <p:spPr>
           <a:xfrm>
-            <a:off x="7162800" y="2495550"/>
+            <a:off x="6734175" y="2936240"/>
             <a:ext cx="76200" cy="76200"/>
           </a:xfrm>
           <a:prstGeom prst="roundRect">
@@ -10531,7 +8679,9 @@
         </p:spPr>
         <p:txBody>
           <a:bodyPr/>
-          <a:p/>
+          <a:p>
+            <a:endParaRPr sz="2000" b="1"/>
+          </a:p>
         </p:txBody>
       </p:sp>
       <p:sp>
@@ -10542,7 +8692,7 @@
         </p:nvSpPr>
         <p:spPr>
           <a:xfrm>
-            <a:off x="7353300" y="2419350"/>
+            <a:off x="6924675" y="2860040"/>
             <a:ext cx="2743200" cy="276225"/>
           </a:xfrm>
           <a:prstGeom prst="rect">
@@ -10558,7 +8708,7 @@
               </a:lnSpc>
             </a:pPr>
             <a:r>
-              <a:rPr lang="zh-CN" sz="1200">
+              <a:rPr lang="zh-CN" sz="1400" b="1">
                 <a:solidFill>
                   <a:srgbClr val="1A1A1A"/>
                 </a:solidFill>
@@ -10567,7 +8717,7 @@
               </a:rPr>
               <a:t>工时量化需业务方配合记录使用前后耗时</a:t>
             </a:r>
-            <a:endParaRPr lang="zh-CN" sz="1200">
+            <a:endParaRPr lang="zh-CN" sz="1400" b="1">
               <a:solidFill>
                 <a:srgbClr val="1A1A1A"/>
               </a:solidFill>
@@ -10585,7 +8735,7 @@
         </p:nvSpPr>
         <p:spPr>
           <a:xfrm>
-            <a:off x="7162800" y="2905125"/>
+            <a:off x="6734175" y="3345815"/>
             <a:ext cx="76200" cy="76200"/>
           </a:xfrm>
           <a:prstGeom prst="roundRect">
@@ -10599,7 +8749,9 @@
         </p:spPr>
         <p:txBody>
           <a:bodyPr/>
-          <a:p/>
+          <a:p>
+            <a:endParaRPr sz="2000" b="1"/>
+          </a:p>
         </p:txBody>
       </p:sp>
       <p:sp>
@@ -10610,7 +8762,7 @@
         </p:nvSpPr>
         <p:spPr>
           <a:xfrm>
-            <a:off x="7353300" y="2828925"/>
+            <a:off x="6924675" y="3269615"/>
             <a:ext cx="2333625" cy="276225"/>
           </a:xfrm>
           <a:prstGeom prst="rect">
@@ -10626,7 +8778,7 @@
               </a:lnSpc>
             </a:pPr>
             <a:r>
-              <a:rPr lang="zh-CN" sz="1200">
+              <a:rPr lang="zh-CN" sz="1400" b="1">
                 <a:solidFill>
                   <a:srgbClr val="1A1A1A"/>
                 </a:solidFill>
@@ -10636,7 +8788,7 @@
               <a:t>采纳率看板需</a:t>
             </a:r>
             <a:r>
-              <a:rPr lang="en-US" sz="1200">
+              <a:rPr lang="en-US" sz="1400" b="1">
                 <a:solidFill>
                   <a:srgbClr val="1A1A1A"/>
                 </a:solidFill>
@@ -10646,7 +8798,7 @@
               <a:t> IT / </a:t>
             </a:r>
             <a:r>
-              <a:rPr lang="zh-CN" sz="1200">
+              <a:rPr lang="zh-CN" sz="1400" b="1">
                 <a:solidFill>
                   <a:srgbClr val="1A1A1A"/>
                 </a:solidFill>
@@ -10655,7 +8807,7 @@
               </a:rPr>
               <a:t>数据侧轻量支持</a:t>
             </a:r>
-            <a:endParaRPr lang="zh-CN" sz="1200">
+            <a:endParaRPr lang="zh-CN" sz="1400" b="1">
               <a:solidFill>
                 <a:srgbClr val="1A1A1A"/>
               </a:solidFill>
@@ -10771,6 +8923,166 @@
           </a:p>
         </p:txBody>
       </p:sp>
+      <p:sp>
+        <p:nvSpPr>
+          <p:cNvPr id="1" name="圆角矩形 0"/>
+          <p:cNvSpPr/>
+          <p:nvPr/>
+        </p:nvSpPr>
+        <p:spPr>
+          <a:xfrm>
+            <a:off x="533400" y="2536190"/>
+            <a:ext cx="76200" cy="76200"/>
+          </a:xfrm>
+          <a:prstGeom prst="roundRect">
+            <a:avLst>
+              <a:gd name="adj" fmla="val 25000"/>
+            </a:avLst>
+          </a:prstGeom>
+          <a:solidFill>
+            <a:srgbClr val="4472C4"/>
+          </a:solidFill>
+        </p:spPr>
+        <p:txBody>
+          <a:bodyPr/>
+          <a:p>
+            <a:endParaRPr sz="2000" b="1"/>
+          </a:p>
+        </p:txBody>
+      </p:sp>
+      <p:sp>
+        <p:nvSpPr>
+          <p:cNvPr id="2" name="文本框 1" descr="{&quot;isTemplate&quot;:true,&quot;type&quot;:&quot;text&quot;}"/>
+          <p:cNvSpPr txBox="1"/>
+          <p:nvPr/>
+        </p:nvSpPr>
+        <p:spPr>
+          <a:xfrm>
+            <a:off x="723900" y="2459990"/>
+            <a:ext cx="2295525" cy="276225"/>
+          </a:xfrm>
+          <a:prstGeom prst="rect">
+            <a:avLst/>
+          </a:prstGeom>
+        </p:spPr>
+        <p:txBody>
+          <a:bodyPr wrap="none" lIns="0" tIns="0" rIns="0" bIns="0"/>
+          <a:p>
+            <a:pPr>
+              <a:lnSpc>
+                <a:spcPct val="150000"/>
+              </a:lnSpc>
+            </a:pPr>
+            <a:r>
+              <a:rPr lang="zh-CN" sz="1400" b="1">
+                <a:solidFill>
+                  <a:srgbClr val="1A1A1A"/>
+                </a:solidFill>
+                <a:latin typeface="微软雅黑" panose="020B0503020204020204" charset="-122"/>
+                <a:ea typeface="微软雅黑" panose="020B0503020204020204" charset="-122"/>
+              </a:rPr>
+              <a:t>培训助手迁移方案落地进度</a:t>
+            </a:r>
+            <a:r>
+              <a:rPr lang="zh-CN" sz="1400" b="1">
+                <a:solidFill>
+                  <a:srgbClr val="1A1A1A"/>
+                </a:solidFill>
+                <a:latin typeface="微软雅黑" panose="020B0503020204020204" charset="-122"/>
+                <a:ea typeface="微软雅黑" panose="020B0503020204020204" charset="-122"/>
+              </a:rPr>
+              <a:t>跟进</a:t>
+            </a:r>
+            <a:endParaRPr lang="zh-CN" sz="1400" b="1">
+              <a:solidFill>
+                <a:srgbClr val="1A1A1A"/>
+              </a:solidFill>
+              <a:latin typeface="微软雅黑" panose="020B0503020204020204" charset="-122"/>
+              <a:ea typeface="微软雅黑" panose="020B0503020204020204" charset="-122"/>
+            </a:endParaRPr>
+          </a:p>
+        </p:txBody>
+      </p:sp>
+      <p:sp>
+        <p:nvSpPr>
+          <p:cNvPr id="3" name="圆角矩形 2"/>
+          <p:cNvSpPr/>
+          <p:nvPr/>
+        </p:nvSpPr>
+        <p:spPr>
+          <a:xfrm>
+            <a:off x="533400" y="2945765"/>
+            <a:ext cx="76200" cy="76200"/>
+          </a:xfrm>
+          <a:prstGeom prst="roundRect">
+            <a:avLst>
+              <a:gd name="adj" fmla="val 25000"/>
+            </a:avLst>
+          </a:prstGeom>
+          <a:solidFill>
+            <a:srgbClr val="4472C4"/>
+          </a:solidFill>
+        </p:spPr>
+        <p:txBody>
+          <a:bodyPr/>
+          <a:p>
+            <a:endParaRPr sz="2000" b="1"/>
+          </a:p>
+        </p:txBody>
+      </p:sp>
+      <p:sp>
+        <p:nvSpPr>
+          <p:cNvPr id="4" name="文本框 3" descr="{&quot;isTemplate&quot;:true,&quot;type&quot;:&quot;text&quot;}"/>
+          <p:cNvSpPr txBox="1"/>
+          <p:nvPr/>
+        </p:nvSpPr>
+        <p:spPr>
+          <a:xfrm>
+            <a:off x="723900" y="2869565"/>
+            <a:ext cx="2295525" cy="276225"/>
+          </a:xfrm>
+          <a:prstGeom prst="rect">
+            <a:avLst/>
+          </a:prstGeom>
+        </p:spPr>
+        <p:txBody>
+          <a:bodyPr wrap="none" lIns="0" tIns="0" rIns="0" bIns="0"/>
+          <a:p>
+            <a:pPr>
+              <a:lnSpc>
+                <a:spcPct val="150000"/>
+              </a:lnSpc>
+            </a:pPr>
+            <a:r>
+              <a:rPr lang="zh-CN" sz="1400" b="1">
+                <a:solidFill>
+                  <a:srgbClr val="1A1A1A"/>
+                </a:solidFill>
+                <a:latin typeface="微软雅黑" panose="020B0503020204020204" charset="-122"/>
+                <a:ea typeface="微软雅黑" panose="020B0503020204020204" charset="-122"/>
+              </a:rPr>
+              <a:t>深入分析需求池内容，输出路径少、高价值的</a:t>
+            </a:r>
+            <a:r>
+              <a:rPr lang="en-US" altLang="zh-CN" sz="1400" b="1">
+                <a:solidFill>
+                  <a:srgbClr val="1A1A1A"/>
+                </a:solidFill>
+                <a:latin typeface="微软雅黑" panose="020B0503020204020204" charset="-122"/>
+                <a:ea typeface="微软雅黑" panose="020B0503020204020204" charset="-122"/>
+              </a:rPr>
+              <a:t>skill</a:t>
+            </a:r>
+            <a:endParaRPr lang="en-US" altLang="zh-CN" sz="1400" b="1">
+              <a:solidFill>
+                <a:srgbClr val="1A1A1A"/>
+              </a:solidFill>
+              <a:latin typeface="微软雅黑" panose="020B0503020204020204" charset="-122"/>
+              <a:ea typeface="微软雅黑" panose="020B0503020204020204" charset="-122"/>
+            </a:endParaRPr>
+          </a:p>
+        </p:txBody>
+      </p:sp>
     </p:spTree>
   </p:cSld>
   <p:clrMapOvr>
@@ -10779,7 +9091,7 @@
 </p:sld>
 </file>
 
-<file path=ppt/slides/slide9.xml><?xml version="1.0" encoding="utf-8"?>
+<file path=ppt/slides/slide8.xml><?xml version="1.0" encoding="utf-8"?>
 <p:sld xmlns:a="http://schemas.openxmlformats.org/drawingml/2006/main" xmlns:r="http://schemas.openxmlformats.org/officeDocument/2006/relationships" xmlns:p="http://schemas.openxmlformats.org/presentationml/2006/main">
   <p:cSld>
     <p:spTree>

</xml_diff>